<commit_message>
Add slide 16: 15 real-world use cases infographic
</commit_message>
<xml_diff>
--- a/docs/IoT-GPT-Research-Presentation.pptx
+++ b/docs/IoT-GPT-Research-Presentation.pptx
@@ -20,6 +20,7 @@
     <p:sldId id="268" r:id="rId19"/>
     <p:sldId id="269" r:id="rId20"/>
     <p:sldId id="270" r:id="rId21"/>
+    <p:sldId id="271" r:id="rId22"/>
   </p:sldIdLst>
   <p:sldSz cx="12188952" cy="6858000" type="screen4x3"/>
   <p:notesSz cx="6858000" cy="9144000"/>
@@ -8758,6 +8759,3516 @@
                 <a:latin typeface="Calibri"/>
               </a:rPr>
               <a:t>15 / 15</a:t>
+            </a:r>
+          </a:p>
+        </p:txBody>
+      </p:sp>
+    </p:spTree>
+  </p:cSld>
+  <p:clrMapOvr>
+    <a:masterClrMapping/>
+  </p:clrMapOvr>
+</p:sld>
+</file>
+
+<file path=ppt/slides/slide16.xml><?xml version="1.0" encoding="utf-8"?>
+<p:sld xmlns:a="http://schemas.openxmlformats.org/drawingml/2006/main" xmlns:p="http://schemas.openxmlformats.org/presentationml/2006/main" xmlns:r="http://schemas.openxmlformats.org/officeDocument/2006/relationships">
+  <p:cSld>
+    <p:bg>
+      <p:bgPr>
+        <a:solidFill>
+          <a:srgbClr val="0D3B3B"/>
+        </a:solidFill>
+        <a:effectLst/>
+      </p:bgPr>
+    </p:bg>
+    <p:spTree>
+      <p:nvGrpSpPr>
+        <p:cNvPr id="1" name=""/>
+        <p:cNvGrpSpPr/>
+        <p:nvPr/>
+      </p:nvGrpSpPr>
+      <p:grpSpPr/>
+      <p:sp>
+        <p:nvSpPr>
+          <p:cNvPr id="2" name="Oval 1"/>
+          <p:cNvSpPr/>
+          <p:nvPr/>
+        </p:nvSpPr>
+        <p:spPr>
+          <a:xfrm>
+            <a:off x="9600000" y="-700000"/>
+            <a:ext cx="4800000" cy="4800000"/>
+          </a:xfrm>
+          <a:prstGeom prst="ellipse">
+            <a:avLst/>
+          </a:prstGeom>
+          <a:solidFill>
+            <a:srgbClr val="1A6B6B"/>
+          </a:solidFill>
+          <a:ln>
+            <a:noFill/>
+          </a:ln>
+        </p:spPr>
+        <p:style>
+          <a:lnRef idx="1">
+            <a:schemeClr val="accent1"/>
+          </a:lnRef>
+          <a:fillRef idx="3">
+            <a:schemeClr val="accent1"/>
+          </a:fillRef>
+          <a:effectRef idx="2">
+            <a:schemeClr val="accent1"/>
+          </a:effectRef>
+          <a:fontRef idx="minor">
+            <a:schemeClr val="lt1"/>
+          </a:fontRef>
+        </p:style>
+        <p:txBody>
+          <a:bodyPr rtlCol="0" anchor="ctr"/>
+          <a:lstStyle/>
+          <a:p>
+            <a:pPr algn="ctr"/>
+          </a:p>
+        </p:txBody>
+      </p:sp>
+      <p:sp>
+        <p:nvSpPr>
+          <p:cNvPr id="3" name="Oval 2"/>
+          <p:cNvSpPr/>
+          <p:nvPr/>
+        </p:nvSpPr>
+        <p:spPr>
+          <a:xfrm>
+            <a:off x="10400000" y="2500000"/>
+            <a:ext cx="3000000" cy="3000000"/>
+          </a:xfrm>
+          <a:prstGeom prst="ellipse">
+            <a:avLst/>
+          </a:prstGeom>
+          <a:solidFill>
+            <a:srgbClr val="0A4545"/>
+          </a:solidFill>
+          <a:ln>
+            <a:noFill/>
+          </a:ln>
+        </p:spPr>
+        <p:style>
+          <a:lnRef idx="1">
+            <a:schemeClr val="accent1"/>
+          </a:lnRef>
+          <a:fillRef idx="3">
+            <a:schemeClr val="accent1"/>
+          </a:fillRef>
+          <a:effectRef idx="2">
+            <a:schemeClr val="accent1"/>
+          </a:effectRef>
+          <a:fontRef idx="minor">
+            <a:schemeClr val="lt1"/>
+          </a:fontRef>
+        </p:style>
+        <p:txBody>
+          <a:bodyPr rtlCol="0" anchor="ctr"/>
+          <a:lstStyle/>
+          <a:p>
+            <a:pPr algn="ctr"/>
+          </a:p>
+        </p:txBody>
+      </p:sp>
+      <p:sp>
+        <p:nvSpPr>
+          <p:cNvPr id="4" name="Rectangle 3"/>
+          <p:cNvSpPr/>
+          <p:nvPr/>
+        </p:nvSpPr>
+        <p:spPr>
+          <a:xfrm>
+            <a:off x="182880" y="150000"/>
+            <a:ext cx="60000" cy="380000"/>
+          </a:xfrm>
+          <a:prstGeom prst="rect">
+            <a:avLst/>
+          </a:prstGeom>
+          <a:solidFill>
+            <a:srgbClr val="F4A261"/>
+          </a:solidFill>
+          <a:ln>
+            <a:noFill/>
+          </a:ln>
+        </p:spPr>
+        <p:style>
+          <a:lnRef idx="1">
+            <a:schemeClr val="accent1"/>
+          </a:lnRef>
+          <a:fillRef idx="3">
+            <a:schemeClr val="accent1"/>
+          </a:fillRef>
+          <a:effectRef idx="2">
+            <a:schemeClr val="accent1"/>
+          </a:effectRef>
+          <a:fontRef idx="minor">
+            <a:schemeClr val="lt1"/>
+          </a:fontRef>
+        </p:style>
+        <p:txBody>
+          <a:bodyPr rtlCol="0" anchor="ctr"/>
+          <a:lstStyle/>
+          <a:p>
+            <a:pPr algn="ctr"/>
+          </a:p>
+        </p:txBody>
+      </p:sp>
+      <p:sp>
+        <p:nvSpPr>
+          <p:cNvPr id="5" name="TextBox 4"/>
+          <p:cNvSpPr txBox="1"/>
+          <p:nvPr/>
+        </p:nvSpPr>
+        <p:spPr>
+          <a:xfrm>
+            <a:off x="274320" y="100000"/>
+            <a:ext cx="11423192" cy="500000"/>
+          </a:xfrm>
+          <a:prstGeom prst="rect">
+            <a:avLst/>
+          </a:prstGeom>
+          <a:noFill/>
+        </p:spPr>
+        <p:txBody>
+          <a:bodyPr wrap="square" anchor="ctr">
+            <a:spAutoFit/>
+          </a:bodyPr>
+          <a:lstStyle/>
+          <a:p>
+            <a:pPr algn="l"/>
+            <a:r>
+              <a:rPr sz="2600" b="1">
+                <a:solidFill>
+                  <a:srgbClr val="F4A261"/>
+                </a:solidFill>
+                <a:latin typeface="Calibri"/>
+              </a:rPr>
+              <a:t>15 Real-World Use Cases  |  IoT-GPT Research</a:t>
+            </a:r>
+          </a:p>
+        </p:txBody>
+      </p:sp>
+      <p:sp>
+        <p:nvSpPr>
+          <p:cNvPr id="6" name="TextBox 5"/>
+          <p:cNvSpPr txBox="1"/>
+          <p:nvPr/>
+        </p:nvSpPr>
+        <p:spPr>
+          <a:xfrm>
+            <a:off x="11488952" y="6508000"/>
+            <a:ext cx="600000" cy="250000"/>
+          </a:xfrm>
+          <a:prstGeom prst="rect">
+            <a:avLst/>
+          </a:prstGeom>
+          <a:noFill/>
+        </p:spPr>
+        <p:txBody>
+          <a:bodyPr wrap="square" anchor="ctr">
+            <a:spAutoFit/>
+          </a:bodyPr>
+          <a:lstStyle/>
+          <a:p>
+            <a:pPr algn="r"/>
+            <a:r>
+              <a:rPr sz="1100" b="0">
+                <a:solidFill>
+                  <a:srgbClr val="80C0C0"/>
+                </a:solidFill>
+                <a:latin typeface="Calibri"/>
+              </a:rPr>
+              <a:t>16 / 16</a:t>
+            </a:r>
+          </a:p>
+        </p:txBody>
+      </p:sp>
+      <p:sp>
+        <p:nvSpPr>
+          <p:cNvPr id="7" name="Rectangle 6"/>
+          <p:cNvSpPr/>
+          <p:nvPr/>
+        </p:nvSpPr>
+        <p:spPr>
+          <a:xfrm>
+            <a:off x="182880" y="685800"/>
+            <a:ext cx="2291486" cy="1945640"/>
+          </a:xfrm>
+          <a:prstGeom prst="roundRect">
+            <a:avLst>
+              <a:gd name="adj" fmla="val 30000"/>
+            </a:avLst>
+          </a:prstGeom>
+          <a:solidFill>
+            <a:srgbClr val="0A4A4A"/>
+          </a:solidFill>
+          <a:ln w="9144">
+            <a:solidFill>
+              <a:srgbClr val="1A6B6B"/>
+            </a:solidFill>
+          </a:ln>
+        </p:spPr>
+        <p:style>
+          <a:lnRef idx="1">
+            <a:schemeClr val="accent1"/>
+          </a:lnRef>
+          <a:fillRef idx="3">
+            <a:schemeClr val="accent1"/>
+          </a:fillRef>
+          <a:effectRef idx="2">
+            <a:schemeClr val="accent1"/>
+          </a:effectRef>
+          <a:fontRef idx="minor">
+            <a:schemeClr val="lt1"/>
+          </a:fontRef>
+        </p:style>
+        <p:txBody>
+          <a:bodyPr rtlCol="0" anchor="ctr"/>
+          <a:lstStyle/>
+          <a:p>
+            <a:pPr algn="ctr"/>
+          </a:p>
+        </p:txBody>
+      </p:sp>
+      <p:sp>
+        <p:nvSpPr>
+          <p:cNvPr id="8" name="Oval 7"/>
+          <p:cNvSpPr/>
+          <p:nvPr/>
+        </p:nvSpPr>
+        <p:spPr>
+          <a:xfrm>
+            <a:off x="1176223" y="762000"/>
+            <a:ext cx="304800" cy="304800"/>
+          </a:xfrm>
+          <a:prstGeom prst="ellipse">
+            <a:avLst/>
+          </a:prstGeom>
+          <a:solidFill>
+            <a:srgbClr val="F4A261"/>
+          </a:solidFill>
+          <a:ln>
+            <a:noFill/>
+          </a:ln>
+        </p:spPr>
+        <p:style>
+          <a:lnRef idx="1">
+            <a:schemeClr val="accent1"/>
+          </a:lnRef>
+          <a:fillRef idx="3">
+            <a:schemeClr val="accent1"/>
+          </a:fillRef>
+          <a:effectRef idx="2">
+            <a:schemeClr val="accent1"/>
+          </a:effectRef>
+          <a:fontRef idx="minor">
+            <a:schemeClr val="lt1"/>
+          </a:fontRef>
+        </p:style>
+        <p:txBody>
+          <a:bodyPr rtlCol="0" anchor="ctr"/>
+          <a:lstStyle/>
+          <a:p>
+            <a:pPr algn="ctr"/>
+          </a:p>
+        </p:txBody>
+      </p:sp>
+      <p:sp>
+        <p:nvSpPr>
+          <p:cNvPr id="9" name="TextBox 8"/>
+          <p:cNvSpPr txBox="1"/>
+          <p:nvPr/>
+        </p:nvSpPr>
+        <p:spPr>
+          <a:xfrm>
+            <a:off x="1176223" y="762000"/>
+            <a:ext cx="304800" cy="304800"/>
+          </a:xfrm>
+          <a:prstGeom prst="rect">
+            <a:avLst/>
+          </a:prstGeom>
+          <a:noFill/>
+        </p:spPr>
+        <p:txBody>
+          <a:bodyPr wrap="square" anchor="ctr">
+            <a:spAutoFit/>
+          </a:bodyPr>
+          <a:lstStyle/>
+          <a:p>
+            <a:pPr algn="ctr"/>
+            <a:r>
+              <a:rPr sz="1800" b="0">
+                <a:solidFill>
+                  <a:srgbClr val="FFFFFF"/>
+                </a:solidFill>
+                <a:latin typeface="Calibri"/>
+              </a:rPr>
+              <a:t>❄</a:t>
+            </a:r>
+          </a:p>
+        </p:txBody>
+      </p:sp>
+      <p:sp>
+        <p:nvSpPr>
+          <p:cNvPr id="10" name="TextBox 9"/>
+          <p:cNvSpPr txBox="1"/>
+          <p:nvPr/>
+        </p:nvSpPr>
+        <p:spPr>
+          <a:xfrm>
+            <a:off x="243840" y="1126800"/>
+            <a:ext cx="2169566" cy="230000"/>
+          </a:xfrm>
+          <a:prstGeom prst="rect">
+            <a:avLst/>
+          </a:prstGeom>
+          <a:noFill/>
+        </p:spPr>
+        <p:txBody>
+          <a:bodyPr wrap="square" anchor="ctr">
+            <a:spAutoFit/>
+          </a:bodyPr>
+          <a:lstStyle/>
+          <a:p>
+            <a:pPr algn="ctr"/>
+            <a:r>
+              <a:rPr sz="1100" b="1">
+                <a:solidFill>
+                  <a:srgbClr val="FFFFFF"/>
+                </a:solidFill>
+                <a:latin typeface="Calibri"/>
+              </a:rPr>
+              <a:t>Snow Alert</a:t>
+            </a:r>
+          </a:p>
+        </p:txBody>
+      </p:sp>
+      <p:sp>
+        <p:nvSpPr>
+          <p:cNvPr id="11" name="TextBox 10"/>
+          <p:cNvSpPr txBox="1"/>
+          <p:nvPr/>
+        </p:nvSpPr>
+        <p:spPr>
+          <a:xfrm>
+            <a:off x="243840" y="1356800"/>
+            <a:ext cx="2169566" cy="1213680"/>
+          </a:xfrm>
+          <a:prstGeom prst="rect">
+            <a:avLst/>
+          </a:prstGeom>
+          <a:noFill/>
+        </p:spPr>
+        <p:txBody>
+          <a:bodyPr wrap="square" anchor="ctr">
+            <a:spAutoFit/>
+          </a:bodyPr>
+          <a:lstStyle/>
+          <a:p>
+            <a:pPr algn="ctr"/>
+            <a:r>
+              <a:rPr sz="900" b="0">
+                <a:solidFill>
+                  <a:srgbClr val="CCEEEE"/>
+                </a:solidFill>
+                <a:latin typeface="Calibri"/>
+              </a:rPr>
+              <a:t>Shoe-rack bulb glows</a:t>
+            </a:r>
+          </a:p>
+          <a:p>
+            <a:pPr algn="ctr"/>
+            <a:r>
+              <a:rPr sz="900" b="0">
+                <a:solidFill>
+                  <a:srgbClr val="CCEEEE"/>
+                </a:solidFill>
+                <a:latin typeface="Calibri"/>
+              </a:rPr>
+              <a:t>blue when snow</a:t>
+            </a:r>
+          </a:p>
+          <a:p>
+            <a:pPr algn="ctr"/>
+            <a:r>
+              <a:rPr sz="900" b="0">
+                <a:solidFill>
+                  <a:srgbClr val="CCEEEE"/>
+                </a:solidFill>
+                <a:latin typeface="Calibri"/>
+              </a:rPr>
+              <a:t>is forecast tonight</a:t>
+            </a:r>
+          </a:p>
+        </p:txBody>
+      </p:sp>
+      <p:sp>
+        <p:nvSpPr>
+          <p:cNvPr id="12" name="Rectangle 11"/>
+          <p:cNvSpPr/>
+          <p:nvPr/>
+        </p:nvSpPr>
+        <p:spPr>
+          <a:xfrm>
+            <a:off x="2565806" y="685800"/>
+            <a:ext cx="2291486" cy="1945640"/>
+          </a:xfrm>
+          <a:prstGeom prst="roundRect">
+            <a:avLst>
+              <a:gd name="adj" fmla="val 30000"/>
+            </a:avLst>
+          </a:prstGeom>
+          <a:solidFill>
+            <a:srgbClr val="0A4A4A"/>
+          </a:solidFill>
+          <a:ln w="9144">
+            <a:solidFill>
+              <a:srgbClr val="1A6B6B"/>
+            </a:solidFill>
+          </a:ln>
+        </p:spPr>
+        <p:style>
+          <a:lnRef idx="1">
+            <a:schemeClr val="accent1"/>
+          </a:lnRef>
+          <a:fillRef idx="3">
+            <a:schemeClr val="accent1"/>
+          </a:fillRef>
+          <a:effectRef idx="2">
+            <a:schemeClr val="accent1"/>
+          </a:effectRef>
+          <a:fontRef idx="minor">
+            <a:schemeClr val="lt1"/>
+          </a:fontRef>
+        </p:style>
+        <p:txBody>
+          <a:bodyPr rtlCol="0" anchor="ctr"/>
+          <a:lstStyle/>
+          <a:p>
+            <a:pPr algn="ctr"/>
+          </a:p>
+        </p:txBody>
+      </p:sp>
+      <p:sp>
+        <p:nvSpPr>
+          <p:cNvPr id="13" name="Oval 12"/>
+          <p:cNvSpPr/>
+          <p:nvPr/>
+        </p:nvSpPr>
+        <p:spPr>
+          <a:xfrm>
+            <a:off x="3559149" y="762000"/>
+            <a:ext cx="304800" cy="304800"/>
+          </a:xfrm>
+          <a:prstGeom prst="ellipse">
+            <a:avLst/>
+          </a:prstGeom>
+          <a:solidFill>
+            <a:srgbClr val="F4A261"/>
+          </a:solidFill>
+          <a:ln>
+            <a:noFill/>
+          </a:ln>
+        </p:spPr>
+        <p:style>
+          <a:lnRef idx="1">
+            <a:schemeClr val="accent1"/>
+          </a:lnRef>
+          <a:fillRef idx="3">
+            <a:schemeClr val="accent1"/>
+          </a:fillRef>
+          <a:effectRef idx="2">
+            <a:schemeClr val="accent1"/>
+          </a:effectRef>
+          <a:fontRef idx="minor">
+            <a:schemeClr val="lt1"/>
+          </a:fontRef>
+        </p:style>
+        <p:txBody>
+          <a:bodyPr rtlCol="0" anchor="ctr"/>
+          <a:lstStyle/>
+          <a:p>
+            <a:pPr algn="ctr"/>
+          </a:p>
+        </p:txBody>
+      </p:sp>
+      <p:sp>
+        <p:nvSpPr>
+          <p:cNvPr id="14" name="TextBox 13"/>
+          <p:cNvSpPr txBox="1"/>
+          <p:nvPr/>
+        </p:nvSpPr>
+        <p:spPr>
+          <a:xfrm>
+            <a:off x="3559149" y="762000"/>
+            <a:ext cx="304800" cy="304800"/>
+          </a:xfrm>
+          <a:prstGeom prst="rect">
+            <a:avLst/>
+          </a:prstGeom>
+          <a:noFill/>
+        </p:spPr>
+        <p:txBody>
+          <a:bodyPr wrap="square" anchor="ctr">
+            <a:spAutoFit/>
+          </a:bodyPr>
+          <a:lstStyle/>
+          <a:p>
+            <a:pPr algn="ctr"/>
+            <a:r>
+              <a:rPr sz="1800" b="0">
+                <a:solidFill>
+                  <a:srgbClr val="FFFFFF"/>
+                </a:solidFill>
+                <a:latin typeface="Calibri"/>
+              </a:rPr>
+              <a:t>⚡</a:t>
+            </a:r>
+          </a:p>
+        </p:txBody>
+      </p:sp>
+      <p:sp>
+        <p:nvSpPr>
+          <p:cNvPr id="15" name="TextBox 14"/>
+          <p:cNvSpPr txBox="1"/>
+          <p:nvPr/>
+        </p:nvSpPr>
+        <p:spPr>
+          <a:xfrm>
+            <a:off x="2626766" y="1126800"/>
+            <a:ext cx="2169566" cy="230000"/>
+          </a:xfrm>
+          <a:prstGeom prst="rect">
+            <a:avLst/>
+          </a:prstGeom>
+          <a:noFill/>
+        </p:spPr>
+        <p:txBody>
+          <a:bodyPr wrap="square" anchor="ctr">
+            <a:spAutoFit/>
+          </a:bodyPr>
+          <a:lstStyle/>
+          <a:p>
+            <a:pPr algn="ctr"/>
+            <a:r>
+              <a:rPr sz="1100" b="1">
+                <a:solidFill>
+                  <a:srgbClr val="FFFFFF"/>
+                </a:solidFill>
+                <a:latin typeface="Calibri"/>
+              </a:rPr>
+              <a:t>Load Staggering</a:t>
+            </a:r>
+          </a:p>
+        </p:txBody>
+      </p:sp>
+      <p:sp>
+        <p:nvSpPr>
+          <p:cNvPr id="16" name="TextBox 15"/>
+          <p:cNvSpPr txBox="1"/>
+          <p:nvPr/>
+        </p:nvSpPr>
+        <p:spPr>
+          <a:xfrm>
+            <a:off x="2626766" y="1356800"/>
+            <a:ext cx="2169566" cy="1213680"/>
+          </a:xfrm>
+          <a:prstGeom prst="rect">
+            <a:avLst/>
+          </a:prstGeom>
+          <a:noFill/>
+        </p:spPr>
+        <p:txBody>
+          <a:bodyPr wrap="square" anchor="ctr">
+            <a:spAutoFit/>
+          </a:bodyPr>
+          <a:lstStyle/>
+          <a:p>
+            <a:pPr algn="ctr"/>
+            <a:r>
+              <a:rPr sz="900" b="0">
+                <a:solidFill>
+                  <a:srgbClr val="CCEEEE"/>
+                </a:solidFill>
+                <a:latin typeface="Calibri"/>
+              </a:rPr>
+              <a:t>Stops room heater +</a:t>
+            </a:r>
+          </a:p>
+          <a:p>
+            <a:pPr algn="ctr"/>
+            <a:r>
+              <a:rPr sz="900" b="0">
+                <a:solidFill>
+                  <a:srgbClr val="CCEEEE"/>
+                </a:solidFill>
+                <a:latin typeface="Calibri"/>
+              </a:rPr>
+              <a:t>water heater running</a:t>
+            </a:r>
+          </a:p>
+          <a:p>
+            <a:pPr algn="ctr"/>
+            <a:r>
+              <a:rPr sz="900" b="0">
+                <a:solidFill>
+                  <a:srgbClr val="CCEEEE"/>
+                </a:solidFill>
+                <a:latin typeface="Calibri"/>
+              </a:rPr>
+              <a:t>at the same time</a:t>
+            </a:r>
+          </a:p>
+        </p:txBody>
+      </p:sp>
+      <p:sp>
+        <p:nvSpPr>
+          <p:cNvPr id="17" name="Rectangle 16"/>
+          <p:cNvSpPr/>
+          <p:nvPr/>
+        </p:nvSpPr>
+        <p:spPr>
+          <a:xfrm>
+            <a:off x="4948732" y="685800"/>
+            <a:ext cx="2291486" cy="1945640"/>
+          </a:xfrm>
+          <a:prstGeom prst="roundRect">
+            <a:avLst>
+              <a:gd name="adj" fmla="val 30000"/>
+            </a:avLst>
+          </a:prstGeom>
+          <a:solidFill>
+            <a:srgbClr val="0A4A4A"/>
+          </a:solidFill>
+          <a:ln w="9144">
+            <a:solidFill>
+              <a:srgbClr val="1A6B6B"/>
+            </a:solidFill>
+          </a:ln>
+        </p:spPr>
+        <p:style>
+          <a:lnRef idx="1">
+            <a:schemeClr val="accent1"/>
+          </a:lnRef>
+          <a:fillRef idx="3">
+            <a:schemeClr val="accent1"/>
+          </a:fillRef>
+          <a:effectRef idx="2">
+            <a:schemeClr val="accent1"/>
+          </a:effectRef>
+          <a:fontRef idx="minor">
+            <a:schemeClr val="lt1"/>
+          </a:fontRef>
+        </p:style>
+        <p:txBody>
+          <a:bodyPr rtlCol="0" anchor="ctr"/>
+          <a:lstStyle/>
+          <a:p>
+            <a:pPr algn="ctr"/>
+          </a:p>
+        </p:txBody>
+      </p:sp>
+      <p:sp>
+        <p:nvSpPr>
+          <p:cNvPr id="18" name="Oval 17"/>
+          <p:cNvSpPr/>
+          <p:nvPr/>
+        </p:nvSpPr>
+        <p:spPr>
+          <a:xfrm>
+            <a:off x="5942075" y="762000"/>
+            <a:ext cx="304800" cy="304800"/>
+          </a:xfrm>
+          <a:prstGeom prst="ellipse">
+            <a:avLst/>
+          </a:prstGeom>
+          <a:solidFill>
+            <a:srgbClr val="F4A261"/>
+          </a:solidFill>
+          <a:ln>
+            <a:noFill/>
+          </a:ln>
+        </p:spPr>
+        <p:style>
+          <a:lnRef idx="1">
+            <a:schemeClr val="accent1"/>
+          </a:lnRef>
+          <a:fillRef idx="3">
+            <a:schemeClr val="accent1"/>
+          </a:fillRef>
+          <a:effectRef idx="2">
+            <a:schemeClr val="accent1"/>
+          </a:effectRef>
+          <a:fontRef idx="minor">
+            <a:schemeClr val="lt1"/>
+          </a:fontRef>
+        </p:style>
+        <p:txBody>
+          <a:bodyPr rtlCol="0" anchor="ctr"/>
+          <a:lstStyle/>
+          <a:p>
+            <a:pPr algn="ctr"/>
+          </a:p>
+        </p:txBody>
+      </p:sp>
+      <p:sp>
+        <p:nvSpPr>
+          <p:cNvPr id="19" name="TextBox 18"/>
+          <p:cNvSpPr txBox="1"/>
+          <p:nvPr/>
+        </p:nvSpPr>
+        <p:spPr>
+          <a:xfrm>
+            <a:off x="5942075" y="762000"/>
+            <a:ext cx="304800" cy="304800"/>
+          </a:xfrm>
+          <a:prstGeom prst="rect">
+            <a:avLst/>
+          </a:prstGeom>
+          <a:noFill/>
+        </p:spPr>
+        <p:txBody>
+          <a:bodyPr wrap="square" anchor="ctr">
+            <a:spAutoFit/>
+          </a:bodyPr>
+          <a:lstStyle/>
+          <a:p>
+            <a:pPr algn="ctr"/>
+            <a:r>
+              <a:rPr sz="1800" b="0">
+                <a:solidFill>
+                  <a:srgbClr val="FFFFFF"/>
+                </a:solidFill>
+                <a:latin typeface="Calibri"/>
+              </a:rPr>
+              <a:t>🌙</a:t>
+            </a:r>
+          </a:p>
+        </p:txBody>
+      </p:sp>
+      <p:sp>
+        <p:nvSpPr>
+          <p:cNvPr id="20" name="TextBox 19"/>
+          <p:cNvSpPr txBox="1"/>
+          <p:nvPr/>
+        </p:nvSpPr>
+        <p:spPr>
+          <a:xfrm>
+            <a:off x="5009692" y="1126800"/>
+            <a:ext cx="2169566" cy="230000"/>
+          </a:xfrm>
+          <a:prstGeom prst="rect">
+            <a:avLst/>
+          </a:prstGeom>
+          <a:noFill/>
+        </p:spPr>
+        <p:txBody>
+          <a:bodyPr wrap="square" anchor="ctr">
+            <a:spAutoFit/>
+          </a:bodyPr>
+          <a:lstStyle/>
+          <a:p>
+            <a:pPr algn="ctr"/>
+            <a:r>
+              <a:rPr sz="1100" b="1">
+                <a:solidFill>
+                  <a:srgbClr val="FFFFFF"/>
+                </a:solidFill>
+                <a:latin typeface="Calibri"/>
+              </a:rPr>
+              <a:t>Off-Peak Shifting</a:t>
+            </a:r>
+          </a:p>
+        </p:txBody>
+      </p:sp>
+      <p:sp>
+        <p:nvSpPr>
+          <p:cNvPr id="21" name="TextBox 20"/>
+          <p:cNvSpPr txBox="1"/>
+          <p:nvPr/>
+        </p:nvSpPr>
+        <p:spPr>
+          <a:xfrm>
+            <a:off x="5009692" y="1356800"/>
+            <a:ext cx="2169566" cy="1213680"/>
+          </a:xfrm>
+          <a:prstGeom prst="rect">
+            <a:avLst/>
+          </a:prstGeom>
+          <a:noFill/>
+        </p:spPr>
+        <p:txBody>
+          <a:bodyPr wrap="square" anchor="ctr">
+            <a:spAutoFit/>
+          </a:bodyPr>
+          <a:lstStyle/>
+          <a:p>
+            <a:pPr algn="ctr"/>
+            <a:r>
+              <a:rPr sz="900" b="0">
+                <a:solidFill>
+                  <a:srgbClr val="CCEEEE"/>
+                </a:solidFill>
+                <a:latin typeface="Calibri"/>
+              </a:rPr>
+              <a:t>Moves heavy devices</a:t>
+            </a:r>
+          </a:p>
+          <a:p>
+            <a:pPr algn="ctr"/>
+            <a:r>
+              <a:rPr sz="900" b="0">
+                <a:solidFill>
+                  <a:srgbClr val="CCEEEE"/>
+                </a:solidFill>
+                <a:latin typeface="Calibri"/>
+              </a:rPr>
+              <a:t>to cheap-rate hours</a:t>
+            </a:r>
+          </a:p>
+          <a:p>
+            <a:pPr algn="ctr"/>
+            <a:r>
+              <a:rPr sz="900" b="0">
+                <a:solidFill>
+                  <a:srgbClr val="CCEEEE"/>
+                </a:solidFill>
+                <a:latin typeface="Calibri"/>
+              </a:rPr>
+              <a:t>(11 pm – 6 am)</a:t>
+            </a:r>
+          </a:p>
+        </p:txBody>
+      </p:sp>
+      <p:sp>
+        <p:nvSpPr>
+          <p:cNvPr id="22" name="Rectangle 21"/>
+          <p:cNvSpPr/>
+          <p:nvPr/>
+        </p:nvSpPr>
+        <p:spPr>
+          <a:xfrm>
+            <a:off x="7331658" y="685800"/>
+            <a:ext cx="2291486" cy="1945640"/>
+          </a:xfrm>
+          <a:prstGeom prst="roundRect">
+            <a:avLst>
+              <a:gd name="adj" fmla="val 30000"/>
+            </a:avLst>
+          </a:prstGeom>
+          <a:solidFill>
+            <a:srgbClr val="0A4A4A"/>
+          </a:solidFill>
+          <a:ln w="9144">
+            <a:solidFill>
+              <a:srgbClr val="1A6B6B"/>
+            </a:solidFill>
+          </a:ln>
+        </p:spPr>
+        <p:style>
+          <a:lnRef idx="1">
+            <a:schemeClr val="accent1"/>
+          </a:lnRef>
+          <a:fillRef idx="3">
+            <a:schemeClr val="accent1"/>
+          </a:fillRef>
+          <a:effectRef idx="2">
+            <a:schemeClr val="accent1"/>
+          </a:effectRef>
+          <a:fontRef idx="minor">
+            <a:schemeClr val="lt1"/>
+          </a:fontRef>
+        </p:style>
+        <p:txBody>
+          <a:bodyPr rtlCol="0" anchor="ctr"/>
+          <a:lstStyle/>
+          <a:p>
+            <a:pPr algn="ctr"/>
+          </a:p>
+        </p:txBody>
+      </p:sp>
+      <p:sp>
+        <p:nvSpPr>
+          <p:cNvPr id="23" name="Oval 22"/>
+          <p:cNvSpPr/>
+          <p:nvPr/>
+        </p:nvSpPr>
+        <p:spPr>
+          <a:xfrm>
+            <a:off x="8325001" y="762000"/>
+            <a:ext cx="304800" cy="304800"/>
+          </a:xfrm>
+          <a:prstGeom prst="ellipse">
+            <a:avLst/>
+          </a:prstGeom>
+          <a:solidFill>
+            <a:srgbClr val="F4A261"/>
+          </a:solidFill>
+          <a:ln>
+            <a:noFill/>
+          </a:ln>
+        </p:spPr>
+        <p:style>
+          <a:lnRef idx="1">
+            <a:schemeClr val="accent1"/>
+          </a:lnRef>
+          <a:fillRef idx="3">
+            <a:schemeClr val="accent1"/>
+          </a:fillRef>
+          <a:effectRef idx="2">
+            <a:schemeClr val="accent1"/>
+          </a:effectRef>
+          <a:fontRef idx="minor">
+            <a:schemeClr val="lt1"/>
+          </a:fontRef>
+        </p:style>
+        <p:txBody>
+          <a:bodyPr rtlCol="0" anchor="ctr"/>
+          <a:lstStyle/>
+          <a:p>
+            <a:pPr algn="ctr"/>
+          </a:p>
+        </p:txBody>
+      </p:sp>
+      <p:sp>
+        <p:nvSpPr>
+          <p:cNvPr id="24" name="TextBox 23"/>
+          <p:cNvSpPr txBox="1"/>
+          <p:nvPr/>
+        </p:nvSpPr>
+        <p:spPr>
+          <a:xfrm>
+            <a:off x="8325001" y="762000"/>
+            <a:ext cx="304800" cy="304800"/>
+          </a:xfrm>
+          <a:prstGeom prst="rect">
+            <a:avLst/>
+          </a:prstGeom>
+          <a:noFill/>
+        </p:spPr>
+        <p:txBody>
+          <a:bodyPr wrap="square" anchor="ctr">
+            <a:spAutoFit/>
+          </a:bodyPr>
+          <a:lstStyle/>
+          <a:p>
+            <a:pPr algn="ctr"/>
+            <a:r>
+              <a:rPr sz="1800" b="0">
+                <a:solidFill>
+                  <a:srgbClr val="FFFFFF"/>
+                </a:solidFill>
+                <a:latin typeface="Calibri"/>
+              </a:rPr>
+              <a:t>🏠</a:t>
+            </a:r>
+          </a:p>
+        </p:txBody>
+      </p:sp>
+      <p:sp>
+        <p:nvSpPr>
+          <p:cNvPr id="25" name="TextBox 24"/>
+          <p:cNvSpPr txBox="1"/>
+          <p:nvPr/>
+        </p:nvSpPr>
+        <p:spPr>
+          <a:xfrm>
+            <a:off x="7392618" y="1126800"/>
+            <a:ext cx="2169566" cy="230000"/>
+          </a:xfrm>
+          <a:prstGeom prst="rect">
+            <a:avLst/>
+          </a:prstGeom>
+          <a:noFill/>
+        </p:spPr>
+        <p:txBody>
+          <a:bodyPr wrap="square" anchor="ctr">
+            <a:spAutoFit/>
+          </a:bodyPr>
+          <a:lstStyle/>
+          <a:p>
+            <a:pPr algn="ctr"/>
+            <a:r>
+              <a:rPr sz="1100" b="1">
+                <a:solidFill>
+                  <a:srgbClr val="FFFFFF"/>
+                </a:solidFill>
+                <a:latin typeface="Calibri"/>
+              </a:rPr>
+              <a:t>Guest Arrival Mode</a:t>
+            </a:r>
+          </a:p>
+        </p:txBody>
+      </p:sp>
+      <p:sp>
+        <p:nvSpPr>
+          <p:cNvPr id="26" name="TextBox 25"/>
+          <p:cNvSpPr txBox="1"/>
+          <p:nvPr/>
+        </p:nvSpPr>
+        <p:spPr>
+          <a:xfrm>
+            <a:off x="7392618" y="1356800"/>
+            <a:ext cx="2169566" cy="1213680"/>
+          </a:xfrm>
+          <a:prstGeom prst="rect">
+            <a:avLst/>
+          </a:prstGeom>
+          <a:noFill/>
+        </p:spPr>
+        <p:txBody>
+          <a:bodyPr wrap="square" anchor="ctr">
+            <a:spAutoFit/>
+          </a:bodyPr>
+          <a:lstStyle/>
+          <a:p>
+            <a:pPr algn="ctr"/>
+            <a:r>
+              <a:rPr sz="900" b="0">
+                <a:solidFill>
+                  <a:srgbClr val="CCEEEE"/>
+                </a:solidFill>
+                <a:latin typeface="Calibri"/>
+              </a:rPr>
+              <a:t>Home warms &amp; lights</a:t>
+            </a:r>
+          </a:p>
+          <a:p>
+            <a:pPr algn="ctr"/>
+            <a:r>
+              <a:rPr sz="900" b="0">
+                <a:solidFill>
+                  <a:srgbClr val="CCEEEE"/>
+                </a:solidFill>
+                <a:latin typeface="Calibri"/>
+              </a:rPr>
+              <a:t>adjust 30 min before</a:t>
+            </a:r>
+          </a:p>
+          <a:p>
+            <a:pPr algn="ctr"/>
+            <a:r>
+              <a:rPr sz="900" b="0">
+                <a:solidFill>
+                  <a:srgbClr val="CCEEEE"/>
+                </a:solidFill>
+                <a:latin typeface="Calibri"/>
+              </a:rPr>
+              <a:t>guests arrive</a:t>
+            </a:r>
+          </a:p>
+        </p:txBody>
+      </p:sp>
+      <p:sp>
+        <p:nvSpPr>
+          <p:cNvPr id="27" name="Rectangle 26"/>
+          <p:cNvSpPr/>
+          <p:nvPr/>
+        </p:nvSpPr>
+        <p:spPr>
+          <a:xfrm>
+            <a:off x="9714584" y="685800"/>
+            <a:ext cx="2291486" cy="1945640"/>
+          </a:xfrm>
+          <a:prstGeom prst="roundRect">
+            <a:avLst>
+              <a:gd name="adj" fmla="val 30000"/>
+            </a:avLst>
+          </a:prstGeom>
+          <a:solidFill>
+            <a:srgbClr val="0A4A4A"/>
+          </a:solidFill>
+          <a:ln w="9144">
+            <a:solidFill>
+              <a:srgbClr val="1A6B6B"/>
+            </a:solidFill>
+          </a:ln>
+        </p:spPr>
+        <p:style>
+          <a:lnRef idx="1">
+            <a:schemeClr val="accent1"/>
+          </a:lnRef>
+          <a:fillRef idx="3">
+            <a:schemeClr val="accent1"/>
+          </a:fillRef>
+          <a:effectRef idx="2">
+            <a:schemeClr val="accent1"/>
+          </a:effectRef>
+          <a:fontRef idx="minor">
+            <a:schemeClr val="lt1"/>
+          </a:fontRef>
+        </p:style>
+        <p:txBody>
+          <a:bodyPr rtlCol="0" anchor="ctr"/>
+          <a:lstStyle/>
+          <a:p>
+            <a:pPr algn="ctr"/>
+          </a:p>
+        </p:txBody>
+      </p:sp>
+      <p:sp>
+        <p:nvSpPr>
+          <p:cNvPr id="28" name="Oval 27"/>
+          <p:cNvSpPr/>
+          <p:nvPr/>
+        </p:nvSpPr>
+        <p:spPr>
+          <a:xfrm>
+            <a:off x="10707927" y="762000"/>
+            <a:ext cx="304800" cy="304800"/>
+          </a:xfrm>
+          <a:prstGeom prst="ellipse">
+            <a:avLst/>
+          </a:prstGeom>
+          <a:solidFill>
+            <a:srgbClr val="F4A261"/>
+          </a:solidFill>
+          <a:ln>
+            <a:noFill/>
+          </a:ln>
+        </p:spPr>
+        <p:style>
+          <a:lnRef idx="1">
+            <a:schemeClr val="accent1"/>
+          </a:lnRef>
+          <a:fillRef idx="3">
+            <a:schemeClr val="accent1"/>
+          </a:fillRef>
+          <a:effectRef idx="2">
+            <a:schemeClr val="accent1"/>
+          </a:effectRef>
+          <a:fontRef idx="minor">
+            <a:schemeClr val="lt1"/>
+          </a:fontRef>
+        </p:style>
+        <p:txBody>
+          <a:bodyPr rtlCol="0" anchor="ctr"/>
+          <a:lstStyle/>
+          <a:p>
+            <a:pPr algn="ctr"/>
+          </a:p>
+        </p:txBody>
+      </p:sp>
+      <p:sp>
+        <p:nvSpPr>
+          <p:cNvPr id="29" name="TextBox 28"/>
+          <p:cNvSpPr txBox="1"/>
+          <p:nvPr/>
+        </p:nvSpPr>
+        <p:spPr>
+          <a:xfrm>
+            <a:off x="10707927" y="762000"/>
+            <a:ext cx="304800" cy="304800"/>
+          </a:xfrm>
+          <a:prstGeom prst="rect">
+            <a:avLst/>
+          </a:prstGeom>
+          <a:noFill/>
+        </p:spPr>
+        <p:txBody>
+          <a:bodyPr wrap="square" anchor="ctr">
+            <a:spAutoFit/>
+          </a:bodyPr>
+          <a:lstStyle/>
+          <a:p>
+            <a:pPr algn="ctr"/>
+            <a:r>
+              <a:rPr sz="1800" b="0">
+                <a:solidFill>
+                  <a:srgbClr val="FFFFFF"/>
+                </a:solidFill>
+                <a:latin typeface="Calibri"/>
+              </a:rPr>
+              <a:t>🌬</a:t>
+            </a:r>
+          </a:p>
+        </p:txBody>
+      </p:sp>
+      <p:sp>
+        <p:nvSpPr>
+          <p:cNvPr id="30" name="TextBox 29"/>
+          <p:cNvSpPr txBox="1"/>
+          <p:nvPr/>
+        </p:nvSpPr>
+        <p:spPr>
+          <a:xfrm>
+            <a:off x="9775544" y="1126800"/>
+            <a:ext cx="2169566" cy="230000"/>
+          </a:xfrm>
+          <a:prstGeom prst="rect">
+            <a:avLst/>
+          </a:prstGeom>
+          <a:noFill/>
+        </p:spPr>
+        <p:txBody>
+          <a:bodyPr wrap="square" anchor="ctr">
+            <a:spAutoFit/>
+          </a:bodyPr>
+          <a:lstStyle/>
+          <a:p>
+            <a:pPr algn="ctr"/>
+            <a:r>
+              <a:rPr sz="1100" b="1">
+                <a:solidFill>
+                  <a:srgbClr val="FFFFFF"/>
+                </a:solidFill>
+                <a:latin typeface="Calibri"/>
+              </a:rPr>
+              <a:t>Air Quality Control</a:t>
+            </a:r>
+          </a:p>
+        </p:txBody>
+      </p:sp>
+      <p:sp>
+        <p:nvSpPr>
+          <p:cNvPr id="31" name="TextBox 30"/>
+          <p:cNvSpPr txBox="1"/>
+          <p:nvPr/>
+        </p:nvSpPr>
+        <p:spPr>
+          <a:xfrm>
+            <a:off x="9775544" y="1356800"/>
+            <a:ext cx="2169566" cy="1213680"/>
+          </a:xfrm>
+          <a:prstGeom prst="rect">
+            <a:avLst/>
+          </a:prstGeom>
+          <a:noFill/>
+        </p:spPr>
+        <p:txBody>
+          <a:bodyPr wrap="square" anchor="ctr">
+            <a:spAutoFit/>
+          </a:bodyPr>
+          <a:lstStyle/>
+          <a:p>
+            <a:pPr algn="ctr"/>
+            <a:r>
+              <a:rPr sz="900" b="0">
+                <a:solidFill>
+                  <a:srgbClr val="CCEEEE"/>
+                </a:solidFill>
+                <a:latin typeface="Calibri"/>
+              </a:rPr>
+              <a:t>Auto-opens windows</a:t>
+            </a:r>
+          </a:p>
+          <a:p>
+            <a:pPr algn="ctr"/>
+            <a:r>
+              <a:rPr sz="900" b="0">
+                <a:solidFill>
+                  <a:srgbClr val="CCEEEE"/>
+                </a:solidFill>
+                <a:latin typeface="Calibri"/>
+              </a:rPr>
+              <a:t>when outdoor AQI</a:t>
+            </a:r>
+          </a:p>
+          <a:p>
+            <a:pPr algn="ctr"/>
+            <a:r>
+              <a:rPr sz="900" b="0">
+                <a:solidFill>
+                  <a:srgbClr val="CCEEEE"/>
+                </a:solidFill>
+                <a:latin typeface="Calibri"/>
+              </a:rPr>
+              <a:t>is cleaner than indoor</a:t>
+            </a:r>
+          </a:p>
+        </p:txBody>
+      </p:sp>
+      <p:sp>
+        <p:nvSpPr>
+          <p:cNvPr id="32" name="Rectangle 31"/>
+          <p:cNvSpPr/>
+          <p:nvPr/>
+        </p:nvSpPr>
+        <p:spPr>
+          <a:xfrm>
+            <a:off x="182880" y="2722880"/>
+            <a:ext cx="2291486" cy="1945640"/>
+          </a:xfrm>
+          <a:prstGeom prst="roundRect">
+            <a:avLst>
+              <a:gd name="adj" fmla="val 30000"/>
+            </a:avLst>
+          </a:prstGeom>
+          <a:solidFill>
+            <a:srgbClr val="0A4A4A"/>
+          </a:solidFill>
+          <a:ln w="9144">
+            <a:solidFill>
+              <a:srgbClr val="1A6B6B"/>
+            </a:solidFill>
+          </a:ln>
+        </p:spPr>
+        <p:style>
+          <a:lnRef idx="1">
+            <a:schemeClr val="accent1"/>
+          </a:lnRef>
+          <a:fillRef idx="3">
+            <a:schemeClr val="accent1"/>
+          </a:fillRef>
+          <a:effectRef idx="2">
+            <a:schemeClr val="accent1"/>
+          </a:effectRef>
+          <a:fontRef idx="minor">
+            <a:schemeClr val="lt1"/>
+          </a:fontRef>
+        </p:style>
+        <p:txBody>
+          <a:bodyPr rtlCol="0" anchor="ctr"/>
+          <a:lstStyle/>
+          <a:p>
+            <a:pPr algn="ctr"/>
+          </a:p>
+        </p:txBody>
+      </p:sp>
+      <p:sp>
+        <p:nvSpPr>
+          <p:cNvPr id="33" name="Oval 32"/>
+          <p:cNvSpPr/>
+          <p:nvPr/>
+        </p:nvSpPr>
+        <p:spPr>
+          <a:xfrm>
+            <a:off x="1176223" y="2799080"/>
+            <a:ext cx="304800" cy="304800"/>
+          </a:xfrm>
+          <a:prstGeom prst="ellipse">
+            <a:avLst/>
+          </a:prstGeom>
+          <a:solidFill>
+            <a:srgbClr val="2EC4B6"/>
+          </a:solidFill>
+          <a:ln>
+            <a:noFill/>
+          </a:ln>
+        </p:spPr>
+        <p:style>
+          <a:lnRef idx="1">
+            <a:schemeClr val="accent1"/>
+          </a:lnRef>
+          <a:fillRef idx="3">
+            <a:schemeClr val="accent1"/>
+          </a:fillRef>
+          <a:effectRef idx="2">
+            <a:schemeClr val="accent1"/>
+          </a:effectRef>
+          <a:fontRef idx="minor">
+            <a:schemeClr val="lt1"/>
+          </a:fontRef>
+        </p:style>
+        <p:txBody>
+          <a:bodyPr rtlCol="0" anchor="ctr"/>
+          <a:lstStyle/>
+          <a:p>
+            <a:pPr algn="ctr"/>
+          </a:p>
+        </p:txBody>
+      </p:sp>
+      <p:sp>
+        <p:nvSpPr>
+          <p:cNvPr id="34" name="TextBox 33"/>
+          <p:cNvSpPr txBox="1"/>
+          <p:nvPr/>
+        </p:nvSpPr>
+        <p:spPr>
+          <a:xfrm>
+            <a:off x="1176223" y="2799080"/>
+            <a:ext cx="304800" cy="304800"/>
+          </a:xfrm>
+          <a:prstGeom prst="rect">
+            <a:avLst/>
+          </a:prstGeom>
+          <a:noFill/>
+        </p:spPr>
+        <p:txBody>
+          <a:bodyPr wrap="square" anchor="ctr">
+            <a:spAutoFit/>
+          </a:bodyPr>
+          <a:lstStyle/>
+          <a:p>
+            <a:pPr algn="ctr"/>
+            <a:r>
+              <a:rPr sz="1800" b="0">
+                <a:solidFill>
+                  <a:srgbClr val="FFFFFF"/>
+                </a:solidFill>
+                <a:latin typeface="Calibri"/>
+              </a:rPr>
+              <a:t>🌅</a:t>
+            </a:r>
+          </a:p>
+        </p:txBody>
+      </p:sp>
+      <p:sp>
+        <p:nvSpPr>
+          <p:cNvPr id="35" name="TextBox 34"/>
+          <p:cNvSpPr txBox="1"/>
+          <p:nvPr/>
+        </p:nvSpPr>
+        <p:spPr>
+          <a:xfrm>
+            <a:off x="243840" y="3163880"/>
+            <a:ext cx="2169566" cy="230000"/>
+          </a:xfrm>
+          <a:prstGeom prst="rect">
+            <a:avLst/>
+          </a:prstGeom>
+          <a:noFill/>
+        </p:spPr>
+        <p:txBody>
+          <a:bodyPr wrap="square" anchor="ctr">
+            <a:spAutoFit/>
+          </a:bodyPr>
+          <a:lstStyle/>
+          <a:p>
+            <a:pPr algn="ctr"/>
+            <a:r>
+              <a:rPr sz="1100" b="1">
+                <a:solidFill>
+                  <a:srgbClr val="FFFFFF"/>
+                </a:solidFill>
+                <a:latin typeface="Calibri"/>
+              </a:rPr>
+              <a:t>Sunrise Automation</a:t>
+            </a:r>
+          </a:p>
+        </p:txBody>
+      </p:sp>
+      <p:sp>
+        <p:nvSpPr>
+          <p:cNvPr id="36" name="TextBox 35"/>
+          <p:cNvSpPr txBox="1"/>
+          <p:nvPr/>
+        </p:nvSpPr>
+        <p:spPr>
+          <a:xfrm>
+            <a:off x="243840" y="3393880"/>
+            <a:ext cx="2169566" cy="1213680"/>
+          </a:xfrm>
+          <a:prstGeom prst="rect">
+            <a:avLst/>
+          </a:prstGeom>
+          <a:noFill/>
+        </p:spPr>
+        <p:txBody>
+          <a:bodyPr wrap="square" anchor="ctr">
+            <a:spAutoFit/>
+          </a:bodyPr>
+          <a:lstStyle/>
+          <a:p>
+            <a:pPr algn="ctr"/>
+            <a:r>
+              <a:rPr sz="900" b="0">
+                <a:solidFill>
+                  <a:srgbClr val="CCEEEE"/>
+                </a:solidFill>
+                <a:latin typeface="Calibri"/>
+              </a:rPr>
+              <a:t>Lights fade in gently</a:t>
+            </a:r>
+          </a:p>
+          <a:p>
+            <a:pPr algn="ctr"/>
+            <a:r>
+              <a:rPr sz="900" b="0">
+                <a:solidFill>
+                  <a:srgbClr val="CCEEEE"/>
+                </a:solidFill>
+                <a:latin typeface="Calibri"/>
+              </a:rPr>
+              <a:t>at local sunrise;</a:t>
+            </a:r>
+          </a:p>
+          <a:p>
+            <a:pPr algn="ctr"/>
+            <a:r>
+              <a:rPr sz="900" b="0">
+                <a:solidFill>
+                  <a:srgbClr val="CCEEEE"/>
+                </a:solidFill>
+                <a:latin typeface="Calibri"/>
+              </a:rPr>
+              <a:t>blinds raise at dusk</a:t>
+            </a:r>
+          </a:p>
+        </p:txBody>
+      </p:sp>
+      <p:sp>
+        <p:nvSpPr>
+          <p:cNvPr id="37" name="Rectangle 36"/>
+          <p:cNvSpPr/>
+          <p:nvPr/>
+        </p:nvSpPr>
+        <p:spPr>
+          <a:xfrm>
+            <a:off x="2565806" y="2722880"/>
+            <a:ext cx="2291486" cy="1945640"/>
+          </a:xfrm>
+          <a:prstGeom prst="roundRect">
+            <a:avLst>
+              <a:gd name="adj" fmla="val 30000"/>
+            </a:avLst>
+          </a:prstGeom>
+          <a:solidFill>
+            <a:srgbClr val="0A4A4A"/>
+          </a:solidFill>
+          <a:ln w="9144">
+            <a:solidFill>
+              <a:srgbClr val="1A6B6B"/>
+            </a:solidFill>
+          </a:ln>
+        </p:spPr>
+        <p:style>
+          <a:lnRef idx="1">
+            <a:schemeClr val="accent1"/>
+          </a:lnRef>
+          <a:fillRef idx="3">
+            <a:schemeClr val="accent1"/>
+          </a:fillRef>
+          <a:effectRef idx="2">
+            <a:schemeClr val="accent1"/>
+          </a:effectRef>
+          <a:fontRef idx="minor">
+            <a:schemeClr val="lt1"/>
+          </a:fontRef>
+        </p:style>
+        <p:txBody>
+          <a:bodyPr rtlCol="0" anchor="ctr"/>
+          <a:lstStyle/>
+          <a:p>
+            <a:pPr algn="ctr"/>
+          </a:p>
+        </p:txBody>
+      </p:sp>
+      <p:sp>
+        <p:nvSpPr>
+          <p:cNvPr id="38" name="Oval 37"/>
+          <p:cNvSpPr/>
+          <p:nvPr/>
+        </p:nvSpPr>
+        <p:spPr>
+          <a:xfrm>
+            <a:off x="3559149" y="2799080"/>
+            <a:ext cx="304800" cy="304800"/>
+          </a:xfrm>
+          <a:prstGeom prst="ellipse">
+            <a:avLst/>
+          </a:prstGeom>
+          <a:solidFill>
+            <a:srgbClr val="2EC4B6"/>
+          </a:solidFill>
+          <a:ln>
+            <a:noFill/>
+          </a:ln>
+        </p:spPr>
+        <p:style>
+          <a:lnRef idx="1">
+            <a:schemeClr val="accent1"/>
+          </a:lnRef>
+          <a:fillRef idx="3">
+            <a:schemeClr val="accent1"/>
+          </a:fillRef>
+          <a:effectRef idx="2">
+            <a:schemeClr val="accent1"/>
+          </a:effectRef>
+          <a:fontRef idx="minor">
+            <a:schemeClr val="lt1"/>
+          </a:fontRef>
+        </p:style>
+        <p:txBody>
+          <a:bodyPr rtlCol="0" anchor="ctr"/>
+          <a:lstStyle/>
+          <a:p>
+            <a:pPr algn="ctr"/>
+          </a:p>
+        </p:txBody>
+      </p:sp>
+      <p:sp>
+        <p:nvSpPr>
+          <p:cNvPr id="39" name="TextBox 38"/>
+          <p:cNvSpPr txBox="1"/>
+          <p:nvPr/>
+        </p:nvSpPr>
+        <p:spPr>
+          <a:xfrm>
+            <a:off x="3559149" y="2799080"/>
+            <a:ext cx="304800" cy="304800"/>
+          </a:xfrm>
+          <a:prstGeom prst="rect">
+            <a:avLst/>
+          </a:prstGeom>
+          <a:noFill/>
+        </p:spPr>
+        <p:txBody>
+          <a:bodyPr wrap="square" anchor="ctr">
+            <a:spAutoFit/>
+          </a:bodyPr>
+          <a:lstStyle/>
+          <a:p>
+            <a:pPr algn="ctr"/>
+            <a:r>
+              <a:rPr sz="1800" b="0">
+                <a:solidFill>
+                  <a:srgbClr val="FFFFFF"/>
+                </a:solidFill>
+                <a:latin typeface="Calibri"/>
+              </a:rPr>
+              <a:t>🚿</a:t>
+            </a:r>
+          </a:p>
+        </p:txBody>
+      </p:sp>
+      <p:sp>
+        <p:nvSpPr>
+          <p:cNvPr id="40" name="TextBox 39"/>
+          <p:cNvSpPr txBox="1"/>
+          <p:nvPr/>
+        </p:nvSpPr>
+        <p:spPr>
+          <a:xfrm>
+            <a:off x="2626766" y="3163880"/>
+            <a:ext cx="2169566" cy="230000"/>
+          </a:xfrm>
+          <a:prstGeom prst="rect">
+            <a:avLst/>
+          </a:prstGeom>
+          <a:noFill/>
+        </p:spPr>
+        <p:txBody>
+          <a:bodyPr wrap="square" anchor="ctr">
+            <a:spAutoFit/>
+          </a:bodyPr>
+          <a:lstStyle/>
+          <a:p>
+            <a:pPr algn="ctr"/>
+            <a:r>
+              <a:rPr sz="1100" b="1">
+                <a:solidFill>
+                  <a:srgbClr val="FFFFFF"/>
+                </a:solidFill>
+                <a:latin typeface="Calibri"/>
+              </a:rPr>
+              <a:t>Pre-Scheduled Water</a:t>
+            </a:r>
+          </a:p>
+        </p:txBody>
+      </p:sp>
+      <p:sp>
+        <p:nvSpPr>
+          <p:cNvPr id="41" name="TextBox 40"/>
+          <p:cNvSpPr txBox="1"/>
+          <p:nvPr/>
+        </p:nvSpPr>
+        <p:spPr>
+          <a:xfrm>
+            <a:off x="2626766" y="3393880"/>
+            <a:ext cx="2169566" cy="1213680"/>
+          </a:xfrm>
+          <a:prstGeom prst="rect">
+            <a:avLst/>
+          </a:prstGeom>
+          <a:noFill/>
+        </p:spPr>
+        <p:txBody>
+          <a:bodyPr wrap="square" anchor="ctr">
+            <a:spAutoFit/>
+          </a:bodyPr>
+          <a:lstStyle/>
+          <a:p>
+            <a:pPr algn="ctr"/>
+            <a:r>
+              <a:rPr sz="900" b="0">
+                <a:solidFill>
+                  <a:srgbClr val="CCEEEE"/>
+                </a:solidFill>
+                <a:latin typeface="Calibri"/>
+              </a:rPr>
+              <a:t>Hot water ready</a:t>
+            </a:r>
+          </a:p>
+          <a:p>
+            <a:pPr algn="ctr"/>
+            <a:r>
+              <a:rPr sz="900" b="0">
+                <a:solidFill>
+                  <a:srgbClr val="CCEEEE"/>
+                </a:solidFill>
+                <a:latin typeface="Calibri"/>
+              </a:rPr>
+              <a:t>5 min before your</a:t>
+            </a:r>
+          </a:p>
+          <a:p>
+            <a:pPr algn="ctr"/>
+            <a:r>
+              <a:rPr sz="900" b="0">
+                <a:solidFill>
+                  <a:srgbClr val="CCEEEE"/>
+                </a:solidFill>
+                <a:latin typeface="Calibri"/>
+              </a:rPr>
+              <a:t>usual shower time</a:t>
+            </a:r>
+          </a:p>
+        </p:txBody>
+      </p:sp>
+      <p:sp>
+        <p:nvSpPr>
+          <p:cNvPr id="42" name="Rectangle 41"/>
+          <p:cNvSpPr/>
+          <p:nvPr/>
+        </p:nvSpPr>
+        <p:spPr>
+          <a:xfrm>
+            <a:off x="4948732" y="2722880"/>
+            <a:ext cx="2291486" cy="1945640"/>
+          </a:xfrm>
+          <a:prstGeom prst="roundRect">
+            <a:avLst>
+              <a:gd name="adj" fmla="val 30000"/>
+            </a:avLst>
+          </a:prstGeom>
+          <a:solidFill>
+            <a:srgbClr val="0A4A4A"/>
+          </a:solidFill>
+          <a:ln w="9144">
+            <a:solidFill>
+              <a:srgbClr val="1A6B6B"/>
+            </a:solidFill>
+          </a:ln>
+        </p:spPr>
+        <p:style>
+          <a:lnRef idx="1">
+            <a:schemeClr val="accent1"/>
+          </a:lnRef>
+          <a:fillRef idx="3">
+            <a:schemeClr val="accent1"/>
+          </a:fillRef>
+          <a:effectRef idx="2">
+            <a:schemeClr val="accent1"/>
+          </a:effectRef>
+          <a:fontRef idx="minor">
+            <a:schemeClr val="lt1"/>
+          </a:fontRef>
+        </p:style>
+        <p:txBody>
+          <a:bodyPr rtlCol="0" anchor="ctr"/>
+          <a:lstStyle/>
+          <a:p>
+            <a:pPr algn="ctr"/>
+          </a:p>
+        </p:txBody>
+      </p:sp>
+      <p:sp>
+        <p:nvSpPr>
+          <p:cNvPr id="43" name="Oval 42"/>
+          <p:cNvSpPr/>
+          <p:nvPr/>
+        </p:nvSpPr>
+        <p:spPr>
+          <a:xfrm>
+            <a:off x="5942075" y="2799080"/>
+            <a:ext cx="304800" cy="304800"/>
+          </a:xfrm>
+          <a:prstGeom prst="ellipse">
+            <a:avLst/>
+          </a:prstGeom>
+          <a:solidFill>
+            <a:srgbClr val="2EC4B6"/>
+          </a:solidFill>
+          <a:ln>
+            <a:noFill/>
+          </a:ln>
+        </p:spPr>
+        <p:style>
+          <a:lnRef idx="1">
+            <a:schemeClr val="accent1"/>
+          </a:lnRef>
+          <a:fillRef idx="3">
+            <a:schemeClr val="accent1"/>
+          </a:fillRef>
+          <a:effectRef idx="2">
+            <a:schemeClr val="accent1"/>
+          </a:effectRef>
+          <a:fontRef idx="minor">
+            <a:schemeClr val="lt1"/>
+          </a:fontRef>
+        </p:style>
+        <p:txBody>
+          <a:bodyPr rtlCol="0" anchor="ctr"/>
+          <a:lstStyle/>
+          <a:p>
+            <a:pPr algn="ctr"/>
+          </a:p>
+        </p:txBody>
+      </p:sp>
+      <p:sp>
+        <p:nvSpPr>
+          <p:cNvPr id="44" name="TextBox 43"/>
+          <p:cNvSpPr txBox="1"/>
+          <p:nvPr/>
+        </p:nvSpPr>
+        <p:spPr>
+          <a:xfrm>
+            <a:off x="5942075" y="2799080"/>
+            <a:ext cx="304800" cy="304800"/>
+          </a:xfrm>
+          <a:prstGeom prst="rect">
+            <a:avLst/>
+          </a:prstGeom>
+          <a:noFill/>
+        </p:spPr>
+        <p:txBody>
+          <a:bodyPr wrap="square" anchor="ctr">
+            <a:spAutoFit/>
+          </a:bodyPr>
+          <a:lstStyle/>
+          <a:p>
+            <a:pPr algn="ctr"/>
+            <a:r>
+              <a:rPr sz="1800" b="0">
+                <a:solidFill>
+                  <a:srgbClr val="FFFFFF"/>
+                </a:solidFill>
+                <a:latin typeface="Calibri"/>
+              </a:rPr>
+              <a:t>🌿</a:t>
+            </a:r>
+          </a:p>
+        </p:txBody>
+      </p:sp>
+      <p:sp>
+        <p:nvSpPr>
+          <p:cNvPr id="45" name="TextBox 44"/>
+          <p:cNvSpPr txBox="1"/>
+          <p:nvPr/>
+        </p:nvSpPr>
+        <p:spPr>
+          <a:xfrm>
+            <a:off x="5009692" y="3163880"/>
+            <a:ext cx="2169566" cy="230000"/>
+          </a:xfrm>
+          <a:prstGeom prst="rect">
+            <a:avLst/>
+          </a:prstGeom>
+          <a:noFill/>
+        </p:spPr>
+        <p:txBody>
+          <a:bodyPr wrap="square" anchor="ctr">
+            <a:spAutoFit/>
+          </a:bodyPr>
+          <a:lstStyle/>
+          <a:p>
+            <a:pPr algn="ctr"/>
+            <a:r>
+              <a:rPr sz="1100" b="1">
+                <a:solidFill>
+                  <a:srgbClr val="FFFFFF"/>
+                </a:solidFill>
+                <a:latin typeface="Calibri"/>
+              </a:rPr>
+              <a:t>Renewable Signal</a:t>
+            </a:r>
+          </a:p>
+        </p:txBody>
+      </p:sp>
+      <p:sp>
+        <p:nvSpPr>
+          <p:cNvPr id="46" name="TextBox 45"/>
+          <p:cNvSpPr txBox="1"/>
+          <p:nvPr/>
+        </p:nvSpPr>
+        <p:spPr>
+          <a:xfrm>
+            <a:off x="5009692" y="3393880"/>
+            <a:ext cx="2169566" cy="1213680"/>
+          </a:xfrm>
+          <a:prstGeom prst="rect">
+            <a:avLst/>
+          </a:prstGeom>
+          <a:noFill/>
+        </p:spPr>
+        <p:txBody>
+          <a:bodyPr wrap="square" anchor="ctr">
+            <a:spAutoFit/>
+          </a:bodyPr>
+          <a:lstStyle/>
+          <a:p>
+            <a:pPr algn="ctr"/>
+            <a:r>
+              <a:rPr sz="900" b="0">
+                <a:solidFill>
+                  <a:srgbClr val="CCEEEE"/>
+                </a:solidFill>
+                <a:latin typeface="Calibri"/>
+              </a:rPr>
+              <a:t>Living room pulses</a:t>
+            </a:r>
+          </a:p>
+          <a:p>
+            <a:pPr algn="ctr"/>
+            <a:r>
+              <a:rPr sz="900" b="0">
+                <a:solidFill>
+                  <a:srgbClr val="CCEEEE"/>
+                </a:solidFill>
+                <a:latin typeface="Calibri"/>
+              </a:rPr>
+              <a:t>green when the grid</a:t>
+            </a:r>
+          </a:p>
+          <a:p>
+            <a:pPr algn="ctr"/>
+            <a:r>
+              <a:rPr sz="900" b="0">
+                <a:solidFill>
+                  <a:srgbClr val="CCEEEE"/>
+                </a:solidFill>
+                <a:latin typeface="Calibri"/>
+              </a:rPr>
+              <a:t>runs on clean energy</a:t>
+            </a:r>
+          </a:p>
+        </p:txBody>
+      </p:sp>
+      <p:sp>
+        <p:nvSpPr>
+          <p:cNvPr id="47" name="Rectangle 46"/>
+          <p:cNvSpPr/>
+          <p:nvPr/>
+        </p:nvSpPr>
+        <p:spPr>
+          <a:xfrm>
+            <a:off x="7331658" y="2722880"/>
+            <a:ext cx="2291486" cy="1945640"/>
+          </a:xfrm>
+          <a:prstGeom prst="roundRect">
+            <a:avLst>
+              <a:gd name="adj" fmla="val 30000"/>
+            </a:avLst>
+          </a:prstGeom>
+          <a:solidFill>
+            <a:srgbClr val="0A4A4A"/>
+          </a:solidFill>
+          <a:ln w="9144">
+            <a:solidFill>
+              <a:srgbClr val="1A6B6B"/>
+            </a:solidFill>
+          </a:ln>
+        </p:spPr>
+        <p:style>
+          <a:lnRef idx="1">
+            <a:schemeClr val="accent1"/>
+          </a:lnRef>
+          <a:fillRef idx="3">
+            <a:schemeClr val="accent1"/>
+          </a:fillRef>
+          <a:effectRef idx="2">
+            <a:schemeClr val="accent1"/>
+          </a:effectRef>
+          <a:fontRef idx="minor">
+            <a:schemeClr val="lt1"/>
+          </a:fontRef>
+        </p:style>
+        <p:txBody>
+          <a:bodyPr rtlCol="0" anchor="ctr"/>
+          <a:lstStyle/>
+          <a:p>
+            <a:pPr algn="ctr"/>
+          </a:p>
+        </p:txBody>
+      </p:sp>
+      <p:sp>
+        <p:nvSpPr>
+          <p:cNvPr id="48" name="Oval 47"/>
+          <p:cNvSpPr/>
+          <p:nvPr/>
+        </p:nvSpPr>
+        <p:spPr>
+          <a:xfrm>
+            <a:off x="8325001" y="2799080"/>
+            <a:ext cx="304800" cy="304800"/>
+          </a:xfrm>
+          <a:prstGeom prst="ellipse">
+            <a:avLst/>
+          </a:prstGeom>
+          <a:solidFill>
+            <a:srgbClr val="2EC4B6"/>
+          </a:solidFill>
+          <a:ln>
+            <a:noFill/>
+          </a:ln>
+        </p:spPr>
+        <p:style>
+          <a:lnRef idx="1">
+            <a:schemeClr val="accent1"/>
+          </a:lnRef>
+          <a:fillRef idx="3">
+            <a:schemeClr val="accent1"/>
+          </a:fillRef>
+          <a:effectRef idx="2">
+            <a:schemeClr val="accent1"/>
+          </a:effectRef>
+          <a:fontRef idx="minor">
+            <a:schemeClr val="lt1"/>
+          </a:fontRef>
+        </p:style>
+        <p:txBody>
+          <a:bodyPr rtlCol="0" anchor="ctr"/>
+          <a:lstStyle/>
+          <a:p>
+            <a:pPr algn="ctr"/>
+          </a:p>
+        </p:txBody>
+      </p:sp>
+      <p:sp>
+        <p:nvSpPr>
+          <p:cNvPr id="49" name="TextBox 48"/>
+          <p:cNvSpPr txBox="1"/>
+          <p:nvPr/>
+        </p:nvSpPr>
+        <p:spPr>
+          <a:xfrm>
+            <a:off x="8325001" y="2799080"/>
+            <a:ext cx="304800" cy="304800"/>
+          </a:xfrm>
+          <a:prstGeom prst="rect">
+            <a:avLst/>
+          </a:prstGeom>
+          <a:noFill/>
+        </p:spPr>
+        <p:txBody>
+          <a:bodyPr wrap="square" anchor="ctr">
+            <a:spAutoFit/>
+          </a:bodyPr>
+          <a:lstStyle/>
+          <a:p>
+            <a:pPr algn="ctr"/>
+            <a:r>
+              <a:rPr sz="1800" b="0">
+                <a:solidFill>
+                  <a:srgbClr val="FFFFFF"/>
+                </a:solidFill>
+                <a:latin typeface="Calibri"/>
+              </a:rPr>
+              <a:t>🌡</a:t>
+            </a:r>
+          </a:p>
+        </p:txBody>
+      </p:sp>
+      <p:sp>
+        <p:nvSpPr>
+          <p:cNvPr id="50" name="TextBox 49"/>
+          <p:cNvSpPr txBox="1"/>
+          <p:nvPr/>
+        </p:nvSpPr>
+        <p:spPr>
+          <a:xfrm>
+            <a:off x="7392618" y="3163880"/>
+            <a:ext cx="2169566" cy="230000"/>
+          </a:xfrm>
+          <a:prstGeom prst="rect">
+            <a:avLst/>
+          </a:prstGeom>
+          <a:noFill/>
+        </p:spPr>
+        <p:txBody>
+          <a:bodyPr wrap="square" anchor="ctr">
+            <a:spAutoFit/>
+          </a:bodyPr>
+          <a:lstStyle/>
+          <a:p>
+            <a:pPr algn="ctr"/>
+            <a:r>
+              <a:rPr sz="1100" b="1">
+                <a:solidFill>
+                  <a:srgbClr val="FFFFFF"/>
+                </a:solidFill>
+                <a:latin typeface="Calibri"/>
+              </a:rPr>
+              <a:t>Climate Balance</a:t>
+            </a:r>
+          </a:p>
+        </p:txBody>
+      </p:sp>
+      <p:sp>
+        <p:nvSpPr>
+          <p:cNvPr id="51" name="TextBox 50"/>
+          <p:cNvSpPr txBox="1"/>
+          <p:nvPr/>
+        </p:nvSpPr>
+        <p:spPr>
+          <a:xfrm>
+            <a:off x="7392618" y="3393880"/>
+            <a:ext cx="2169566" cy="1213680"/>
+          </a:xfrm>
+          <a:prstGeom prst="rect">
+            <a:avLst/>
+          </a:prstGeom>
+          <a:noFill/>
+        </p:spPr>
+        <p:txBody>
+          <a:bodyPr wrap="square" anchor="ctr">
+            <a:spAutoFit/>
+          </a:bodyPr>
+          <a:lstStyle/>
+          <a:p>
+            <a:pPr algn="ctr"/>
+            <a:r>
+              <a:rPr sz="900" b="0">
+                <a:solidFill>
+                  <a:srgbClr val="CCEEEE"/>
+                </a:solidFill>
+                <a:latin typeface="Calibri"/>
+              </a:rPr>
+              <a:t>Coordinates heating</a:t>
+            </a:r>
+          </a:p>
+          <a:p>
+            <a:pPr algn="ctr"/>
+            <a:r>
+              <a:rPr sz="900" b="0">
+                <a:solidFill>
+                  <a:srgbClr val="CCEEEE"/>
+                </a:solidFill>
+                <a:latin typeface="Calibri"/>
+              </a:rPr>
+              <a:t>across rooms to avoid</a:t>
+            </a:r>
+          </a:p>
+          <a:p>
+            <a:pPr algn="ctr"/>
+            <a:r>
+              <a:rPr sz="900" b="0">
+                <a:solidFill>
+                  <a:srgbClr val="CCEEEE"/>
+                </a:solidFill>
+                <a:latin typeface="Calibri"/>
+              </a:rPr>
+              <a:t>cold spots</a:t>
+            </a:r>
+          </a:p>
+        </p:txBody>
+      </p:sp>
+      <p:sp>
+        <p:nvSpPr>
+          <p:cNvPr id="52" name="Rectangle 51"/>
+          <p:cNvSpPr/>
+          <p:nvPr/>
+        </p:nvSpPr>
+        <p:spPr>
+          <a:xfrm>
+            <a:off x="9714584" y="2722880"/>
+            <a:ext cx="2291486" cy="1945640"/>
+          </a:xfrm>
+          <a:prstGeom prst="roundRect">
+            <a:avLst>
+              <a:gd name="adj" fmla="val 30000"/>
+            </a:avLst>
+          </a:prstGeom>
+          <a:solidFill>
+            <a:srgbClr val="0A4A4A"/>
+          </a:solidFill>
+          <a:ln w="9144">
+            <a:solidFill>
+              <a:srgbClr val="1A6B6B"/>
+            </a:solidFill>
+          </a:ln>
+        </p:spPr>
+        <p:style>
+          <a:lnRef idx="1">
+            <a:schemeClr val="accent1"/>
+          </a:lnRef>
+          <a:fillRef idx="3">
+            <a:schemeClr val="accent1"/>
+          </a:fillRef>
+          <a:effectRef idx="2">
+            <a:schemeClr val="accent1"/>
+          </a:effectRef>
+          <a:fontRef idx="minor">
+            <a:schemeClr val="lt1"/>
+          </a:fontRef>
+        </p:style>
+        <p:txBody>
+          <a:bodyPr rtlCol="0" anchor="ctr"/>
+          <a:lstStyle/>
+          <a:p>
+            <a:pPr algn="ctr"/>
+          </a:p>
+        </p:txBody>
+      </p:sp>
+      <p:sp>
+        <p:nvSpPr>
+          <p:cNvPr id="53" name="Oval 52"/>
+          <p:cNvSpPr/>
+          <p:nvPr/>
+        </p:nvSpPr>
+        <p:spPr>
+          <a:xfrm>
+            <a:off x="10707927" y="2799080"/>
+            <a:ext cx="304800" cy="304800"/>
+          </a:xfrm>
+          <a:prstGeom prst="ellipse">
+            <a:avLst/>
+          </a:prstGeom>
+          <a:solidFill>
+            <a:srgbClr val="2EC4B6"/>
+          </a:solidFill>
+          <a:ln>
+            <a:noFill/>
+          </a:ln>
+        </p:spPr>
+        <p:style>
+          <a:lnRef idx="1">
+            <a:schemeClr val="accent1"/>
+          </a:lnRef>
+          <a:fillRef idx="3">
+            <a:schemeClr val="accent1"/>
+          </a:fillRef>
+          <a:effectRef idx="2">
+            <a:schemeClr val="accent1"/>
+          </a:effectRef>
+          <a:fontRef idx="minor">
+            <a:schemeClr val="lt1"/>
+          </a:fontRef>
+        </p:style>
+        <p:txBody>
+          <a:bodyPr rtlCol="0" anchor="ctr"/>
+          <a:lstStyle/>
+          <a:p>
+            <a:pPr algn="ctr"/>
+          </a:p>
+        </p:txBody>
+      </p:sp>
+      <p:sp>
+        <p:nvSpPr>
+          <p:cNvPr id="54" name="TextBox 53"/>
+          <p:cNvSpPr txBox="1"/>
+          <p:nvPr/>
+        </p:nvSpPr>
+        <p:spPr>
+          <a:xfrm>
+            <a:off x="10707927" y="2799080"/>
+            <a:ext cx="304800" cy="304800"/>
+          </a:xfrm>
+          <a:prstGeom prst="rect">
+            <a:avLst/>
+          </a:prstGeom>
+          <a:noFill/>
+        </p:spPr>
+        <p:txBody>
+          <a:bodyPr wrap="square" anchor="ctr">
+            <a:spAutoFit/>
+          </a:bodyPr>
+          <a:lstStyle/>
+          <a:p>
+            <a:pPr algn="ctr"/>
+            <a:r>
+              <a:rPr sz="1800" b="0">
+                <a:solidFill>
+                  <a:srgbClr val="FFFFFF"/>
+                </a:solidFill>
+                <a:latin typeface="Calibri"/>
+              </a:rPr>
+              <a:t>🔧</a:t>
+            </a:r>
+          </a:p>
+        </p:txBody>
+      </p:sp>
+      <p:sp>
+        <p:nvSpPr>
+          <p:cNvPr id="55" name="TextBox 54"/>
+          <p:cNvSpPr txBox="1"/>
+          <p:nvPr/>
+        </p:nvSpPr>
+        <p:spPr>
+          <a:xfrm>
+            <a:off x="9775544" y="3163880"/>
+            <a:ext cx="2169566" cy="230000"/>
+          </a:xfrm>
+          <a:prstGeom prst="rect">
+            <a:avLst/>
+          </a:prstGeom>
+          <a:noFill/>
+        </p:spPr>
+        <p:txBody>
+          <a:bodyPr wrap="square" anchor="ctr">
+            <a:spAutoFit/>
+          </a:bodyPr>
+          <a:lstStyle/>
+          <a:p>
+            <a:pPr algn="ctr"/>
+            <a:r>
+              <a:rPr sz="1100" b="1">
+                <a:solidFill>
+                  <a:srgbClr val="FFFFFF"/>
+                </a:solidFill>
+                <a:latin typeface="Calibri"/>
+              </a:rPr>
+              <a:t>Fault Detection</a:t>
+            </a:r>
+          </a:p>
+        </p:txBody>
+      </p:sp>
+      <p:sp>
+        <p:nvSpPr>
+          <p:cNvPr id="56" name="TextBox 55"/>
+          <p:cNvSpPr txBox="1"/>
+          <p:nvPr/>
+        </p:nvSpPr>
+        <p:spPr>
+          <a:xfrm>
+            <a:off x="9775544" y="3393880"/>
+            <a:ext cx="2169566" cy="1213680"/>
+          </a:xfrm>
+          <a:prstGeom prst="rect">
+            <a:avLst/>
+          </a:prstGeom>
+          <a:noFill/>
+        </p:spPr>
+        <p:txBody>
+          <a:bodyPr wrap="square" anchor="ctr">
+            <a:spAutoFit/>
+          </a:bodyPr>
+          <a:lstStyle/>
+          <a:p>
+            <a:pPr algn="ctr"/>
+            <a:r>
+              <a:rPr sz="900" b="0">
+                <a:solidFill>
+                  <a:srgbClr val="CCEEEE"/>
+                </a:solidFill>
+                <a:latin typeface="Calibri"/>
+              </a:rPr>
+              <a:t>Amber glow when a</a:t>
+            </a:r>
+          </a:p>
+          <a:p>
+            <a:pPr algn="ctr"/>
+            <a:r>
+              <a:rPr sz="900" b="0">
+                <a:solidFill>
+                  <a:srgbClr val="CCEEEE"/>
+                </a:solidFill>
+                <a:latin typeface="Calibri"/>
+              </a:rPr>
+              <a:t>device shows unusual</a:t>
+            </a:r>
+          </a:p>
+          <a:p>
+            <a:pPr algn="ctr"/>
+            <a:r>
+              <a:rPr sz="900" b="0">
+                <a:solidFill>
+                  <a:srgbClr val="CCEEEE"/>
+                </a:solidFill>
+                <a:latin typeface="Calibri"/>
+              </a:rPr>
+              <a:t>power behaviour</a:t>
+            </a:r>
+          </a:p>
+        </p:txBody>
+      </p:sp>
+      <p:sp>
+        <p:nvSpPr>
+          <p:cNvPr id="57" name="Rectangle 56"/>
+          <p:cNvSpPr/>
+          <p:nvPr/>
+        </p:nvSpPr>
+        <p:spPr>
+          <a:xfrm>
+            <a:off x="182880" y="4759960"/>
+            <a:ext cx="2291486" cy="1945640"/>
+          </a:xfrm>
+          <a:prstGeom prst="roundRect">
+            <a:avLst>
+              <a:gd name="adj" fmla="val 30000"/>
+            </a:avLst>
+          </a:prstGeom>
+          <a:solidFill>
+            <a:srgbClr val="0A4A4A"/>
+          </a:solidFill>
+          <a:ln w="9144">
+            <a:solidFill>
+              <a:srgbClr val="1A6B6B"/>
+            </a:solidFill>
+          </a:ln>
+        </p:spPr>
+        <p:style>
+          <a:lnRef idx="1">
+            <a:schemeClr val="accent1"/>
+          </a:lnRef>
+          <a:fillRef idx="3">
+            <a:schemeClr val="accent1"/>
+          </a:fillRef>
+          <a:effectRef idx="2">
+            <a:schemeClr val="accent1"/>
+          </a:effectRef>
+          <a:fontRef idx="minor">
+            <a:schemeClr val="lt1"/>
+          </a:fontRef>
+        </p:style>
+        <p:txBody>
+          <a:bodyPr rtlCol="0" anchor="ctr"/>
+          <a:lstStyle/>
+          <a:p>
+            <a:pPr algn="ctr"/>
+          </a:p>
+        </p:txBody>
+      </p:sp>
+      <p:sp>
+        <p:nvSpPr>
+          <p:cNvPr id="58" name="Oval 57"/>
+          <p:cNvSpPr/>
+          <p:nvPr/>
+        </p:nvSpPr>
+        <p:spPr>
+          <a:xfrm>
+            <a:off x="1176223" y="4836160"/>
+            <a:ext cx="304800" cy="304800"/>
+          </a:xfrm>
+          <a:prstGeom prst="ellipse">
+            <a:avLst/>
+          </a:prstGeom>
+          <a:solidFill>
+            <a:srgbClr val="48CAE4"/>
+          </a:solidFill>
+          <a:ln>
+            <a:noFill/>
+          </a:ln>
+        </p:spPr>
+        <p:style>
+          <a:lnRef idx="1">
+            <a:schemeClr val="accent1"/>
+          </a:lnRef>
+          <a:fillRef idx="3">
+            <a:schemeClr val="accent1"/>
+          </a:fillRef>
+          <a:effectRef idx="2">
+            <a:schemeClr val="accent1"/>
+          </a:effectRef>
+          <a:fontRef idx="minor">
+            <a:schemeClr val="lt1"/>
+          </a:fontRef>
+        </p:style>
+        <p:txBody>
+          <a:bodyPr rtlCol="0" anchor="ctr"/>
+          <a:lstStyle/>
+          <a:p>
+            <a:pPr algn="ctr"/>
+          </a:p>
+        </p:txBody>
+      </p:sp>
+      <p:sp>
+        <p:nvSpPr>
+          <p:cNvPr id="59" name="TextBox 58"/>
+          <p:cNvSpPr txBox="1"/>
+          <p:nvPr/>
+        </p:nvSpPr>
+        <p:spPr>
+          <a:xfrm>
+            <a:off x="1176223" y="4836160"/>
+            <a:ext cx="304800" cy="304800"/>
+          </a:xfrm>
+          <a:prstGeom prst="rect">
+            <a:avLst/>
+          </a:prstGeom>
+          <a:noFill/>
+        </p:spPr>
+        <p:txBody>
+          <a:bodyPr wrap="square" anchor="ctr">
+            <a:spAutoFit/>
+          </a:bodyPr>
+          <a:lstStyle/>
+          <a:p>
+            <a:pPr algn="ctr"/>
+            <a:r>
+              <a:rPr sz="1800" b="0">
+                <a:solidFill>
+                  <a:srgbClr val="FFFFFF"/>
+                </a:solidFill>
+                <a:latin typeface="Calibri"/>
+              </a:rPr>
+              <a:t>🌛</a:t>
+            </a:r>
+          </a:p>
+        </p:txBody>
+      </p:sp>
+      <p:sp>
+        <p:nvSpPr>
+          <p:cNvPr id="60" name="TextBox 59"/>
+          <p:cNvSpPr txBox="1"/>
+          <p:nvPr/>
+        </p:nvSpPr>
+        <p:spPr>
+          <a:xfrm>
+            <a:off x="243840" y="5200960"/>
+            <a:ext cx="2169566" cy="230000"/>
+          </a:xfrm>
+          <a:prstGeom prst="rect">
+            <a:avLst/>
+          </a:prstGeom>
+          <a:noFill/>
+        </p:spPr>
+        <p:txBody>
+          <a:bodyPr wrap="square" anchor="ctr">
+            <a:spAutoFit/>
+          </a:bodyPr>
+          <a:lstStyle/>
+          <a:p>
+            <a:pPr algn="ctr"/>
+            <a:r>
+              <a:rPr sz="1100" b="1">
+                <a:solidFill>
+                  <a:srgbClr val="FFFFFF"/>
+                </a:solidFill>
+                <a:latin typeface="Calibri"/>
+              </a:rPr>
+              <a:t>Sleep Mode</a:t>
+            </a:r>
+          </a:p>
+        </p:txBody>
+      </p:sp>
+      <p:sp>
+        <p:nvSpPr>
+          <p:cNvPr id="61" name="TextBox 60"/>
+          <p:cNvSpPr txBox="1"/>
+          <p:nvPr/>
+        </p:nvSpPr>
+        <p:spPr>
+          <a:xfrm>
+            <a:off x="243840" y="5430960"/>
+            <a:ext cx="2169566" cy="1213680"/>
+          </a:xfrm>
+          <a:prstGeom prst="rect">
+            <a:avLst/>
+          </a:prstGeom>
+          <a:noFill/>
+        </p:spPr>
+        <p:txBody>
+          <a:bodyPr wrap="square" anchor="ctr">
+            <a:spAutoFit/>
+          </a:bodyPr>
+          <a:lstStyle/>
+          <a:p>
+            <a:pPr algn="ctr"/>
+            <a:r>
+              <a:rPr sz="900" b="0">
+                <a:solidFill>
+                  <a:srgbClr val="CCEEEE"/>
+                </a:solidFill>
+                <a:latin typeface="Calibri"/>
+              </a:rPr>
+              <a:t>All standby devices</a:t>
+            </a:r>
+          </a:p>
+          <a:p>
+            <a:pPr algn="ctr"/>
+            <a:r>
+              <a:rPr sz="900" b="0">
+                <a:solidFill>
+                  <a:srgbClr val="CCEEEE"/>
+                </a:solidFill>
+                <a:latin typeface="Calibri"/>
+              </a:rPr>
+              <a:t>power down quietly</a:t>
+            </a:r>
+          </a:p>
+          <a:p>
+            <a:pPr algn="ctr"/>
+            <a:r>
+              <a:rPr sz="900" b="0">
+                <a:solidFill>
+                  <a:srgbClr val="CCEEEE"/>
+                </a:solidFill>
+                <a:latin typeface="Calibri"/>
+              </a:rPr>
+              <a:t>at your bedtime</a:t>
+            </a:r>
+          </a:p>
+        </p:txBody>
+      </p:sp>
+      <p:sp>
+        <p:nvSpPr>
+          <p:cNvPr id="62" name="Rectangle 61"/>
+          <p:cNvSpPr/>
+          <p:nvPr/>
+        </p:nvSpPr>
+        <p:spPr>
+          <a:xfrm>
+            <a:off x="2565806" y="4759960"/>
+            <a:ext cx="2291486" cy="1945640"/>
+          </a:xfrm>
+          <a:prstGeom prst="roundRect">
+            <a:avLst>
+              <a:gd name="adj" fmla="val 30000"/>
+            </a:avLst>
+          </a:prstGeom>
+          <a:solidFill>
+            <a:srgbClr val="0A4A4A"/>
+          </a:solidFill>
+          <a:ln w="9144">
+            <a:solidFill>
+              <a:srgbClr val="1A6B6B"/>
+            </a:solidFill>
+          </a:ln>
+        </p:spPr>
+        <p:style>
+          <a:lnRef idx="1">
+            <a:schemeClr val="accent1"/>
+          </a:lnRef>
+          <a:fillRef idx="3">
+            <a:schemeClr val="accent1"/>
+          </a:fillRef>
+          <a:effectRef idx="2">
+            <a:schemeClr val="accent1"/>
+          </a:effectRef>
+          <a:fontRef idx="minor">
+            <a:schemeClr val="lt1"/>
+          </a:fontRef>
+        </p:style>
+        <p:txBody>
+          <a:bodyPr rtlCol="0" anchor="ctr"/>
+          <a:lstStyle/>
+          <a:p>
+            <a:pPr algn="ctr"/>
+          </a:p>
+        </p:txBody>
+      </p:sp>
+      <p:sp>
+        <p:nvSpPr>
+          <p:cNvPr id="63" name="Oval 62"/>
+          <p:cNvSpPr/>
+          <p:nvPr/>
+        </p:nvSpPr>
+        <p:spPr>
+          <a:xfrm>
+            <a:off x="3559149" y="4836160"/>
+            <a:ext cx="304800" cy="304800"/>
+          </a:xfrm>
+          <a:prstGeom prst="ellipse">
+            <a:avLst/>
+          </a:prstGeom>
+          <a:solidFill>
+            <a:srgbClr val="48CAE4"/>
+          </a:solidFill>
+          <a:ln>
+            <a:noFill/>
+          </a:ln>
+        </p:spPr>
+        <p:style>
+          <a:lnRef idx="1">
+            <a:schemeClr val="accent1"/>
+          </a:lnRef>
+          <a:fillRef idx="3">
+            <a:schemeClr val="accent1"/>
+          </a:fillRef>
+          <a:effectRef idx="2">
+            <a:schemeClr val="accent1"/>
+          </a:effectRef>
+          <a:fontRef idx="minor">
+            <a:schemeClr val="lt1"/>
+          </a:fontRef>
+        </p:style>
+        <p:txBody>
+          <a:bodyPr rtlCol="0" anchor="ctr"/>
+          <a:lstStyle/>
+          <a:p>
+            <a:pPr algn="ctr"/>
+          </a:p>
+        </p:txBody>
+      </p:sp>
+      <p:sp>
+        <p:nvSpPr>
+          <p:cNvPr id="64" name="TextBox 63"/>
+          <p:cNvSpPr txBox="1"/>
+          <p:nvPr/>
+        </p:nvSpPr>
+        <p:spPr>
+          <a:xfrm>
+            <a:off x="3559149" y="4836160"/>
+            <a:ext cx="304800" cy="304800"/>
+          </a:xfrm>
+          <a:prstGeom prst="rect">
+            <a:avLst/>
+          </a:prstGeom>
+          <a:noFill/>
+        </p:spPr>
+        <p:txBody>
+          <a:bodyPr wrap="square" anchor="ctr">
+            <a:spAutoFit/>
+          </a:bodyPr>
+          <a:lstStyle/>
+          <a:p>
+            <a:pPr algn="ctr"/>
+            <a:r>
+              <a:rPr sz="1800" b="0">
+                <a:solidFill>
+                  <a:srgbClr val="FFFFFF"/>
+                </a:solidFill>
+                <a:latin typeface="Calibri"/>
+              </a:rPr>
+              <a:t>📊</a:t>
+            </a:r>
+          </a:p>
+        </p:txBody>
+      </p:sp>
+      <p:sp>
+        <p:nvSpPr>
+          <p:cNvPr id="65" name="TextBox 64"/>
+          <p:cNvSpPr txBox="1"/>
+          <p:nvPr/>
+        </p:nvSpPr>
+        <p:spPr>
+          <a:xfrm>
+            <a:off x="2626766" y="5200960"/>
+            <a:ext cx="2169566" cy="230000"/>
+          </a:xfrm>
+          <a:prstGeom prst="rect">
+            <a:avLst/>
+          </a:prstGeom>
+          <a:noFill/>
+        </p:spPr>
+        <p:txBody>
+          <a:bodyPr wrap="square" anchor="ctr">
+            <a:spAutoFit/>
+          </a:bodyPr>
+          <a:lstStyle/>
+          <a:p>
+            <a:pPr algn="ctr"/>
+            <a:r>
+              <a:rPr sz="1100" b="1">
+                <a:solidFill>
+                  <a:srgbClr val="FFFFFF"/>
+                </a:solidFill>
+                <a:latin typeface="Calibri"/>
+              </a:rPr>
+              <a:t>Budget Tracking</a:t>
+            </a:r>
+          </a:p>
+        </p:txBody>
+      </p:sp>
+      <p:sp>
+        <p:nvSpPr>
+          <p:cNvPr id="66" name="TextBox 65"/>
+          <p:cNvSpPr txBox="1"/>
+          <p:nvPr/>
+        </p:nvSpPr>
+        <p:spPr>
+          <a:xfrm>
+            <a:off x="2626766" y="5430960"/>
+            <a:ext cx="2169566" cy="1213680"/>
+          </a:xfrm>
+          <a:prstGeom prst="rect">
+            <a:avLst/>
+          </a:prstGeom>
+          <a:noFill/>
+        </p:spPr>
+        <p:txBody>
+          <a:bodyPr wrap="square" anchor="ctr">
+            <a:spAutoFit/>
+          </a:bodyPr>
+          <a:lstStyle/>
+          <a:p>
+            <a:pPr algn="ctr"/>
+            <a:r>
+              <a:rPr sz="900" b="0">
+                <a:solidFill>
+                  <a:srgbClr val="CCEEEE"/>
+                </a:solidFill>
+                <a:latin typeface="Calibri"/>
+              </a:rPr>
+              <a:t>Monitors daily spend</a:t>
+            </a:r>
+          </a:p>
+          <a:p>
+            <a:pPr algn="ctr"/>
+            <a:r>
+              <a:rPr sz="900" b="0">
+                <a:solidFill>
+                  <a:srgbClr val="CCEEEE"/>
+                </a:solidFill>
+                <a:latin typeface="Calibri"/>
+              </a:rPr>
+              <a:t>vs. energy budget;</a:t>
+            </a:r>
+          </a:p>
+          <a:p>
+            <a:pPr algn="ctr"/>
+            <a:r>
+              <a:rPr sz="900" b="0">
+                <a:solidFill>
+                  <a:srgbClr val="CCEEEE"/>
+                </a:solidFill>
+                <a:latin typeface="Calibri"/>
+              </a:rPr>
+              <a:t>shows calm review</a:t>
+            </a:r>
+          </a:p>
+        </p:txBody>
+      </p:sp>
+      <p:sp>
+        <p:nvSpPr>
+          <p:cNvPr id="67" name="Rectangle 66"/>
+          <p:cNvSpPr/>
+          <p:nvPr/>
+        </p:nvSpPr>
+        <p:spPr>
+          <a:xfrm>
+            <a:off x="4948732" y="4759960"/>
+            <a:ext cx="2291486" cy="1945640"/>
+          </a:xfrm>
+          <a:prstGeom prst="roundRect">
+            <a:avLst>
+              <a:gd name="adj" fmla="val 30000"/>
+            </a:avLst>
+          </a:prstGeom>
+          <a:solidFill>
+            <a:srgbClr val="0A4A4A"/>
+          </a:solidFill>
+          <a:ln w="9144">
+            <a:solidFill>
+              <a:srgbClr val="1A6B6B"/>
+            </a:solidFill>
+          </a:ln>
+        </p:spPr>
+        <p:style>
+          <a:lnRef idx="1">
+            <a:schemeClr val="accent1"/>
+          </a:lnRef>
+          <a:fillRef idx="3">
+            <a:schemeClr val="accent1"/>
+          </a:fillRef>
+          <a:effectRef idx="2">
+            <a:schemeClr val="accent1"/>
+          </a:effectRef>
+          <a:fontRef idx="minor">
+            <a:schemeClr val="lt1"/>
+          </a:fontRef>
+        </p:style>
+        <p:txBody>
+          <a:bodyPr rtlCol="0" anchor="ctr"/>
+          <a:lstStyle/>
+          <a:p>
+            <a:pPr algn="ctr"/>
+          </a:p>
+        </p:txBody>
+      </p:sp>
+      <p:sp>
+        <p:nvSpPr>
+          <p:cNvPr id="68" name="Oval 67"/>
+          <p:cNvSpPr/>
+          <p:nvPr/>
+        </p:nvSpPr>
+        <p:spPr>
+          <a:xfrm>
+            <a:off x="5942075" y="4836160"/>
+            <a:ext cx="304800" cy="304800"/>
+          </a:xfrm>
+          <a:prstGeom prst="ellipse">
+            <a:avLst/>
+          </a:prstGeom>
+          <a:solidFill>
+            <a:srgbClr val="48CAE4"/>
+          </a:solidFill>
+          <a:ln>
+            <a:noFill/>
+          </a:ln>
+        </p:spPr>
+        <p:style>
+          <a:lnRef idx="1">
+            <a:schemeClr val="accent1"/>
+          </a:lnRef>
+          <a:fillRef idx="3">
+            <a:schemeClr val="accent1"/>
+          </a:fillRef>
+          <a:effectRef idx="2">
+            <a:schemeClr val="accent1"/>
+          </a:effectRef>
+          <a:fontRef idx="minor">
+            <a:schemeClr val="lt1"/>
+          </a:fontRef>
+        </p:style>
+        <p:txBody>
+          <a:bodyPr rtlCol="0" anchor="ctr"/>
+          <a:lstStyle/>
+          <a:p>
+            <a:pPr algn="ctr"/>
+          </a:p>
+        </p:txBody>
+      </p:sp>
+      <p:sp>
+        <p:nvSpPr>
+          <p:cNvPr id="69" name="TextBox 68"/>
+          <p:cNvSpPr txBox="1"/>
+          <p:nvPr/>
+        </p:nvSpPr>
+        <p:spPr>
+          <a:xfrm>
+            <a:off x="5942075" y="4836160"/>
+            <a:ext cx="304800" cy="304800"/>
+          </a:xfrm>
+          <a:prstGeom prst="rect">
+            <a:avLst/>
+          </a:prstGeom>
+          <a:noFill/>
+        </p:spPr>
+        <p:txBody>
+          <a:bodyPr wrap="square" anchor="ctr">
+            <a:spAutoFit/>
+          </a:bodyPr>
+          <a:lstStyle/>
+          <a:p>
+            <a:pPr algn="ctr"/>
+            <a:r>
+              <a:rPr sz="1800" b="0">
+                <a:solidFill>
+                  <a:srgbClr val="FFFFFF"/>
+                </a:solidFill>
+                <a:latin typeface="Calibri"/>
+              </a:rPr>
+              <a:t>🔍</a:t>
+            </a:r>
+          </a:p>
+        </p:txBody>
+      </p:sp>
+      <p:sp>
+        <p:nvSpPr>
+          <p:cNvPr id="70" name="TextBox 69"/>
+          <p:cNvSpPr txBox="1"/>
+          <p:nvPr/>
+        </p:nvSpPr>
+        <p:spPr>
+          <a:xfrm>
+            <a:off x="5009692" y="5200960"/>
+            <a:ext cx="2169566" cy="230000"/>
+          </a:xfrm>
+          <a:prstGeom prst="rect">
+            <a:avLst/>
+          </a:prstGeom>
+          <a:noFill/>
+        </p:spPr>
+        <p:txBody>
+          <a:bodyPr wrap="square" anchor="ctr">
+            <a:spAutoFit/>
+          </a:bodyPr>
+          <a:lstStyle/>
+          <a:p>
+            <a:pPr algn="ctr"/>
+            <a:r>
+              <a:rPr sz="1100" b="1">
+                <a:solidFill>
+                  <a:srgbClr val="FFFFFF"/>
+                </a:solidFill>
+                <a:latin typeface="Calibri"/>
+              </a:rPr>
+              <a:t>Device Discovery</a:t>
+            </a:r>
+          </a:p>
+        </p:txBody>
+      </p:sp>
+      <p:sp>
+        <p:nvSpPr>
+          <p:cNvPr id="71" name="TextBox 70"/>
+          <p:cNvSpPr txBox="1"/>
+          <p:nvPr/>
+        </p:nvSpPr>
+        <p:spPr>
+          <a:xfrm>
+            <a:off x="5009692" y="5430960"/>
+            <a:ext cx="2169566" cy="1213680"/>
+          </a:xfrm>
+          <a:prstGeom prst="rect">
+            <a:avLst/>
+          </a:prstGeom>
+          <a:noFill/>
+        </p:spPr>
+        <p:txBody>
+          <a:bodyPr wrap="square" anchor="ctr">
+            <a:spAutoFit/>
+          </a:bodyPr>
+          <a:lstStyle/>
+          <a:p>
+            <a:pPr algn="ctr"/>
+            <a:r>
+              <a:rPr sz="900" b="0">
+                <a:solidFill>
+                  <a:srgbClr val="CCEEEE"/>
+                </a:solidFill>
+                <a:latin typeface="Calibri"/>
+              </a:rPr>
+              <a:t>Auto-detects new</a:t>
+            </a:r>
+          </a:p>
+          <a:p>
+            <a:pPr algn="ctr"/>
+            <a:r>
+              <a:rPr sz="900" b="0">
+                <a:solidFill>
+                  <a:srgbClr val="CCEEEE"/>
+                </a:solidFill>
+                <a:latin typeface="Calibri"/>
+              </a:rPr>
+              <a:t>IoT devices added</a:t>
+            </a:r>
+          </a:p>
+          <a:p>
+            <a:pPr algn="ctr"/>
+            <a:r>
+              <a:rPr sz="900" b="0">
+                <a:solidFill>
+                  <a:srgbClr val="CCEEEE"/>
+                </a:solidFill>
+                <a:latin typeface="Calibri"/>
+              </a:rPr>
+              <a:t>to the home network</a:t>
+            </a:r>
+          </a:p>
+        </p:txBody>
+      </p:sp>
+      <p:sp>
+        <p:nvSpPr>
+          <p:cNvPr id="72" name="Rectangle 71"/>
+          <p:cNvSpPr/>
+          <p:nvPr/>
+        </p:nvSpPr>
+        <p:spPr>
+          <a:xfrm>
+            <a:off x="7331658" y="4759960"/>
+            <a:ext cx="2291486" cy="1945640"/>
+          </a:xfrm>
+          <a:prstGeom prst="roundRect">
+            <a:avLst>
+              <a:gd name="adj" fmla="val 30000"/>
+            </a:avLst>
+          </a:prstGeom>
+          <a:solidFill>
+            <a:srgbClr val="0A4A4A"/>
+          </a:solidFill>
+          <a:ln w="9144">
+            <a:solidFill>
+              <a:srgbClr val="1A6B6B"/>
+            </a:solidFill>
+          </a:ln>
+        </p:spPr>
+        <p:style>
+          <a:lnRef idx="1">
+            <a:schemeClr val="accent1"/>
+          </a:lnRef>
+          <a:fillRef idx="3">
+            <a:schemeClr val="accent1"/>
+          </a:fillRef>
+          <a:effectRef idx="2">
+            <a:schemeClr val="accent1"/>
+          </a:effectRef>
+          <a:fontRef idx="minor">
+            <a:schemeClr val="lt1"/>
+          </a:fontRef>
+        </p:style>
+        <p:txBody>
+          <a:bodyPr rtlCol="0" anchor="ctr"/>
+          <a:lstStyle/>
+          <a:p>
+            <a:pPr algn="ctr"/>
+          </a:p>
+        </p:txBody>
+      </p:sp>
+      <p:sp>
+        <p:nvSpPr>
+          <p:cNvPr id="73" name="Oval 72"/>
+          <p:cNvSpPr/>
+          <p:nvPr/>
+        </p:nvSpPr>
+        <p:spPr>
+          <a:xfrm>
+            <a:off x="8325001" y="4836160"/>
+            <a:ext cx="304800" cy="304800"/>
+          </a:xfrm>
+          <a:prstGeom prst="ellipse">
+            <a:avLst/>
+          </a:prstGeom>
+          <a:solidFill>
+            <a:srgbClr val="48CAE4"/>
+          </a:solidFill>
+          <a:ln>
+            <a:noFill/>
+          </a:ln>
+        </p:spPr>
+        <p:style>
+          <a:lnRef idx="1">
+            <a:schemeClr val="accent1"/>
+          </a:lnRef>
+          <a:fillRef idx="3">
+            <a:schemeClr val="accent1"/>
+          </a:fillRef>
+          <a:effectRef idx="2">
+            <a:schemeClr val="accent1"/>
+          </a:effectRef>
+          <a:fontRef idx="minor">
+            <a:schemeClr val="lt1"/>
+          </a:fontRef>
+        </p:style>
+        <p:txBody>
+          <a:bodyPr rtlCol="0" anchor="ctr"/>
+          <a:lstStyle/>
+          <a:p>
+            <a:pPr algn="ctr"/>
+          </a:p>
+        </p:txBody>
+      </p:sp>
+      <p:sp>
+        <p:nvSpPr>
+          <p:cNvPr id="74" name="TextBox 73"/>
+          <p:cNvSpPr txBox="1"/>
+          <p:nvPr/>
+        </p:nvSpPr>
+        <p:spPr>
+          <a:xfrm>
+            <a:off x="8325001" y="4836160"/>
+            <a:ext cx="304800" cy="304800"/>
+          </a:xfrm>
+          <a:prstGeom prst="rect">
+            <a:avLst/>
+          </a:prstGeom>
+          <a:noFill/>
+        </p:spPr>
+        <p:txBody>
+          <a:bodyPr wrap="square" anchor="ctr">
+            <a:spAutoFit/>
+          </a:bodyPr>
+          <a:lstStyle/>
+          <a:p>
+            <a:pPr algn="ctr"/>
+            <a:r>
+              <a:rPr sz="1800" b="0">
+                <a:solidFill>
+                  <a:srgbClr val="FFFFFF"/>
+                </a:solidFill>
+                <a:latin typeface="Calibri"/>
+              </a:rPr>
+              <a:t>🌍</a:t>
+            </a:r>
+          </a:p>
+        </p:txBody>
+      </p:sp>
+      <p:sp>
+        <p:nvSpPr>
+          <p:cNvPr id="75" name="TextBox 74"/>
+          <p:cNvSpPr txBox="1"/>
+          <p:nvPr/>
+        </p:nvSpPr>
+        <p:spPr>
+          <a:xfrm>
+            <a:off x="7392618" y="5200960"/>
+            <a:ext cx="2169566" cy="230000"/>
+          </a:xfrm>
+          <a:prstGeom prst="rect">
+            <a:avLst/>
+          </a:prstGeom>
+          <a:noFill/>
+        </p:spPr>
+        <p:txBody>
+          <a:bodyPr wrap="square" anchor="ctr">
+            <a:spAutoFit/>
+          </a:bodyPr>
+          <a:lstStyle/>
+          <a:p>
+            <a:pPr algn="ctr"/>
+            <a:r>
+              <a:rPr sz="1100" b="1">
+                <a:solidFill>
+                  <a:srgbClr val="FFFFFF"/>
+                </a:solidFill>
+                <a:latin typeface="Calibri"/>
+              </a:rPr>
+              <a:t>Carbon Monitor</a:t>
+            </a:r>
+          </a:p>
+        </p:txBody>
+      </p:sp>
+      <p:sp>
+        <p:nvSpPr>
+          <p:cNvPr id="76" name="TextBox 75"/>
+          <p:cNvSpPr txBox="1"/>
+          <p:nvPr/>
+        </p:nvSpPr>
+        <p:spPr>
+          <a:xfrm>
+            <a:off x="7392618" y="5430960"/>
+            <a:ext cx="2169566" cy="1213680"/>
+          </a:xfrm>
+          <a:prstGeom prst="rect">
+            <a:avLst/>
+          </a:prstGeom>
+          <a:noFill/>
+        </p:spPr>
+        <p:txBody>
+          <a:bodyPr wrap="square" anchor="ctr">
+            <a:spAutoFit/>
+          </a:bodyPr>
+          <a:lstStyle/>
+          <a:p>
+            <a:pPr algn="ctr"/>
+            <a:r>
+              <a:rPr sz="900" b="0">
+                <a:solidFill>
+                  <a:srgbClr val="CCEEEE"/>
+                </a:solidFill>
+                <a:latin typeface="Calibri"/>
+              </a:rPr>
+              <a:t>Tracks household</a:t>
+            </a:r>
+          </a:p>
+          <a:p>
+            <a:pPr algn="ctr"/>
+            <a:r>
+              <a:rPr sz="900" b="0">
+                <a:solidFill>
+                  <a:srgbClr val="CCEEEE"/>
+                </a:solidFill>
+                <a:latin typeface="Calibri"/>
+              </a:rPr>
+              <a:t>CO₂e daily and shows</a:t>
+            </a:r>
+          </a:p>
+          <a:p>
+            <a:pPr algn="ctr"/>
+            <a:r>
+              <a:rPr sz="900" b="0">
+                <a:solidFill>
+                  <a:srgbClr val="CCEEEE"/>
+                </a:solidFill>
+                <a:latin typeface="Calibri"/>
+              </a:rPr>
+              <a:t>a weekly trend chart</a:t>
+            </a:r>
+          </a:p>
+        </p:txBody>
+      </p:sp>
+      <p:sp>
+        <p:nvSpPr>
+          <p:cNvPr id="77" name="Rectangle 76"/>
+          <p:cNvSpPr/>
+          <p:nvPr/>
+        </p:nvSpPr>
+        <p:spPr>
+          <a:xfrm>
+            <a:off x="9714584" y="4759960"/>
+            <a:ext cx="2291486" cy="1945640"/>
+          </a:xfrm>
+          <a:prstGeom prst="roundRect">
+            <a:avLst>
+              <a:gd name="adj" fmla="val 30000"/>
+            </a:avLst>
+          </a:prstGeom>
+          <a:solidFill>
+            <a:srgbClr val="0A4A4A"/>
+          </a:solidFill>
+          <a:ln w="9144">
+            <a:solidFill>
+              <a:srgbClr val="1A6B6B"/>
+            </a:solidFill>
+          </a:ln>
+        </p:spPr>
+        <p:style>
+          <a:lnRef idx="1">
+            <a:schemeClr val="accent1"/>
+          </a:lnRef>
+          <a:fillRef idx="3">
+            <a:schemeClr val="accent1"/>
+          </a:fillRef>
+          <a:effectRef idx="2">
+            <a:schemeClr val="accent1"/>
+          </a:effectRef>
+          <a:fontRef idx="minor">
+            <a:schemeClr val="lt1"/>
+          </a:fontRef>
+        </p:style>
+        <p:txBody>
+          <a:bodyPr rtlCol="0" anchor="ctr"/>
+          <a:lstStyle/>
+          <a:p>
+            <a:pPr algn="ctr"/>
+          </a:p>
+        </p:txBody>
+      </p:sp>
+      <p:sp>
+        <p:nvSpPr>
+          <p:cNvPr id="78" name="Oval 77"/>
+          <p:cNvSpPr/>
+          <p:nvPr/>
+        </p:nvSpPr>
+        <p:spPr>
+          <a:xfrm>
+            <a:off x="10707927" y="4836160"/>
+            <a:ext cx="304800" cy="304800"/>
+          </a:xfrm>
+          <a:prstGeom prst="ellipse">
+            <a:avLst/>
+          </a:prstGeom>
+          <a:solidFill>
+            <a:srgbClr val="48CAE4"/>
+          </a:solidFill>
+          <a:ln>
+            <a:noFill/>
+          </a:ln>
+        </p:spPr>
+        <p:style>
+          <a:lnRef idx="1">
+            <a:schemeClr val="accent1"/>
+          </a:lnRef>
+          <a:fillRef idx="3">
+            <a:schemeClr val="accent1"/>
+          </a:fillRef>
+          <a:effectRef idx="2">
+            <a:schemeClr val="accent1"/>
+          </a:effectRef>
+          <a:fontRef idx="minor">
+            <a:schemeClr val="lt1"/>
+          </a:fontRef>
+        </p:style>
+        <p:txBody>
+          <a:bodyPr rtlCol="0" anchor="ctr"/>
+          <a:lstStyle/>
+          <a:p>
+            <a:pPr algn="ctr"/>
+          </a:p>
+        </p:txBody>
+      </p:sp>
+      <p:sp>
+        <p:nvSpPr>
+          <p:cNvPr id="79" name="TextBox 78"/>
+          <p:cNvSpPr txBox="1"/>
+          <p:nvPr/>
+        </p:nvSpPr>
+        <p:spPr>
+          <a:xfrm>
+            <a:off x="10707927" y="4836160"/>
+            <a:ext cx="304800" cy="304800"/>
+          </a:xfrm>
+          <a:prstGeom prst="rect">
+            <a:avLst/>
+          </a:prstGeom>
+          <a:noFill/>
+        </p:spPr>
+        <p:txBody>
+          <a:bodyPr wrap="square" anchor="ctr">
+            <a:spAutoFit/>
+          </a:bodyPr>
+          <a:lstStyle/>
+          <a:p>
+            <a:pPr algn="ctr"/>
+            <a:r>
+              <a:rPr sz="1800" b="0">
+                <a:solidFill>
+                  <a:srgbClr val="FFFFFF"/>
+                </a:solidFill>
+                <a:latin typeface="Calibri"/>
+              </a:rPr>
+              <a:t>☀</a:t>
+            </a:r>
+          </a:p>
+        </p:txBody>
+      </p:sp>
+      <p:sp>
+        <p:nvSpPr>
+          <p:cNvPr id="80" name="TextBox 79"/>
+          <p:cNvSpPr txBox="1"/>
+          <p:nvPr/>
+        </p:nvSpPr>
+        <p:spPr>
+          <a:xfrm>
+            <a:off x="9775544" y="5200960"/>
+            <a:ext cx="2169566" cy="230000"/>
+          </a:xfrm>
+          <a:prstGeom prst="rect">
+            <a:avLst/>
+          </a:prstGeom>
+          <a:noFill/>
+        </p:spPr>
+        <p:txBody>
+          <a:bodyPr wrap="square" anchor="ctr">
+            <a:spAutoFit/>
+          </a:bodyPr>
+          <a:lstStyle/>
+          <a:p>
+            <a:pPr algn="ctr"/>
+            <a:r>
+              <a:rPr sz="1100" b="1">
+                <a:solidFill>
+                  <a:srgbClr val="FFFFFF"/>
+                </a:solidFill>
+                <a:latin typeface="Calibri"/>
+              </a:rPr>
+              <a:t>Morning Routine</a:t>
+            </a:r>
+          </a:p>
+        </p:txBody>
+      </p:sp>
+      <p:sp>
+        <p:nvSpPr>
+          <p:cNvPr id="81" name="TextBox 80"/>
+          <p:cNvSpPr txBox="1"/>
+          <p:nvPr/>
+        </p:nvSpPr>
+        <p:spPr>
+          <a:xfrm>
+            <a:off x="9775544" y="5430960"/>
+            <a:ext cx="2169566" cy="1213680"/>
+          </a:xfrm>
+          <a:prstGeom prst="rect">
+            <a:avLst/>
+          </a:prstGeom>
+          <a:noFill/>
+        </p:spPr>
+        <p:txBody>
+          <a:bodyPr wrap="square" anchor="ctr">
+            <a:spAutoFit/>
+          </a:bodyPr>
+          <a:lstStyle/>
+          <a:p>
+            <a:pPr algn="ctr"/>
+            <a:r>
+              <a:rPr sz="900" b="0">
+                <a:solidFill>
+                  <a:srgbClr val="CCEEEE"/>
+                </a:solidFill>
+                <a:latin typeface="Calibri"/>
+              </a:rPr>
+              <a:t>Orchestrated wake-up:</a:t>
+            </a:r>
+          </a:p>
+          <a:p>
+            <a:pPr algn="ctr"/>
+            <a:r>
+              <a:rPr sz="900" b="0">
+                <a:solidFill>
+                  <a:srgbClr val="CCEEEE"/>
+                </a:solidFill>
+                <a:latin typeface="Calibri"/>
+              </a:rPr>
+              <a:t>heater, kettle &amp; lights</a:t>
+            </a:r>
+          </a:p>
+          <a:p>
+            <a:pPr algn="ctr"/>
+            <a:r>
+              <a:rPr sz="900" b="0">
+                <a:solidFill>
+                  <a:srgbClr val="CCEEEE"/>
+                </a:solidFill>
+                <a:latin typeface="Calibri"/>
+              </a:rPr>
+              <a:t>all coordinated</a:t>
             </a:r>
           </a:p>
         </p:txBody>

</xml_diff>

<commit_message>
Add slide 17: student contribution roadmap infographic
</commit_message>
<xml_diff>
--- a/docs/IoT-GPT-Research-Presentation.pptx
+++ b/docs/IoT-GPT-Research-Presentation.pptx
@@ -21,6 +21,7 @@
     <p:sldId id="269" r:id="rId20"/>
     <p:sldId id="270" r:id="rId21"/>
     <p:sldId id="271" r:id="rId22"/>
+    <p:sldId id="272" r:id="rId23"/>
   </p:sldIdLst>
   <p:sldSz cx="12188952" cy="6858000" type="screen4x3"/>
   <p:notesSz cx="6858000" cy="9144000"/>
@@ -12269,6 +12270,4335 @@
                 <a:latin typeface="Calibri"/>
               </a:rPr>
               <a:t>all coordinated</a:t>
+            </a:r>
+          </a:p>
+        </p:txBody>
+      </p:sp>
+    </p:spTree>
+  </p:cSld>
+  <p:clrMapOvr>
+    <a:masterClrMapping/>
+  </p:clrMapOvr>
+</p:sld>
+</file>
+
+<file path=ppt/slides/slide17.xml><?xml version="1.0" encoding="utf-8"?>
+<p:sld xmlns:a="http://schemas.openxmlformats.org/drawingml/2006/main" xmlns:p="http://schemas.openxmlformats.org/presentationml/2006/main" xmlns:r="http://schemas.openxmlformats.org/officeDocument/2006/relationships">
+  <p:cSld>
+    <p:bg>
+      <p:bgPr>
+        <a:solidFill>
+          <a:srgbClr val="0D3B3B"/>
+        </a:solidFill>
+        <a:effectLst/>
+      </p:bgPr>
+    </p:bg>
+    <p:spTree>
+      <p:nvGrpSpPr>
+        <p:cNvPr id="1" name=""/>
+        <p:cNvGrpSpPr/>
+        <p:nvPr/>
+      </p:nvGrpSpPr>
+      <p:grpSpPr/>
+      <p:sp>
+        <p:nvSpPr>
+          <p:cNvPr id="2" name="Oval 1"/>
+          <p:cNvSpPr/>
+          <p:nvPr/>
+        </p:nvSpPr>
+        <p:spPr>
+          <a:xfrm>
+            <a:off x="9600000" y="-700000"/>
+            <a:ext cx="4800000" cy="4800000"/>
+          </a:xfrm>
+          <a:prstGeom prst="ellipse">
+            <a:avLst/>
+          </a:prstGeom>
+          <a:solidFill>
+            <a:srgbClr val="1A6B6B"/>
+          </a:solidFill>
+          <a:ln>
+            <a:noFill/>
+          </a:ln>
+        </p:spPr>
+        <p:style>
+          <a:lnRef idx="1">
+            <a:schemeClr val="accent1"/>
+          </a:lnRef>
+          <a:fillRef idx="3">
+            <a:schemeClr val="accent1"/>
+          </a:fillRef>
+          <a:effectRef idx="2">
+            <a:schemeClr val="accent1"/>
+          </a:effectRef>
+          <a:fontRef idx="minor">
+            <a:schemeClr val="lt1"/>
+          </a:fontRef>
+        </p:style>
+        <p:txBody>
+          <a:bodyPr rtlCol="0" anchor="ctr"/>
+          <a:lstStyle/>
+          <a:p>
+            <a:pPr algn="ctr"/>
+          </a:p>
+        </p:txBody>
+      </p:sp>
+      <p:sp>
+        <p:nvSpPr>
+          <p:cNvPr id="3" name="Oval 2"/>
+          <p:cNvSpPr/>
+          <p:nvPr/>
+        </p:nvSpPr>
+        <p:spPr>
+          <a:xfrm>
+            <a:off x="10400000" y="2500000"/>
+            <a:ext cx="3000000" cy="3000000"/>
+          </a:xfrm>
+          <a:prstGeom prst="ellipse">
+            <a:avLst/>
+          </a:prstGeom>
+          <a:solidFill>
+            <a:srgbClr val="0A4545"/>
+          </a:solidFill>
+          <a:ln>
+            <a:noFill/>
+          </a:ln>
+        </p:spPr>
+        <p:style>
+          <a:lnRef idx="1">
+            <a:schemeClr val="accent1"/>
+          </a:lnRef>
+          <a:fillRef idx="3">
+            <a:schemeClr val="accent1"/>
+          </a:fillRef>
+          <a:effectRef idx="2">
+            <a:schemeClr val="accent1"/>
+          </a:effectRef>
+          <a:fontRef idx="minor">
+            <a:schemeClr val="lt1"/>
+          </a:fontRef>
+        </p:style>
+        <p:txBody>
+          <a:bodyPr rtlCol="0" anchor="ctr"/>
+          <a:lstStyle/>
+          <a:p>
+            <a:pPr algn="ctr"/>
+          </a:p>
+        </p:txBody>
+      </p:sp>
+      <p:sp>
+        <p:nvSpPr>
+          <p:cNvPr id="4" name="Rectangle 3"/>
+          <p:cNvSpPr/>
+          <p:nvPr/>
+        </p:nvSpPr>
+        <p:spPr>
+          <a:xfrm>
+            <a:off x="182880" y="100000"/>
+            <a:ext cx="55000" cy="400000"/>
+          </a:xfrm>
+          <a:prstGeom prst="rect">
+            <a:avLst/>
+          </a:prstGeom>
+          <a:solidFill>
+            <a:srgbClr val="F4A261"/>
+          </a:solidFill>
+          <a:ln>
+            <a:noFill/>
+          </a:ln>
+        </p:spPr>
+        <p:style>
+          <a:lnRef idx="1">
+            <a:schemeClr val="accent1"/>
+          </a:lnRef>
+          <a:fillRef idx="3">
+            <a:schemeClr val="accent1"/>
+          </a:fillRef>
+          <a:effectRef idx="2">
+            <a:schemeClr val="accent1"/>
+          </a:effectRef>
+          <a:fontRef idx="minor">
+            <a:schemeClr val="lt1"/>
+          </a:fontRef>
+        </p:style>
+        <p:txBody>
+          <a:bodyPr rtlCol="0" anchor="ctr"/>
+          <a:lstStyle/>
+          <a:p>
+            <a:pPr algn="ctr"/>
+          </a:p>
+        </p:txBody>
+      </p:sp>
+      <p:sp>
+        <p:nvSpPr>
+          <p:cNvPr id="5" name="TextBox 4"/>
+          <p:cNvSpPr txBox="1"/>
+          <p:nvPr/>
+        </p:nvSpPr>
+        <p:spPr>
+          <a:xfrm>
+            <a:off x="292880" y="90000"/>
+            <a:ext cx="11323192" cy="510000"/>
+          </a:xfrm>
+          <a:prstGeom prst="rect">
+            <a:avLst/>
+          </a:prstGeom>
+          <a:noFill/>
+        </p:spPr>
+        <p:txBody>
+          <a:bodyPr wrap="square" anchor="ctr">
+            <a:spAutoFit/>
+          </a:bodyPr>
+          <a:lstStyle/>
+          <a:p>
+            <a:pPr algn="l"/>
+            <a:r>
+              <a:rPr sz="2600" b="1">
+                <a:solidFill>
+                  <a:srgbClr val="F4A261"/>
+                </a:solidFill>
+                <a:latin typeface="Calibri"/>
+              </a:rPr>
+              <a:t>Student Contribution Roadmap  |  How to Join the Research</a:t>
+            </a:r>
+          </a:p>
+        </p:txBody>
+      </p:sp>
+      <p:sp>
+        <p:nvSpPr>
+          <p:cNvPr id="6" name="TextBox 5"/>
+          <p:cNvSpPr txBox="1"/>
+          <p:nvPr/>
+        </p:nvSpPr>
+        <p:spPr>
+          <a:xfrm>
+            <a:off x="11488952" y="6498000"/>
+            <a:ext cx="600000" cy="260000"/>
+          </a:xfrm>
+          <a:prstGeom prst="rect">
+            <a:avLst/>
+          </a:prstGeom>
+          <a:noFill/>
+        </p:spPr>
+        <p:txBody>
+          <a:bodyPr wrap="square" anchor="ctr">
+            <a:spAutoFit/>
+          </a:bodyPr>
+          <a:lstStyle/>
+          <a:p>
+            <a:pPr algn="r"/>
+            <a:r>
+              <a:rPr sz="1100" b="0">
+                <a:solidFill>
+                  <a:srgbClr val="CCEEEE"/>
+                </a:solidFill>
+                <a:latin typeface="Calibri"/>
+              </a:rPr>
+              <a:t>17 / 17</a:t>
+            </a:r>
+          </a:p>
+        </p:txBody>
+      </p:sp>
+      <p:sp>
+        <p:nvSpPr>
+          <p:cNvPr id="7" name="Rectangle 6"/>
+          <p:cNvSpPr/>
+          <p:nvPr/>
+        </p:nvSpPr>
+        <p:spPr>
+          <a:xfrm>
+            <a:off x="182880" y="670000"/>
+            <a:ext cx="5861596" cy="2979000"/>
+          </a:xfrm>
+          <a:prstGeom prst="roundRect">
+            <a:avLst>
+              <a:gd name="adj" fmla="val 20000"/>
+            </a:avLst>
+          </a:prstGeom>
+          <a:solidFill>
+            <a:srgbClr val="0A4A4A"/>
+          </a:solidFill>
+          <a:ln w="9144">
+            <a:solidFill>
+              <a:srgbClr val="1A6B6B"/>
+            </a:solidFill>
+          </a:ln>
+        </p:spPr>
+        <p:style>
+          <a:lnRef idx="1">
+            <a:schemeClr val="accent1"/>
+          </a:lnRef>
+          <a:fillRef idx="3">
+            <a:schemeClr val="accent1"/>
+          </a:fillRef>
+          <a:effectRef idx="2">
+            <a:schemeClr val="accent1"/>
+          </a:effectRef>
+          <a:fontRef idx="minor">
+            <a:schemeClr val="lt1"/>
+          </a:fontRef>
+        </p:style>
+        <p:txBody>
+          <a:bodyPr rtlCol="0" anchor="ctr"/>
+          <a:lstStyle/>
+          <a:p>
+            <a:pPr algn="ctr"/>
+          </a:p>
+        </p:txBody>
+      </p:sp>
+      <p:sp>
+        <p:nvSpPr>
+          <p:cNvPr id="8" name="Rectangle 7"/>
+          <p:cNvSpPr/>
+          <p:nvPr/>
+        </p:nvSpPr>
+        <p:spPr>
+          <a:xfrm>
+            <a:off x="242880" y="730000"/>
+            <a:ext cx="50000" cy="280000"/>
+          </a:xfrm>
+          <a:prstGeom prst="rect">
+            <a:avLst/>
+          </a:prstGeom>
+          <a:solidFill>
+            <a:srgbClr val="F4A261"/>
+          </a:solidFill>
+          <a:ln>
+            <a:noFill/>
+          </a:ln>
+        </p:spPr>
+        <p:style>
+          <a:lnRef idx="1">
+            <a:schemeClr val="accent1"/>
+          </a:lnRef>
+          <a:fillRef idx="3">
+            <a:schemeClr val="accent1"/>
+          </a:fillRef>
+          <a:effectRef idx="2">
+            <a:schemeClr val="accent1"/>
+          </a:effectRef>
+          <a:fontRef idx="minor">
+            <a:schemeClr val="lt1"/>
+          </a:fontRef>
+        </p:style>
+        <p:txBody>
+          <a:bodyPr rtlCol="0" anchor="ctr"/>
+          <a:lstStyle/>
+          <a:p>
+            <a:pPr algn="ctr"/>
+          </a:p>
+        </p:txBody>
+      </p:sp>
+      <p:sp>
+        <p:nvSpPr>
+          <p:cNvPr id="9" name="Oval 8"/>
+          <p:cNvSpPr/>
+          <p:nvPr/>
+        </p:nvSpPr>
+        <p:spPr>
+          <a:xfrm>
+            <a:off x="242880" y="730000"/>
+            <a:ext cx="280000" cy="280000"/>
+          </a:xfrm>
+          <a:prstGeom prst="ellipse">
+            <a:avLst/>
+          </a:prstGeom>
+          <a:solidFill>
+            <a:srgbClr val="F4A261"/>
+          </a:solidFill>
+          <a:ln>
+            <a:noFill/>
+          </a:ln>
+        </p:spPr>
+        <p:style>
+          <a:lnRef idx="1">
+            <a:schemeClr val="accent1"/>
+          </a:lnRef>
+          <a:fillRef idx="3">
+            <a:schemeClr val="accent1"/>
+          </a:fillRef>
+          <a:effectRef idx="2">
+            <a:schemeClr val="accent1"/>
+          </a:effectRef>
+          <a:fontRef idx="minor">
+            <a:schemeClr val="lt1"/>
+          </a:fontRef>
+        </p:style>
+        <p:txBody>
+          <a:bodyPr rtlCol="0" anchor="ctr"/>
+          <a:lstStyle/>
+          <a:p>
+            <a:pPr algn="ctr"/>
+          </a:p>
+        </p:txBody>
+      </p:sp>
+      <p:sp>
+        <p:nvSpPr>
+          <p:cNvPr id="10" name="TextBox 9"/>
+          <p:cNvSpPr txBox="1"/>
+          <p:nvPr/>
+        </p:nvSpPr>
+        <p:spPr>
+          <a:xfrm>
+            <a:off x="452880" y="790000"/>
+            <a:ext cx="5521596" cy="250000"/>
+          </a:xfrm>
+          <a:prstGeom prst="rect">
+            <a:avLst/>
+          </a:prstGeom>
+          <a:noFill/>
+        </p:spPr>
+        <p:txBody>
+          <a:bodyPr wrap="square" anchor="ctr">
+            <a:spAutoFit/>
+          </a:bodyPr>
+          <a:lstStyle/>
+          <a:p>
+            <a:pPr algn="l"/>
+            <a:r>
+              <a:rPr sz="2000" b="0">
+                <a:solidFill>
+                  <a:srgbClr val="FFFFFF"/>
+                </a:solidFill>
+                <a:latin typeface="Calibri"/>
+              </a:rPr>
+              <a:t>⚙</a:t>
+            </a:r>
+          </a:p>
+        </p:txBody>
+      </p:sp>
+      <p:sp>
+        <p:nvSpPr>
+          <p:cNvPr id="11" name="TextBox 10"/>
+          <p:cNvSpPr txBox="1"/>
+          <p:nvPr/>
+        </p:nvSpPr>
+        <p:spPr>
+          <a:xfrm>
+            <a:off x="592880" y="780000"/>
+            <a:ext cx="5381596" cy="280000"/>
+          </a:xfrm>
+          <a:prstGeom prst="rect">
+            <a:avLst/>
+          </a:prstGeom>
+          <a:noFill/>
+        </p:spPr>
+        <p:txBody>
+          <a:bodyPr wrap="square" anchor="ctr">
+            <a:spAutoFit/>
+          </a:bodyPr>
+          <a:lstStyle/>
+          <a:p>
+            <a:pPr algn="l"/>
+            <a:r>
+              <a:rPr sz="1400" b="1">
+                <a:solidFill>
+                  <a:srgbClr val="FFFFFF"/>
+                </a:solidFill>
+                <a:latin typeface="Calibri"/>
+              </a:rPr>
+              <a:t>Hardware Kit</a:t>
+            </a:r>
+          </a:p>
+        </p:txBody>
+      </p:sp>
+      <p:sp>
+        <p:nvSpPr>
+          <p:cNvPr id="12" name="Oval 11"/>
+          <p:cNvSpPr/>
+          <p:nvPr/>
+        </p:nvSpPr>
+        <p:spPr>
+          <a:xfrm>
+            <a:off x="262880" y="1209083"/>
+            <a:ext cx="80000" cy="80000"/>
+          </a:xfrm>
+          <a:prstGeom prst="ellipse">
+            <a:avLst/>
+          </a:prstGeom>
+          <a:solidFill>
+            <a:srgbClr val="F4A261"/>
+          </a:solidFill>
+          <a:ln>
+            <a:noFill/>
+          </a:ln>
+        </p:spPr>
+        <p:style>
+          <a:lnRef idx="1">
+            <a:schemeClr val="accent1"/>
+          </a:lnRef>
+          <a:fillRef idx="3">
+            <a:schemeClr val="accent1"/>
+          </a:fillRef>
+          <a:effectRef idx="2">
+            <a:schemeClr val="accent1"/>
+          </a:effectRef>
+          <a:fontRef idx="minor">
+            <a:schemeClr val="lt1"/>
+          </a:fontRef>
+        </p:style>
+        <p:txBody>
+          <a:bodyPr rtlCol="0" anchor="ctr"/>
+          <a:lstStyle/>
+          <a:p>
+            <a:pPr algn="ctr"/>
+          </a:p>
+        </p:txBody>
+      </p:sp>
+      <p:sp>
+        <p:nvSpPr>
+          <p:cNvPr id="13" name="TextBox 12"/>
+          <p:cNvSpPr txBox="1"/>
+          <p:nvPr/>
+        </p:nvSpPr>
+        <p:spPr>
+          <a:xfrm>
+            <a:off x="372880" y="1030000"/>
+            <a:ext cx="5491596" cy="438166"/>
+          </a:xfrm>
+          <a:prstGeom prst="rect">
+            <a:avLst/>
+          </a:prstGeom>
+          <a:noFill/>
+        </p:spPr>
+        <p:txBody>
+          <a:bodyPr wrap="square" anchor="ctr">
+            <a:spAutoFit/>
+          </a:bodyPr>
+          <a:lstStyle/>
+          <a:p>
+            <a:pPr algn="l"/>
+            <a:r>
+              <a:rPr sz="1050" b="0">
+                <a:solidFill>
+                  <a:srgbClr val="FFFFFF"/>
+                </a:solidFill>
+                <a:latin typeface="Calibri"/>
+              </a:rPr>
+              <a:t>Raspberry Pi 5 (4 GB)</a:t>
+            </a:r>
+          </a:p>
+        </p:txBody>
+      </p:sp>
+      <p:sp>
+        <p:nvSpPr>
+          <p:cNvPr id="14" name="Rectangle 13"/>
+          <p:cNvSpPr/>
+          <p:nvPr/>
+        </p:nvSpPr>
+        <p:spPr>
+          <a:xfrm>
+            <a:off x="5804476" y="1159083"/>
+            <a:ext cx="210000" cy="180000"/>
+          </a:xfrm>
+          <a:prstGeom prst="roundRect">
+            <a:avLst>
+              <a:gd name="adj" fmla="val 50000"/>
+            </a:avLst>
+          </a:prstGeom>
+          <a:solidFill>
+            <a:srgbClr val="1A6B6B"/>
+          </a:solidFill>
+          <a:ln>
+            <a:noFill/>
+          </a:ln>
+        </p:spPr>
+        <p:style>
+          <a:lnRef idx="1">
+            <a:schemeClr val="accent1"/>
+          </a:lnRef>
+          <a:fillRef idx="3">
+            <a:schemeClr val="accent1"/>
+          </a:fillRef>
+          <a:effectRef idx="2">
+            <a:schemeClr val="accent1"/>
+          </a:effectRef>
+          <a:fontRef idx="minor">
+            <a:schemeClr val="lt1"/>
+          </a:fontRef>
+        </p:style>
+        <p:txBody>
+          <a:bodyPr rtlCol="0" anchor="ctr"/>
+          <a:lstStyle/>
+          <a:p>
+            <a:pPr algn="ctr"/>
+          </a:p>
+        </p:txBody>
+      </p:sp>
+      <p:sp>
+        <p:nvSpPr>
+          <p:cNvPr id="15" name="TextBox 14"/>
+          <p:cNvSpPr txBox="1"/>
+          <p:nvPr/>
+        </p:nvSpPr>
+        <p:spPr>
+          <a:xfrm>
+            <a:off x="5804476" y="1159083"/>
+            <a:ext cx="210000" cy="180000"/>
+          </a:xfrm>
+          <a:prstGeom prst="rect">
+            <a:avLst/>
+          </a:prstGeom>
+          <a:noFill/>
+        </p:spPr>
+        <p:txBody>
+          <a:bodyPr wrap="square" anchor="ctr">
+            <a:spAutoFit/>
+          </a:bodyPr>
+          <a:lstStyle/>
+          <a:p>
+            <a:pPr algn="ctr"/>
+            <a:r>
+              <a:rPr sz="850" b="1">
+                <a:solidFill>
+                  <a:srgbClr val="FFFFFF"/>
+                </a:solidFill>
+                <a:latin typeface="Calibri"/>
+              </a:rPr>
+              <a:t>~£55</a:t>
+            </a:r>
+          </a:p>
+        </p:txBody>
+      </p:sp>
+      <p:sp>
+        <p:nvSpPr>
+          <p:cNvPr id="16" name="Oval 15"/>
+          <p:cNvSpPr/>
+          <p:nvPr/>
+        </p:nvSpPr>
+        <p:spPr>
+          <a:xfrm>
+            <a:off x="262880" y="1647249"/>
+            <a:ext cx="80000" cy="80000"/>
+          </a:xfrm>
+          <a:prstGeom prst="ellipse">
+            <a:avLst/>
+          </a:prstGeom>
+          <a:solidFill>
+            <a:srgbClr val="F4A261"/>
+          </a:solidFill>
+          <a:ln>
+            <a:noFill/>
+          </a:ln>
+        </p:spPr>
+        <p:style>
+          <a:lnRef idx="1">
+            <a:schemeClr val="accent1"/>
+          </a:lnRef>
+          <a:fillRef idx="3">
+            <a:schemeClr val="accent1"/>
+          </a:fillRef>
+          <a:effectRef idx="2">
+            <a:schemeClr val="accent1"/>
+          </a:effectRef>
+          <a:fontRef idx="minor">
+            <a:schemeClr val="lt1"/>
+          </a:fontRef>
+        </p:style>
+        <p:txBody>
+          <a:bodyPr rtlCol="0" anchor="ctr"/>
+          <a:lstStyle/>
+          <a:p>
+            <a:pPr algn="ctr"/>
+          </a:p>
+        </p:txBody>
+      </p:sp>
+      <p:sp>
+        <p:nvSpPr>
+          <p:cNvPr id="17" name="TextBox 16"/>
+          <p:cNvSpPr txBox="1"/>
+          <p:nvPr/>
+        </p:nvSpPr>
+        <p:spPr>
+          <a:xfrm>
+            <a:off x="372880" y="1468166"/>
+            <a:ext cx="5491596" cy="438166"/>
+          </a:xfrm>
+          <a:prstGeom prst="rect">
+            <a:avLst/>
+          </a:prstGeom>
+          <a:noFill/>
+        </p:spPr>
+        <p:txBody>
+          <a:bodyPr wrap="square" anchor="ctr">
+            <a:spAutoFit/>
+          </a:bodyPr>
+          <a:lstStyle/>
+          <a:p>
+            <a:pPr algn="l"/>
+            <a:r>
+              <a:rPr sz="1050" b="0">
+                <a:solidFill>
+                  <a:srgbClr val="FFFFFF"/>
+                </a:solidFill>
+                <a:latin typeface="Calibri"/>
+              </a:rPr>
+              <a:t>DHT22 Temp/Humidity Sensor</a:t>
+            </a:r>
+          </a:p>
+        </p:txBody>
+      </p:sp>
+      <p:sp>
+        <p:nvSpPr>
+          <p:cNvPr id="18" name="Rectangle 17"/>
+          <p:cNvSpPr/>
+          <p:nvPr/>
+        </p:nvSpPr>
+        <p:spPr>
+          <a:xfrm>
+            <a:off x="5804476" y="1597249"/>
+            <a:ext cx="210000" cy="180000"/>
+          </a:xfrm>
+          <a:prstGeom prst="roundRect">
+            <a:avLst>
+              <a:gd name="adj" fmla="val 50000"/>
+            </a:avLst>
+          </a:prstGeom>
+          <a:solidFill>
+            <a:srgbClr val="1A6B6B"/>
+          </a:solidFill>
+          <a:ln>
+            <a:noFill/>
+          </a:ln>
+        </p:spPr>
+        <p:style>
+          <a:lnRef idx="1">
+            <a:schemeClr val="accent1"/>
+          </a:lnRef>
+          <a:fillRef idx="3">
+            <a:schemeClr val="accent1"/>
+          </a:fillRef>
+          <a:effectRef idx="2">
+            <a:schemeClr val="accent1"/>
+          </a:effectRef>
+          <a:fontRef idx="minor">
+            <a:schemeClr val="lt1"/>
+          </a:fontRef>
+        </p:style>
+        <p:txBody>
+          <a:bodyPr rtlCol="0" anchor="ctr"/>
+          <a:lstStyle/>
+          <a:p>
+            <a:pPr algn="ctr"/>
+          </a:p>
+        </p:txBody>
+      </p:sp>
+      <p:sp>
+        <p:nvSpPr>
+          <p:cNvPr id="19" name="TextBox 18"/>
+          <p:cNvSpPr txBox="1"/>
+          <p:nvPr/>
+        </p:nvSpPr>
+        <p:spPr>
+          <a:xfrm>
+            <a:off x="5804476" y="1597249"/>
+            <a:ext cx="210000" cy="180000"/>
+          </a:xfrm>
+          <a:prstGeom prst="rect">
+            <a:avLst/>
+          </a:prstGeom>
+          <a:noFill/>
+        </p:spPr>
+        <p:txBody>
+          <a:bodyPr wrap="square" anchor="ctr">
+            <a:spAutoFit/>
+          </a:bodyPr>
+          <a:lstStyle/>
+          <a:p>
+            <a:pPr algn="ctr"/>
+            <a:r>
+              <a:rPr sz="850" b="1">
+                <a:solidFill>
+                  <a:srgbClr val="FFFFFF"/>
+                </a:solidFill>
+                <a:latin typeface="Calibri"/>
+              </a:rPr>
+              <a:t>~£5</a:t>
+            </a:r>
+          </a:p>
+        </p:txBody>
+      </p:sp>
+      <p:sp>
+        <p:nvSpPr>
+          <p:cNvPr id="20" name="Oval 19"/>
+          <p:cNvSpPr/>
+          <p:nvPr/>
+        </p:nvSpPr>
+        <p:spPr>
+          <a:xfrm>
+            <a:off x="262880" y="2085415"/>
+            <a:ext cx="80000" cy="80000"/>
+          </a:xfrm>
+          <a:prstGeom prst="ellipse">
+            <a:avLst/>
+          </a:prstGeom>
+          <a:solidFill>
+            <a:srgbClr val="F4A261"/>
+          </a:solidFill>
+          <a:ln>
+            <a:noFill/>
+          </a:ln>
+        </p:spPr>
+        <p:style>
+          <a:lnRef idx="1">
+            <a:schemeClr val="accent1"/>
+          </a:lnRef>
+          <a:fillRef idx="3">
+            <a:schemeClr val="accent1"/>
+          </a:fillRef>
+          <a:effectRef idx="2">
+            <a:schemeClr val="accent1"/>
+          </a:effectRef>
+          <a:fontRef idx="minor">
+            <a:schemeClr val="lt1"/>
+          </a:fontRef>
+        </p:style>
+        <p:txBody>
+          <a:bodyPr rtlCol="0" anchor="ctr"/>
+          <a:lstStyle/>
+          <a:p>
+            <a:pPr algn="ctr"/>
+          </a:p>
+        </p:txBody>
+      </p:sp>
+      <p:sp>
+        <p:nvSpPr>
+          <p:cNvPr id="21" name="TextBox 20"/>
+          <p:cNvSpPr txBox="1"/>
+          <p:nvPr/>
+        </p:nvSpPr>
+        <p:spPr>
+          <a:xfrm>
+            <a:off x="372880" y="1906332"/>
+            <a:ext cx="5491596" cy="438166"/>
+          </a:xfrm>
+          <a:prstGeom prst="rect">
+            <a:avLst/>
+          </a:prstGeom>
+          <a:noFill/>
+        </p:spPr>
+        <p:txBody>
+          <a:bodyPr wrap="square" anchor="ctr">
+            <a:spAutoFit/>
+          </a:bodyPr>
+          <a:lstStyle/>
+          <a:p>
+            <a:pPr algn="l"/>
+            <a:r>
+              <a:rPr sz="1050" b="0">
+                <a:solidFill>
+                  <a:srgbClr val="FFFFFF"/>
+                </a:solidFill>
+                <a:latin typeface="Calibri"/>
+              </a:rPr>
+              <a:t>SONOFF ZigBee USB Dongle</a:t>
+            </a:r>
+          </a:p>
+        </p:txBody>
+      </p:sp>
+      <p:sp>
+        <p:nvSpPr>
+          <p:cNvPr id="22" name="Rectangle 21"/>
+          <p:cNvSpPr/>
+          <p:nvPr/>
+        </p:nvSpPr>
+        <p:spPr>
+          <a:xfrm>
+            <a:off x="5804476" y="2035415"/>
+            <a:ext cx="210000" cy="180000"/>
+          </a:xfrm>
+          <a:prstGeom prst="roundRect">
+            <a:avLst>
+              <a:gd name="adj" fmla="val 50000"/>
+            </a:avLst>
+          </a:prstGeom>
+          <a:solidFill>
+            <a:srgbClr val="1A6B6B"/>
+          </a:solidFill>
+          <a:ln>
+            <a:noFill/>
+          </a:ln>
+        </p:spPr>
+        <p:style>
+          <a:lnRef idx="1">
+            <a:schemeClr val="accent1"/>
+          </a:lnRef>
+          <a:fillRef idx="3">
+            <a:schemeClr val="accent1"/>
+          </a:fillRef>
+          <a:effectRef idx="2">
+            <a:schemeClr val="accent1"/>
+          </a:effectRef>
+          <a:fontRef idx="minor">
+            <a:schemeClr val="lt1"/>
+          </a:fontRef>
+        </p:style>
+        <p:txBody>
+          <a:bodyPr rtlCol="0" anchor="ctr"/>
+          <a:lstStyle/>
+          <a:p>
+            <a:pPr algn="ctr"/>
+          </a:p>
+        </p:txBody>
+      </p:sp>
+      <p:sp>
+        <p:nvSpPr>
+          <p:cNvPr id="23" name="TextBox 22"/>
+          <p:cNvSpPr txBox="1"/>
+          <p:nvPr/>
+        </p:nvSpPr>
+        <p:spPr>
+          <a:xfrm>
+            <a:off x="5804476" y="2035415"/>
+            <a:ext cx="210000" cy="180000"/>
+          </a:xfrm>
+          <a:prstGeom prst="rect">
+            <a:avLst/>
+          </a:prstGeom>
+          <a:noFill/>
+        </p:spPr>
+        <p:txBody>
+          <a:bodyPr wrap="square" anchor="ctr">
+            <a:spAutoFit/>
+          </a:bodyPr>
+          <a:lstStyle/>
+          <a:p>
+            <a:pPr algn="ctr"/>
+            <a:r>
+              <a:rPr sz="850" b="1">
+                <a:solidFill>
+                  <a:srgbClr val="FFFFFF"/>
+                </a:solidFill>
+                <a:latin typeface="Calibri"/>
+              </a:rPr>
+              <a:t>~£15</a:t>
+            </a:r>
+          </a:p>
+        </p:txBody>
+      </p:sp>
+      <p:sp>
+        <p:nvSpPr>
+          <p:cNvPr id="24" name="Oval 23"/>
+          <p:cNvSpPr/>
+          <p:nvPr/>
+        </p:nvSpPr>
+        <p:spPr>
+          <a:xfrm>
+            <a:off x="262880" y="2523581"/>
+            <a:ext cx="80000" cy="80000"/>
+          </a:xfrm>
+          <a:prstGeom prst="ellipse">
+            <a:avLst/>
+          </a:prstGeom>
+          <a:solidFill>
+            <a:srgbClr val="F4A261"/>
+          </a:solidFill>
+          <a:ln>
+            <a:noFill/>
+          </a:ln>
+        </p:spPr>
+        <p:style>
+          <a:lnRef idx="1">
+            <a:schemeClr val="accent1"/>
+          </a:lnRef>
+          <a:fillRef idx="3">
+            <a:schemeClr val="accent1"/>
+          </a:fillRef>
+          <a:effectRef idx="2">
+            <a:schemeClr val="accent1"/>
+          </a:effectRef>
+          <a:fontRef idx="minor">
+            <a:schemeClr val="lt1"/>
+          </a:fontRef>
+        </p:style>
+        <p:txBody>
+          <a:bodyPr rtlCol="0" anchor="ctr"/>
+          <a:lstStyle/>
+          <a:p>
+            <a:pPr algn="ctr"/>
+          </a:p>
+        </p:txBody>
+      </p:sp>
+      <p:sp>
+        <p:nvSpPr>
+          <p:cNvPr id="25" name="TextBox 24"/>
+          <p:cNvSpPr txBox="1"/>
+          <p:nvPr/>
+        </p:nvSpPr>
+        <p:spPr>
+          <a:xfrm>
+            <a:off x="372880" y="2344498"/>
+            <a:ext cx="5491596" cy="438166"/>
+          </a:xfrm>
+          <a:prstGeom prst="rect">
+            <a:avLst/>
+          </a:prstGeom>
+          <a:noFill/>
+        </p:spPr>
+        <p:txBody>
+          <a:bodyPr wrap="square" anchor="ctr">
+            <a:spAutoFit/>
+          </a:bodyPr>
+          <a:lstStyle/>
+          <a:p>
+            <a:pPr algn="l"/>
+            <a:r>
+              <a:rPr sz="1050" b="0">
+                <a:solidFill>
+                  <a:srgbClr val="FFFFFF"/>
+                </a:solidFill>
+                <a:latin typeface="Calibri"/>
+              </a:rPr>
+              <a:t>IKEA TRADFRI Colour Bulb (E27)</a:t>
+            </a:r>
+          </a:p>
+        </p:txBody>
+      </p:sp>
+      <p:sp>
+        <p:nvSpPr>
+          <p:cNvPr id="26" name="Rectangle 25"/>
+          <p:cNvSpPr/>
+          <p:nvPr/>
+        </p:nvSpPr>
+        <p:spPr>
+          <a:xfrm>
+            <a:off x="5804476" y="2473581"/>
+            <a:ext cx="210000" cy="180000"/>
+          </a:xfrm>
+          <a:prstGeom prst="roundRect">
+            <a:avLst>
+              <a:gd name="adj" fmla="val 50000"/>
+            </a:avLst>
+          </a:prstGeom>
+          <a:solidFill>
+            <a:srgbClr val="1A6B6B"/>
+          </a:solidFill>
+          <a:ln>
+            <a:noFill/>
+          </a:ln>
+        </p:spPr>
+        <p:style>
+          <a:lnRef idx="1">
+            <a:schemeClr val="accent1"/>
+          </a:lnRef>
+          <a:fillRef idx="3">
+            <a:schemeClr val="accent1"/>
+          </a:fillRef>
+          <a:effectRef idx="2">
+            <a:schemeClr val="accent1"/>
+          </a:effectRef>
+          <a:fontRef idx="minor">
+            <a:schemeClr val="lt1"/>
+          </a:fontRef>
+        </p:style>
+        <p:txBody>
+          <a:bodyPr rtlCol="0" anchor="ctr"/>
+          <a:lstStyle/>
+          <a:p>
+            <a:pPr algn="ctr"/>
+          </a:p>
+        </p:txBody>
+      </p:sp>
+      <p:sp>
+        <p:nvSpPr>
+          <p:cNvPr id="27" name="TextBox 26"/>
+          <p:cNvSpPr txBox="1"/>
+          <p:nvPr/>
+        </p:nvSpPr>
+        <p:spPr>
+          <a:xfrm>
+            <a:off x="5804476" y="2473581"/>
+            <a:ext cx="210000" cy="180000"/>
+          </a:xfrm>
+          <a:prstGeom prst="rect">
+            <a:avLst/>
+          </a:prstGeom>
+          <a:noFill/>
+        </p:spPr>
+        <p:txBody>
+          <a:bodyPr wrap="square" anchor="ctr">
+            <a:spAutoFit/>
+          </a:bodyPr>
+          <a:lstStyle/>
+          <a:p>
+            <a:pPr algn="ctr"/>
+            <a:r>
+              <a:rPr sz="850" b="1">
+                <a:solidFill>
+                  <a:srgbClr val="FFFFFF"/>
+                </a:solidFill>
+                <a:latin typeface="Calibri"/>
+              </a:rPr>
+              <a:t>~£15</a:t>
+            </a:r>
+          </a:p>
+        </p:txBody>
+      </p:sp>
+      <p:sp>
+        <p:nvSpPr>
+          <p:cNvPr id="28" name="Oval 27"/>
+          <p:cNvSpPr/>
+          <p:nvPr/>
+        </p:nvSpPr>
+        <p:spPr>
+          <a:xfrm>
+            <a:off x="262880" y="2961747"/>
+            <a:ext cx="80000" cy="80000"/>
+          </a:xfrm>
+          <a:prstGeom prst="ellipse">
+            <a:avLst/>
+          </a:prstGeom>
+          <a:solidFill>
+            <a:srgbClr val="F4A261"/>
+          </a:solidFill>
+          <a:ln>
+            <a:noFill/>
+          </a:ln>
+        </p:spPr>
+        <p:style>
+          <a:lnRef idx="1">
+            <a:schemeClr val="accent1"/>
+          </a:lnRef>
+          <a:fillRef idx="3">
+            <a:schemeClr val="accent1"/>
+          </a:fillRef>
+          <a:effectRef idx="2">
+            <a:schemeClr val="accent1"/>
+          </a:effectRef>
+          <a:fontRef idx="minor">
+            <a:schemeClr val="lt1"/>
+          </a:fontRef>
+        </p:style>
+        <p:txBody>
+          <a:bodyPr rtlCol="0" anchor="ctr"/>
+          <a:lstStyle/>
+          <a:p>
+            <a:pPr algn="ctr"/>
+          </a:p>
+        </p:txBody>
+      </p:sp>
+      <p:sp>
+        <p:nvSpPr>
+          <p:cNvPr id="29" name="TextBox 28"/>
+          <p:cNvSpPr txBox="1"/>
+          <p:nvPr/>
+        </p:nvSpPr>
+        <p:spPr>
+          <a:xfrm>
+            <a:off x="372880" y="2782664"/>
+            <a:ext cx="5491596" cy="438166"/>
+          </a:xfrm>
+          <a:prstGeom prst="rect">
+            <a:avLst/>
+          </a:prstGeom>
+          <a:noFill/>
+        </p:spPr>
+        <p:txBody>
+          <a:bodyPr wrap="square" anchor="ctr">
+            <a:spAutoFit/>
+          </a:bodyPr>
+          <a:lstStyle/>
+          <a:p>
+            <a:pPr algn="l"/>
+            <a:r>
+              <a:rPr sz="1050" b="0">
+                <a:solidFill>
+                  <a:srgbClr val="FFFFFF"/>
+                </a:solidFill>
+                <a:latin typeface="Calibri"/>
+              </a:rPr>
+              <a:t>Smart Plug with Energy Meter</a:t>
+            </a:r>
+          </a:p>
+        </p:txBody>
+      </p:sp>
+      <p:sp>
+        <p:nvSpPr>
+          <p:cNvPr id="30" name="Rectangle 29"/>
+          <p:cNvSpPr/>
+          <p:nvPr/>
+        </p:nvSpPr>
+        <p:spPr>
+          <a:xfrm>
+            <a:off x="5804476" y="2911747"/>
+            <a:ext cx="210000" cy="180000"/>
+          </a:xfrm>
+          <a:prstGeom prst="roundRect">
+            <a:avLst>
+              <a:gd name="adj" fmla="val 50000"/>
+            </a:avLst>
+          </a:prstGeom>
+          <a:solidFill>
+            <a:srgbClr val="1A6B6B"/>
+          </a:solidFill>
+          <a:ln>
+            <a:noFill/>
+          </a:ln>
+        </p:spPr>
+        <p:style>
+          <a:lnRef idx="1">
+            <a:schemeClr val="accent1"/>
+          </a:lnRef>
+          <a:fillRef idx="3">
+            <a:schemeClr val="accent1"/>
+          </a:fillRef>
+          <a:effectRef idx="2">
+            <a:schemeClr val="accent1"/>
+          </a:effectRef>
+          <a:fontRef idx="minor">
+            <a:schemeClr val="lt1"/>
+          </a:fontRef>
+        </p:style>
+        <p:txBody>
+          <a:bodyPr rtlCol="0" anchor="ctr"/>
+          <a:lstStyle/>
+          <a:p>
+            <a:pPr algn="ctr"/>
+          </a:p>
+        </p:txBody>
+      </p:sp>
+      <p:sp>
+        <p:nvSpPr>
+          <p:cNvPr id="31" name="TextBox 30"/>
+          <p:cNvSpPr txBox="1"/>
+          <p:nvPr/>
+        </p:nvSpPr>
+        <p:spPr>
+          <a:xfrm>
+            <a:off x="5804476" y="2911747"/>
+            <a:ext cx="210000" cy="180000"/>
+          </a:xfrm>
+          <a:prstGeom prst="rect">
+            <a:avLst/>
+          </a:prstGeom>
+          <a:noFill/>
+        </p:spPr>
+        <p:txBody>
+          <a:bodyPr wrap="square" anchor="ctr">
+            <a:spAutoFit/>
+          </a:bodyPr>
+          <a:lstStyle/>
+          <a:p>
+            <a:pPr algn="ctr"/>
+            <a:r>
+              <a:rPr sz="850" b="1">
+                <a:solidFill>
+                  <a:srgbClr val="FFFFFF"/>
+                </a:solidFill>
+                <a:latin typeface="Calibri"/>
+              </a:rPr>
+              <a:t>~£15</a:t>
+            </a:r>
+          </a:p>
+        </p:txBody>
+      </p:sp>
+      <p:sp>
+        <p:nvSpPr>
+          <p:cNvPr id="32" name="Oval 31"/>
+          <p:cNvSpPr/>
+          <p:nvPr/>
+        </p:nvSpPr>
+        <p:spPr>
+          <a:xfrm>
+            <a:off x="262880" y="3399913"/>
+            <a:ext cx="80000" cy="80000"/>
+          </a:xfrm>
+          <a:prstGeom prst="ellipse">
+            <a:avLst/>
+          </a:prstGeom>
+          <a:solidFill>
+            <a:srgbClr val="F4A261"/>
+          </a:solidFill>
+          <a:ln>
+            <a:noFill/>
+          </a:ln>
+        </p:spPr>
+        <p:style>
+          <a:lnRef idx="1">
+            <a:schemeClr val="accent1"/>
+          </a:lnRef>
+          <a:fillRef idx="3">
+            <a:schemeClr val="accent1"/>
+          </a:fillRef>
+          <a:effectRef idx="2">
+            <a:schemeClr val="accent1"/>
+          </a:effectRef>
+          <a:fontRef idx="minor">
+            <a:schemeClr val="lt1"/>
+          </a:fontRef>
+        </p:style>
+        <p:txBody>
+          <a:bodyPr rtlCol="0" anchor="ctr"/>
+          <a:lstStyle/>
+          <a:p>
+            <a:pPr algn="ctr"/>
+          </a:p>
+        </p:txBody>
+      </p:sp>
+      <p:sp>
+        <p:nvSpPr>
+          <p:cNvPr id="33" name="TextBox 32"/>
+          <p:cNvSpPr txBox="1"/>
+          <p:nvPr/>
+        </p:nvSpPr>
+        <p:spPr>
+          <a:xfrm>
+            <a:off x="372880" y="3220830"/>
+            <a:ext cx="5491596" cy="438166"/>
+          </a:xfrm>
+          <a:prstGeom prst="rect">
+            <a:avLst/>
+          </a:prstGeom>
+          <a:noFill/>
+        </p:spPr>
+        <p:txBody>
+          <a:bodyPr wrap="square" anchor="ctr">
+            <a:spAutoFit/>
+          </a:bodyPr>
+          <a:lstStyle/>
+          <a:p>
+            <a:pPr algn="l"/>
+            <a:r>
+              <a:rPr sz="1050" b="0">
+                <a:solidFill>
+                  <a:srgbClr val="FFFFFF"/>
+                </a:solidFill>
+                <a:latin typeface="Calibri"/>
+              </a:rPr>
+              <a:t>Breadboard + Jumper Wires</a:t>
+            </a:r>
+          </a:p>
+        </p:txBody>
+      </p:sp>
+      <p:sp>
+        <p:nvSpPr>
+          <p:cNvPr id="34" name="Rectangle 33"/>
+          <p:cNvSpPr/>
+          <p:nvPr/>
+        </p:nvSpPr>
+        <p:spPr>
+          <a:xfrm>
+            <a:off x="5804476" y="3349913"/>
+            <a:ext cx="210000" cy="180000"/>
+          </a:xfrm>
+          <a:prstGeom prst="roundRect">
+            <a:avLst>
+              <a:gd name="adj" fmla="val 50000"/>
+            </a:avLst>
+          </a:prstGeom>
+          <a:solidFill>
+            <a:srgbClr val="1A6B6B"/>
+          </a:solidFill>
+          <a:ln>
+            <a:noFill/>
+          </a:ln>
+        </p:spPr>
+        <p:style>
+          <a:lnRef idx="1">
+            <a:schemeClr val="accent1"/>
+          </a:lnRef>
+          <a:fillRef idx="3">
+            <a:schemeClr val="accent1"/>
+          </a:fillRef>
+          <a:effectRef idx="2">
+            <a:schemeClr val="accent1"/>
+          </a:effectRef>
+          <a:fontRef idx="minor">
+            <a:schemeClr val="lt1"/>
+          </a:fontRef>
+        </p:style>
+        <p:txBody>
+          <a:bodyPr rtlCol="0" anchor="ctr"/>
+          <a:lstStyle/>
+          <a:p>
+            <a:pPr algn="ctr"/>
+          </a:p>
+        </p:txBody>
+      </p:sp>
+      <p:sp>
+        <p:nvSpPr>
+          <p:cNvPr id="35" name="TextBox 34"/>
+          <p:cNvSpPr txBox="1"/>
+          <p:nvPr/>
+        </p:nvSpPr>
+        <p:spPr>
+          <a:xfrm>
+            <a:off x="5804476" y="3349913"/>
+            <a:ext cx="210000" cy="180000"/>
+          </a:xfrm>
+          <a:prstGeom prst="rect">
+            <a:avLst/>
+          </a:prstGeom>
+          <a:noFill/>
+        </p:spPr>
+        <p:txBody>
+          <a:bodyPr wrap="square" anchor="ctr">
+            <a:spAutoFit/>
+          </a:bodyPr>
+          <a:lstStyle/>
+          <a:p>
+            <a:pPr algn="ctr"/>
+            <a:r>
+              <a:rPr sz="850" b="1">
+                <a:solidFill>
+                  <a:srgbClr val="FFFFFF"/>
+                </a:solidFill>
+                <a:latin typeface="Calibri"/>
+              </a:rPr>
+              <a:t>~£5</a:t>
+            </a:r>
+          </a:p>
+        </p:txBody>
+      </p:sp>
+      <p:sp>
+        <p:nvSpPr>
+          <p:cNvPr id="36" name="TextBox 35"/>
+          <p:cNvSpPr txBox="1"/>
+          <p:nvPr/>
+        </p:nvSpPr>
+        <p:spPr>
+          <a:xfrm>
+            <a:off x="262880" y="3504000"/>
+            <a:ext cx="5701596" cy="130000"/>
+          </a:xfrm>
+          <a:prstGeom prst="rect">
+            <a:avLst/>
+          </a:prstGeom>
+          <a:noFill/>
+        </p:spPr>
+        <p:txBody>
+          <a:bodyPr wrap="square" anchor="ctr">
+            <a:spAutoFit/>
+          </a:bodyPr>
+          <a:lstStyle/>
+          <a:p>
+            <a:pPr algn="ctr"/>
+            <a:r>
+              <a:rPr sz="900" b="1">
+                <a:solidFill>
+                  <a:srgbClr val="F4A261"/>
+                </a:solidFill>
+                <a:latin typeface="Calibri"/>
+              </a:rPr>
+              <a:t>Total starter budget:  ~£50  |  Full kit:  ~£148</a:t>
+            </a:r>
+          </a:p>
+        </p:txBody>
+      </p:sp>
+      <p:sp>
+        <p:nvSpPr>
+          <p:cNvPr id="37" name="Rectangle 36"/>
+          <p:cNvSpPr/>
+          <p:nvPr/>
+        </p:nvSpPr>
+        <p:spPr>
+          <a:xfrm>
+            <a:off x="6144476" y="670000"/>
+            <a:ext cx="5861596" cy="2979000"/>
+          </a:xfrm>
+          <a:prstGeom prst="roundRect">
+            <a:avLst>
+              <a:gd name="adj" fmla="val 20000"/>
+            </a:avLst>
+          </a:prstGeom>
+          <a:solidFill>
+            <a:srgbClr val="0A4A4A"/>
+          </a:solidFill>
+          <a:ln w="9144">
+            <a:solidFill>
+              <a:srgbClr val="1A6B6B"/>
+            </a:solidFill>
+          </a:ln>
+        </p:spPr>
+        <p:style>
+          <a:lnRef idx="1">
+            <a:schemeClr val="accent1"/>
+          </a:lnRef>
+          <a:fillRef idx="3">
+            <a:schemeClr val="accent1"/>
+          </a:fillRef>
+          <a:effectRef idx="2">
+            <a:schemeClr val="accent1"/>
+          </a:effectRef>
+          <a:fontRef idx="minor">
+            <a:schemeClr val="lt1"/>
+          </a:fontRef>
+        </p:style>
+        <p:txBody>
+          <a:bodyPr rtlCol="0" anchor="ctr"/>
+          <a:lstStyle/>
+          <a:p>
+            <a:pPr algn="ctr"/>
+          </a:p>
+        </p:txBody>
+      </p:sp>
+      <p:sp>
+        <p:nvSpPr>
+          <p:cNvPr id="38" name="Rectangle 37"/>
+          <p:cNvSpPr/>
+          <p:nvPr/>
+        </p:nvSpPr>
+        <p:spPr>
+          <a:xfrm>
+            <a:off x="6204476" y="730000"/>
+            <a:ext cx="50000" cy="280000"/>
+          </a:xfrm>
+          <a:prstGeom prst="rect">
+            <a:avLst/>
+          </a:prstGeom>
+          <a:solidFill>
+            <a:srgbClr val="2EC4B6"/>
+          </a:solidFill>
+          <a:ln>
+            <a:noFill/>
+          </a:ln>
+        </p:spPr>
+        <p:style>
+          <a:lnRef idx="1">
+            <a:schemeClr val="accent1"/>
+          </a:lnRef>
+          <a:fillRef idx="3">
+            <a:schemeClr val="accent1"/>
+          </a:fillRef>
+          <a:effectRef idx="2">
+            <a:schemeClr val="accent1"/>
+          </a:effectRef>
+          <a:fontRef idx="minor">
+            <a:schemeClr val="lt1"/>
+          </a:fontRef>
+        </p:style>
+        <p:txBody>
+          <a:bodyPr rtlCol="0" anchor="ctr"/>
+          <a:lstStyle/>
+          <a:p>
+            <a:pPr algn="ctr"/>
+          </a:p>
+        </p:txBody>
+      </p:sp>
+      <p:sp>
+        <p:nvSpPr>
+          <p:cNvPr id="39" name="Oval 38"/>
+          <p:cNvSpPr/>
+          <p:nvPr/>
+        </p:nvSpPr>
+        <p:spPr>
+          <a:xfrm>
+            <a:off x="6204476" y="730000"/>
+            <a:ext cx="280000" cy="280000"/>
+          </a:xfrm>
+          <a:prstGeom prst="ellipse">
+            <a:avLst/>
+          </a:prstGeom>
+          <a:solidFill>
+            <a:srgbClr val="2EC4B6"/>
+          </a:solidFill>
+          <a:ln>
+            <a:noFill/>
+          </a:ln>
+        </p:spPr>
+        <p:style>
+          <a:lnRef idx="1">
+            <a:schemeClr val="accent1"/>
+          </a:lnRef>
+          <a:fillRef idx="3">
+            <a:schemeClr val="accent1"/>
+          </a:fillRef>
+          <a:effectRef idx="2">
+            <a:schemeClr val="accent1"/>
+          </a:effectRef>
+          <a:fontRef idx="minor">
+            <a:schemeClr val="lt1"/>
+          </a:fontRef>
+        </p:style>
+        <p:txBody>
+          <a:bodyPr rtlCol="0" anchor="ctr"/>
+          <a:lstStyle/>
+          <a:p>
+            <a:pPr algn="ctr"/>
+          </a:p>
+        </p:txBody>
+      </p:sp>
+      <p:sp>
+        <p:nvSpPr>
+          <p:cNvPr id="40" name="TextBox 39"/>
+          <p:cNvSpPr txBox="1"/>
+          <p:nvPr/>
+        </p:nvSpPr>
+        <p:spPr>
+          <a:xfrm>
+            <a:off x="6414476" y="790000"/>
+            <a:ext cx="5521596" cy="250000"/>
+          </a:xfrm>
+          <a:prstGeom prst="rect">
+            <a:avLst/>
+          </a:prstGeom>
+          <a:noFill/>
+        </p:spPr>
+        <p:txBody>
+          <a:bodyPr wrap="square" anchor="ctr">
+            <a:spAutoFit/>
+          </a:bodyPr>
+          <a:lstStyle/>
+          <a:p>
+            <a:pPr algn="l"/>
+            <a:r>
+              <a:rPr sz="2000" b="0">
+                <a:solidFill>
+                  <a:srgbClr val="FFFFFF"/>
+                </a:solidFill>
+                <a:latin typeface="Calibri"/>
+              </a:rPr>
+              <a:t>☀</a:t>
+            </a:r>
+          </a:p>
+        </p:txBody>
+      </p:sp>
+      <p:sp>
+        <p:nvSpPr>
+          <p:cNvPr id="41" name="TextBox 40"/>
+          <p:cNvSpPr txBox="1"/>
+          <p:nvPr/>
+        </p:nvSpPr>
+        <p:spPr>
+          <a:xfrm>
+            <a:off x="6554476" y="780000"/>
+            <a:ext cx="5381596" cy="280000"/>
+          </a:xfrm>
+          <a:prstGeom prst="rect">
+            <a:avLst/>
+          </a:prstGeom>
+          <a:noFill/>
+        </p:spPr>
+        <p:txBody>
+          <a:bodyPr wrap="square" anchor="ctr">
+            <a:spAutoFit/>
+          </a:bodyPr>
+          <a:lstStyle/>
+          <a:p>
+            <a:pPr algn="l"/>
+            <a:r>
+              <a:rPr sz="1400" b="1">
+                <a:solidFill>
+                  <a:srgbClr val="FFFFFF"/>
+                </a:solidFill>
+                <a:latin typeface="Calibri"/>
+              </a:rPr>
+              <a:t>First Project  —  Weather → Light Signal</a:t>
+            </a:r>
+          </a:p>
+        </p:txBody>
+      </p:sp>
+      <p:sp>
+        <p:nvSpPr>
+          <p:cNvPr id="42" name="Rectangle 41"/>
+          <p:cNvSpPr/>
+          <p:nvPr/>
+        </p:nvSpPr>
+        <p:spPr>
+          <a:xfrm>
+            <a:off x="6224476" y="1040000"/>
+            <a:ext cx="1887198" cy="2449000"/>
+          </a:xfrm>
+          <a:prstGeom prst="roundRect">
+            <a:avLst>
+              <a:gd name="adj" fmla="val 20000"/>
+            </a:avLst>
+          </a:prstGeom>
+          <a:solidFill>
+            <a:srgbClr val="125555"/>
+          </a:solidFill>
+          <a:ln w="18000">
+            <a:solidFill>
+              <a:srgbClr val="2EC4B6"/>
+            </a:solidFill>
+          </a:ln>
+        </p:spPr>
+        <p:style>
+          <a:lnRef idx="1">
+            <a:schemeClr val="accent1"/>
+          </a:lnRef>
+          <a:fillRef idx="3">
+            <a:schemeClr val="accent1"/>
+          </a:fillRef>
+          <a:effectRef idx="2">
+            <a:schemeClr val="accent1"/>
+          </a:effectRef>
+          <a:fontRef idx="minor">
+            <a:schemeClr val="lt1"/>
+          </a:fontRef>
+        </p:style>
+        <p:txBody>
+          <a:bodyPr rtlCol="0" anchor="ctr"/>
+          <a:lstStyle/>
+          <a:p>
+            <a:pPr algn="ctr"/>
+          </a:p>
+        </p:txBody>
+      </p:sp>
+      <p:sp>
+        <p:nvSpPr>
+          <p:cNvPr id="43" name="TextBox 42"/>
+          <p:cNvSpPr txBox="1"/>
+          <p:nvPr/>
+        </p:nvSpPr>
+        <p:spPr>
+          <a:xfrm>
+            <a:off x="6224476" y="1090000"/>
+            <a:ext cx="1887198" cy="220000"/>
+          </a:xfrm>
+          <a:prstGeom prst="rect">
+            <a:avLst/>
+          </a:prstGeom>
+          <a:noFill/>
+        </p:spPr>
+        <p:txBody>
+          <a:bodyPr wrap="square" anchor="ctr">
+            <a:spAutoFit/>
+          </a:bodyPr>
+          <a:lstStyle/>
+          <a:p>
+            <a:pPr algn="ctr"/>
+            <a:r>
+              <a:rPr sz="1300" b="1">
+                <a:solidFill>
+                  <a:srgbClr val="2EC4B6"/>
+                </a:solidFill>
+                <a:latin typeface="Calibri"/>
+              </a:rPr>
+              <a:t>Weather</a:t>
+            </a:r>
+          </a:p>
+        </p:txBody>
+      </p:sp>
+      <p:sp>
+        <p:nvSpPr>
+          <p:cNvPr id="44" name="TextBox 43"/>
+          <p:cNvSpPr txBox="1"/>
+          <p:nvPr/>
+        </p:nvSpPr>
+        <p:spPr>
+          <a:xfrm>
+            <a:off x="6224476" y="1290000"/>
+            <a:ext cx="1887198" cy="220000"/>
+          </a:xfrm>
+          <a:prstGeom prst="rect">
+            <a:avLst/>
+          </a:prstGeom>
+          <a:noFill/>
+        </p:spPr>
+        <p:txBody>
+          <a:bodyPr wrap="square" anchor="ctr">
+            <a:spAutoFit/>
+          </a:bodyPr>
+          <a:lstStyle/>
+          <a:p>
+            <a:pPr algn="ctr"/>
+            <a:r>
+              <a:rPr sz="1100" b="0">
+                <a:solidFill>
+                  <a:srgbClr val="FFFFFF"/>
+                </a:solidFill>
+                <a:latin typeface="Calibri"/>
+              </a:rPr>
+              <a:t>API</a:t>
+            </a:r>
+          </a:p>
+        </p:txBody>
+      </p:sp>
+      <p:sp>
+        <p:nvSpPr>
+          <p:cNvPr id="45" name="TextBox 44"/>
+          <p:cNvSpPr txBox="1"/>
+          <p:nvPr/>
+        </p:nvSpPr>
+        <p:spPr>
+          <a:xfrm>
+            <a:off x="6254476" y="2264500"/>
+            <a:ext cx="1827198" cy="200000"/>
+          </a:xfrm>
+          <a:prstGeom prst="rect">
+            <a:avLst/>
+          </a:prstGeom>
+          <a:noFill/>
+        </p:spPr>
+        <p:txBody>
+          <a:bodyPr wrap="square" anchor="ctr">
+            <a:spAutoFit/>
+          </a:bodyPr>
+          <a:lstStyle/>
+          <a:p>
+            <a:pPr algn="ctr"/>
+            <a:r>
+              <a:rPr sz="900" b="0">
+                <a:solidFill>
+                  <a:srgbClr val="CCEEEE"/>
+                </a:solidFill>
+                <a:latin typeface="Calibri"/>
+              </a:rPr>
+              <a:t>open-meteo.com</a:t>
+            </a:r>
+          </a:p>
+        </p:txBody>
+      </p:sp>
+      <p:sp>
+        <p:nvSpPr>
+          <p:cNvPr id="46" name="TextBox 45"/>
+          <p:cNvSpPr txBox="1"/>
+          <p:nvPr/>
+        </p:nvSpPr>
+        <p:spPr>
+          <a:xfrm>
+            <a:off x="6254476" y="2454500"/>
+            <a:ext cx="1827198" cy="200000"/>
+          </a:xfrm>
+          <a:prstGeom prst="rect">
+            <a:avLst/>
+          </a:prstGeom>
+          <a:noFill/>
+        </p:spPr>
+        <p:txBody>
+          <a:bodyPr wrap="square" anchor="ctr">
+            <a:spAutoFit/>
+          </a:bodyPr>
+          <a:lstStyle/>
+          <a:p>
+            <a:pPr algn="ctr"/>
+            <a:r>
+              <a:rPr sz="900" b="0">
+                <a:solidFill>
+                  <a:srgbClr val="CCEEEE"/>
+                </a:solidFill>
+                <a:latin typeface="Calibri"/>
+              </a:rPr>
+              <a:t>free, no key</a:t>
+            </a:r>
+          </a:p>
+        </p:txBody>
+      </p:sp>
+      <p:sp>
+        <p:nvSpPr>
+          <p:cNvPr id="47" name="Can 46"/>
+          <p:cNvSpPr/>
+          <p:nvPr/>
+        </p:nvSpPr>
+        <p:spPr>
+          <a:xfrm>
+            <a:off x="8126674" y="2204500"/>
+            <a:ext cx="120000" cy="120000"/>
+          </a:xfrm>
+          <a:prstGeom prst="can">
+            <a:avLst/>
+          </a:prstGeom>
+          <a:solidFill>
+            <a:srgbClr val="F4A261"/>
+          </a:solidFill>
+          <a:ln>
+            <a:noFill/>
+          </a:ln>
+        </p:spPr>
+        <p:style>
+          <a:lnRef idx="1">
+            <a:schemeClr val="accent1"/>
+          </a:lnRef>
+          <a:fillRef idx="3">
+            <a:schemeClr val="accent1"/>
+          </a:fillRef>
+          <a:effectRef idx="2">
+            <a:schemeClr val="accent1"/>
+          </a:effectRef>
+          <a:fontRef idx="minor">
+            <a:schemeClr val="lt1"/>
+          </a:fontRef>
+        </p:style>
+        <p:txBody>
+          <a:bodyPr rtlCol="0" anchor="ctr"/>
+          <a:lstStyle/>
+          <a:p>
+            <a:pPr algn="ctr"/>
+          </a:p>
+        </p:txBody>
+      </p:sp>
+      <p:sp>
+        <p:nvSpPr>
+          <p:cNvPr id="48" name="Rectangle 47"/>
+          <p:cNvSpPr/>
+          <p:nvPr/>
+        </p:nvSpPr>
+        <p:spPr>
+          <a:xfrm>
+            <a:off x="8201674" y="1040000"/>
+            <a:ext cx="1887198" cy="2449000"/>
+          </a:xfrm>
+          <a:prstGeom prst="roundRect">
+            <a:avLst>
+              <a:gd name="adj" fmla="val 20000"/>
+            </a:avLst>
+          </a:prstGeom>
+          <a:solidFill>
+            <a:srgbClr val="125555"/>
+          </a:solidFill>
+          <a:ln w="18000">
+            <a:solidFill>
+              <a:srgbClr val="F4A261"/>
+            </a:solidFill>
+          </a:ln>
+        </p:spPr>
+        <p:style>
+          <a:lnRef idx="1">
+            <a:schemeClr val="accent1"/>
+          </a:lnRef>
+          <a:fillRef idx="3">
+            <a:schemeClr val="accent1"/>
+          </a:fillRef>
+          <a:effectRef idx="2">
+            <a:schemeClr val="accent1"/>
+          </a:effectRef>
+          <a:fontRef idx="minor">
+            <a:schemeClr val="lt1"/>
+          </a:fontRef>
+        </p:style>
+        <p:txBody>
+          <a:bodyPr rtlCol="0" anchor="ctr"/>
+          <a:lstStyle/>
+          <a:p>
+            <a:pPr algn="ctr"/>
+          </a:p>
+        </p:txBody>
+      </p:sp>
+      <p:sp>
+        <p:nvSpPr>
+          <p:cNvPr id="49" name="TextBox 48"/>
+          <p:cNvSpPr txBox="1"/>
+          <p:nvPr/>
+        </p:nvSpPr>
+        <p:spPr>
+          <a:xfrm>
+            <a:off x="8201674" y="1090000"/>
+            <a:ext cx="1887198" cy="220000"/>
+          </a:xfrm>
+          <a:prstGeom prst="rect">
+            <a:avLst/>
+          </a:prstGeom>
+          <a:noFill/>
+        </p:spPr>
+        <p:txBody>
+          <a:bodyPr wrap="square" anchor="ctr">
+            <a:spAutoFit/>
+          </a:bodyPr>
+          <a:lstStyle/>
+          <a:p>
+            <a:pPr algn="ctr"/>
+            <a:r>
+              <a:rPr sz="1300" b="1">
+                <a:solidFill>
+                  <a:srgbClr val="F4A261"/>
+                </a:solidFill>
+                <a:latin typeface="Calibri"/>
+              </a:rPr>
+              <a:t>IoT-GPT</a:t>
+            </a:r>
+          </a:p>
+        </p:txBody>
+      </p:sp>
+      <p:sp>
+        <p:nvSpPr>
+          <p:cNvPr id="50" name="TextBox 49"/>
+          <p:cNvSpPr txBox="1"/>
+          <p:nvPr/>
+        </p:nvSpPr>
+        <p:spPr>
+          <a:xfrm>
+            <a:off x="8201674" y="1290000"/>
+            <a:ext cx="1887198" cy="220000"/>
+          </a:xfrm>
+          <a:prstGeom prst="rect">
+            <a:avLst/>
+          </a:prstGeom>
+          <a:noFill/>
+        </p:spPr>
+        <p:txBody>
+          <a:bodyPr wrap="square" anchor="ctr">
+            <a:spAutoFit/>
+          </a:bodyPr>
+          <a:lstStyle/>
+          <a:p>
+            <a:pPr algn="ctr"/>
+            <a:r>
+              <a:rPr sz="1100" b="0">
+                <a:solidFill>
+                  <a:srgbClr val="FFFFFF"/>
+                </a:solidFill>
+                <a:latin typeface="Calibri"/>
+              </a:rPr>
+              <a:t>Decision</a:t>
+            </a:r>
+          </a:p>
+        </p:txBody>
+      </p:sp>
+      <p:sp>
+        <p:nvSpPr>
+          <p:cNvPr id="51" name="TextBox 50"/>
+          <p:cNvSpPr txBox="1"/>
+          <p:nvPr/>
+        </p:nvSpPr>
+        <p:spPr>
+          <a:xfrm>
+            <a:off x="8231674" y="2264500"/>
+            <a:ext cx="1827198" cy="200000"/>
+          </a:xfrm>
+          <a:prstGeom prst="rect">
+            <a:avLst/>
+          </a:prstGeom>
+          <a:noFill/>
+        </p:spPr>
+        <p:txBody>
+          <a:bodyPr wrap="square" anchor="ctr">
+            <a:spAutoFit/>
+          </a:bodyPr>
+          <a:lstStyle/>
+          <a:p>
+            <a:pPr algn="ctr"/>
+            <a:r>
+              <a:rPr sz="900" b="0">
+                <a:solidFill>
+                  <a:srgbClr val="CCEEEE"/>
+                </a:solidFill>
+                <a:latin typeface="Calibri"/>
+              </a:rPr>
+              <a:t>Snow? → Blue</a:t>
+            </a:r>
+          </a:p>
+        </p:txBody>
+      </p:sp>
+      <p:sp>
+        <p:nvSpPr>
+          <p:cNvPr id="52" name="TextBox 51"/>
+          <p:cNvSpPr txBox="1"/>
+          <p:nvPr/>
+        </p:nvSpPr>
+        <p:spPr>
+          <a:xfrm>
+            <a:off x="8231674" y="2454500"/>
+            <a:ext cx="1827198" cy="200000"/>
+          </a:xfrm>
+          <a:prstGeom prst="rect">
+            <a:avLst/>
+          </a:prstGeom>
+          <a:noFill/>
+        </p:spPr>
+        <p:txBody>
+          <a:bodyPr wrap="square" anchor="ctr">
+            <a:spAutoFit/>
+          </a:bodyPr>
+          <a:lstStyle/>
+          <a:p>
+            <a:pPr algn="ctr"/>
+            <a:r>
+              <a:rPr sz="900" b="0">
+                <a:solidFill>
+                  <a:srgbClr val="CCEEEE"/>
+                </a:solidFill>
+                <a:latin typeface="Calibri"/>
+              </a:rPr>
+              <a:t>Rain? → Cool</a:t>
+            </a:r>
+          </a:p>
+        </p:txBody>
+      </p:sp>
+      <p:sp>
+        <p:nvSpPr>
+          <p:cNvPr id="53" name="TextBox 52"/>
+          <p:cNvSpPr txBox="1"/>
+          <p:nvPr/>
+        </p:nvSpPr>
+        <p:spPr>
+          <a:xfrm>
+            <a:off x="8231674" y="2644500"/>
+            <a:ext cx="1827198" cy="200000"/>
+          </a:xfrm>
+          <a:prstGeom prst="rect">
+            <a:avLst/>
+          </a:prstGeom>
+          <a:noFill/>
+        </p:spPr>
+        <p:txBody>
+          <a:bodyPr wrap="square" anchor="ctr">
+            <a:spAutoFit/>
+          </a:bodyPr>
+          <a:lstStyle/>
+          <a:p>
+            <a:pPr algn="ctr"/>
+            <a:r>
+              <a:rPr sz="900" b="0">
+                <a:solidFill>
+                  <a:srgbClr val="CCEEEE"/>
+                </a:solidFill>
+                <a:latin typeface="Calibri"/>
+              </a:rPr>
+              <a:t>Sun? → Warm</a:t>
+            </a:r>
+          </a:p>
+        </p:txBody>
+      </p:sp>
+      <p:sp>
+        <p:nvSpPr>
+          <p:cNvPr id="54" name="Can 53"/>
+          <p:cNvSpPr/>
+          <p:nvPr/>
+        </p:nvSpPr>
+        <p:spPr>
+          <a:xfrm>
+            <a:off x="10103872" y="2204500"/>
+            <a:ext cx="120000" cy="120000"/>
+          </a:xfrm>
+          <a:prstGeom prst="can">
+            <a:avLst/>
+          </a:prstGeom>
+          <a:solidFill>
+            <a:srgbClr val="F4A261"/>
+          </a:solidFill>
+          <a:ln>
+            <a:noFill/>
+          </a:ln>
+        </p:spPr>
+        <p:style>
+          <a:lnRef idx="1">
+            <a:schemeClr val="accent1"/>
+          </a:lnRef>
+          <a:fillRef idx="3">
+            <a:schemeClr val="accent1"/>
+          </a:fillRef>
+          <a:effectRef idx="2">
+            <a:schemeClr val="accent1"/>
+          </a:effectRef>
+          <a:fontRef idx="minor">
+            <a:schemeClr val="lt1"/>
+          </a:fontRef>
+        </p:style>
+        <p:txBody>
+          <a:bodyPr rtlCol="0" anchor="ctr"/>
+          <a:lstStyle/>
+          <a:p>
+            <a:pPr algn="ctr"/>
+          </a:p>
+        </p:txBody>
+      </p:sp>
+      <p:sp>
+        <p:nvSpPr>
+          <p:cNvPr id="55" name="Rectangle 54"/>
+          <p:cNvSpPr/>
+          <p:nvPr/>
+        </p:nvSpPr>
+        <p:spPr>
+          <a:xfrm>
+            <a:off x="10178872" y="1040000"/>
+            <a:ext cx="1887198" cy="2449000"/>
+          </a:xfrm>
+          <a:prstGeom prst="roundRect">
+            <a:avLst>
+              <a:gd name="adj" fmla="val 20000"/>
+            </a:avLst>
+          </a:prstGeom>
+          <a:solidFill>
+            <a:srgbClr val="125555"/>
+          </a:solidFill>
+          <a:ln w="18000">
+            <a:solidFill>
+              <a:srgbClr val="48CAE4"/>
+            </a:solidFill>
+          </a:ln>
+        </p:spPr>
+        <p:style>
+          <a:lnRef idx="1">
+            <a:schemeClr val="accent1"/>
+          </a:lnRef>
+          <a:fillRef idx="3">
+            <a:schemeClr val="accent1"/>
+          </a:fillRef>
+          <a:effectRef idx="2">
+            <a:schemeClr val="accent1"/>
+          </a:effectRef>
+          <a:fontRef idx="minor">
+            <a:schemeClr val="lt1"/>
+          </a:fontRef>
+        </p:style>
+        <p:txBody>
+          <a:bodyPr rtlCol="0" anchor="ctr"/>
+          <a:lstStyle/>
+          <a:p>
+            <a:pPr algn="ctr"/>
+          </a:p>
+        </p:txBody>
+      </p:sp>
+      <p:sp>
+        <p:nvSpPr>
+          <p:cNvPr id="56" name="TextBox 55"/>
+          <p:cNvSpPr txBox="1"/>
+          <p:nvPr/>
+        </p:nvSpPr>
+        <p:spPr>
+          <a:xfrm>
+            <a:off x="10178872" y="1090000"/>
+            <a:ext cx="1887198" cy="220000"/>
+          </a:xfrm>
+          <a:prstGeom prst="rect">
+            <a:avLst/>
+          </a:prstGeom>
+          <a:noFill/>
+        </p:spPr>
+        <p:txBody>
+          <a:bodyPr wrap="square" anchor="ctr">
+            <a:spAutoFit/>
+          </a:bodyPr>
+          <a:lstStyle/>
+          <a:p>
+            <a:pPr algn="ctr"/>
+            <a:r>
+              <a:rPr sz="1300" b="1">
+                <a:solidFill>
+                  <a:srgbClr val="48CAE4"/>
+                </a:solidFill>
+                <a:latin typeface="Calibri"/>
+              </a:rPr>
+              <a:t>Smart Bulb</a:t>
+            </a:r>
+          </a:p>
+        </p:txBody>
+      </p:sp>
+      <p:sp>
+        <p:nvSpPr>
+          <p:cNvPr id="57" name="TextBox 56"/>
+          <p:cNvSpPr txBox="1"/>
+          <p:nvPr/>
+        </p:nvSpPr>
+        <p:spPr>
+          <a:xfrm>
+            <a:off x="10178872" y="1290000"/>
+            <a:ext cx="1887198" cy="220000"/>
+          </a:xfrm>
+          <a:prstGeom prst="rect">
+            <a:avLst/>
+          </a:prstGeom>
+          <a:noFill/>
+        </p:spPr>
+        <p:txBody>
+          <a:bodyPr wrap="square" anchor="ctr">
+            <a:spAutoFit/>
+          </a:bodyPr>
+          <a:lstStyle/>
+          <a:p>
+            <a:pPr algn="ctr"/>
+            <a:r>
+              <a:rPr sz="1100" b="0">
+                <a:solidFill>
+                  <a:srgbClr val="FFFFFF"/>
+                </a:solidFill>
+                <a:latin typeface="Calibri"/>
+              </a:rPr>
+              <a:t>Glow</a:t>
+            </a:r>
+          </a:p>
+        </p:txBody>
+      </p:sp>
+      <p:sp>
+        <p:nvSpPr>
+          <p:cNvPr id="58" name="TextBox 57"/>
+          <p:cNvSpPr txBox="1"/>
+          <p:nvPr/>
+        </p:nvSpPr>
+        <p:spPr>
+          <a:xfrm>
+            <a:off x="10208872" y="2264500"/>
+            <a:ext cx="1827198" cy="200000"/>
+          </a:xfrm>
+          <a:prstGeom prst="rect">
+            <a:avLst/>
+          </a:prstGeom>
+          <a:noFill/>
+        </p:spPr>
+        <p:txBody>
+          <a:bodyPr wrap="square" anchor="ctr">
+            <a:spAutoFit/>
+          </a:bodyPr>
+          <a:lstStyle/>
+          <a:p>
+            <a:pPr algn="ctr"/>
+            <a:r>
+              <a:rPr sz="900" b="0">
+                <a:solidFill>
+                  <a:srgbClr val="CCEEEE"/>
+                </a:solidFill>
+                <a:latin typeface="Calibri"/>
+              </a:rPr>
+              <a:t>Ambient signal</a:t>
+            </a:r>
+          </a:p>
+        </p:txBody>
+      </p:sp>
+      <p:sp>
+        <p:nvSpPr>
+          <p:cNvPr id="59" name="TextBox 58"/>
+          <p:cNvSpPr txBox="1"/>
+          <p:nvPr/>
+        </p:nvSpPr>
+        <p:spPr>
+          <a:xfrm>
+            <a:off x="10208872" y="2454500"/>
+            <a:ext cx="1827198" cy="200000"/>
+          </a:xfrm>
+          <a:prstGeom prst="rect">
+            <a:avLst/>
+          </a:prstGeom>
+          <a:noFill/>
+        </p:spPr>
+        <p:txBody>
+          <a:bodyPr wrap="square" anchor="ctr">
+            <a:spAutoFit/>
+          </a:bodyPr>
+          <a:lstStyle/>
+          <a:p>
+            <a:pPr algn="ctr"/>
+            <a:r>
+              <a:rPr sz="900" b="0">
+                <a:solidFill>
+                  <a:srgbClr val="CCEEEE"/>
+                </a:solidFill>
+                <a:latin typeface="Calibri"/>
+              </a:rPr>
+              <a:t>no notification</a:t>
+            </a:r>
+          </a:p>
+        </p:txBody>
+      </p:sp>
+      <p:sp>
+        <p:nvSpPr>
+          <p:cNvPr id="60" name="TextBox 59"/>
+          <p:cNvSpPr txBox="1"/>
+          <p:nvPr/>
+        </p:nvSpPr>
+        <p:spPr>
+          <a:xfrm>
+            <a:off x="10208872" y="2644500"/>
+            <a:ext cx="1827198" cy="200000"/>
+          </a:xfrm>
+          <a:prstGeom prst="rect">
+            <a:avLst/>
+          </a:prstGeom>
+          <a:noFill/>
+        </p:spPr>
+        <p:txBody>
+          <a:bodyPr wrap="square" anchor="ctr">
+            <a:spAutoFit/>
+          </a:bodyPr>
+          <a:lstStyle/>
+          <a:p>
+            <a:pPr algn="ctr"/>
+            <a:r>
+              <a:rPr sz="900" b="0">
+                <a:solidFill>
+                  <a:srgbClr val="CCEEEE"/>
+                </a:solidFill>
+                <a:latin typeface="Calibri"/>
+              </a:rPr>
+              <a:t>no buzz</a:t>
+            </a:r>
+          </a:p>
+        </p:txBody>
+      </p:sp>
+      <p:sp>
+        <p:nvSpPr>
+          <p:cNvPr id="61" name="TextBox 60"/>
+          <p:cNvSpPr txBox="1"/>
+          <p:nvPr/>
+        </p:nvSpPr>
+        <p:spPr>
+          <a:xfrm>
+            <a:off x="6224476" y="3504000"/>
+            <a:ext cx="5701596" cy="130000"/>
+          </a:xfrm>
+          <a:prstGeom prst="rect">
+            <a:avLst/>
+          </a:prstGeom>
+          <a:noFill/>
+        </p:spPr>
+        <p:txBody>
+          <a:bodyPr wrap="square" anchor="ctr">
+            <a:spAutoFit/>
+          </a:bodyPr>
+          <a:lstStyle/>
+          <a:p>
+            <a:pPr algn="ctr"/>
+            <a:r>
+              <a:rPr sz="900" b="1">
+                <a:solidFill>
+                  <a:srgbClr val="F4A261"/>
+                </a:solidFill>
+                <a:latin typeface="Calibri"/>
+              </a:rPr>
+              <a:t>Runs 24/7 on Raspberry Pi  •  No phone needed  •  Built in Week 4–5</a:t>
+            </a:r>
+          </a:p>
+        </p:txBody>
+      </p:sp>
+      <p:sp>
+        <p:nvSpPr>
+          <p:cNvPr id="62" name="Rectangle 61"/>
+          <p:cNvSpPr/>
+          <p:nvPr/>
+        </p:nvSpPr>
+        <p:spPr>
+          <a:xfrm>
+            <a:off x="182880" y="3749000"/>
+            <a:ext cx="5861596" cy="2979000"/>
+          </a:xfrm>
+          <a:prstGeom prst="roundRect">
+            <a:avLst>
+              <a:gd name="adj" fmla="val 20000"/>
+            </a:avLst>
+          </a:prstGeom>
+          <a:solidFill>
+            <a:srgbClr val="0A4A4A"/>
+          </a:solidFill>
+          <a:ln w="9144">
+            <a:solidFill>
+              <a:srgbClr val="1A6B6B"/>
+            </a:solidFill>
+          </a:ln>
+        </p:spPr>
+        <p:style>
+          <a:lnRef idx="1">
+            <a:schemeClr val="accent1"/>
+          </a:lnRef>
+          <a:fillRef idx="3">
+            <a:schemeClr val="accent1"/>
+          </a:fillRef>
+          <a:effectRef idx="2">
+            <a:schemeClr val="accent1"/>
+          </a:effectRef>
+          <a:fontRef idx="minor">
+            <a:schemeClr val="lt1"/>
+          </a:fontRef>
+        </p:style>
+        <p:txBody>
+          <a:bodyPr rtlCol="0" anchor="ctr"/>
+          <a:lstStyle/>
+          <a:p>
+            <a:pPr algn="ctr"/>
+          </a:p>
+        </p:txBody>
+      </p:sp>
+      <p:sp>
+        <p:nvSpPr>
+          <p:cNvPr id="63" name="Rectangle 62"/>
+          <p:cNvSpPr/>
+          <p:nvPr/>
+        </p:nvSpPr>
+        <p:spPr>
+          <a:xfrm>
+            <a:off x="242880" y="3809000"/>
+            <a:ext cx="50000" cy="280000"/>
+          </a:xfrm>
+          <a:prstGeom prst="rect">
+            <a:avLst/>
+          </a:prstGeom>
+          <a:solidFill>
+            <a:srgbClr val="48CAE4"/>
+          </a:solidFill>
+          <a:ln>
+            <a:noFill/>
+          </a:ln>
+        </p:spPr>
+        <p:style>
+          <a:lnRef idx="1">
+            <a:schemeClr val="accent1"/>
+          </a:lnRef>
+          <a:fillRef idx="3">
+            <a:schemeClr val="accent1"/>
+          </a:fillRef>
+          <a:effectRef idx="2">
+            <a:schemeClr val="accent1"/>
+          </a:effectRef>
+          <a:fontRef idx="minor">
+            <a:schemeClr val="lt1"/>
+          </a:fontRef>
+        </p:style>
+        <p:txBody>
+          <a:bodyPr rtlCol="0" anchor="ctr"/>
+          <a:lstStyle/>
+          <a:p>
+            <a:pPr algn="ctr"/>
+          </a:p>
+        </p:txBody>
+      </p:sp>
+      <p:sp>
+        <p:nvSpPr>
+          <p:cNvPr id="64" name="Oval 63"/>
+          <p:cNvSpPr/>
+          <p:nvPr/>
+        </p:nvSpPr>
+        <p:spPr>
+          <a:xfrm>
+            <a:off x="242880" y="3809000"/>
+            <a:ext cx="280000" cy="280000"/>
+          </a:xfrm>
+          <a:prstGeom prst="ellipse">
+            <a:avLst/>
+          </a:prstGeom>
+          <a:solidFill>
+            <a:srgbClr val="48CAE4"/>
+          </a:solidFill>
+          <a:ln>
+            <a:noFill/>
+          </a:ln>
+        </p:spPr>
+        <p:style>
+          <a:lnRef idx="1">
+            <a:schemeClr val="accent1"/>
+          </a:lnRef>
+          <a:fillRef idx="3">
+            <a:schemeClr val="accent1"/>
+          </a:fillRef>
+          <a:effectRef idx="2">
+            <a:schemeClr val="accent1"/>
+          </a:effectRef>
+          <a:fontRef idx="minor">
+            <a:schemeClr val="lt1"/>
+          </a:fontRef>
+        </p:style>
+        <p:txBody>
+          <a:bodyPr rtlCol="0" anchor="ctr"/>
+          <a:lstStyle/>
+          <a:p>
+            <a:pPr algn="ctr"/>
+          </a:p>
+        </p:txBody>
+      </p:sp>
+      <p:sp>
+        <p:nvSpPr>
+          <p:cNvPr id="65" name="TextBox 64"/>
+          <p:cNvSpPr txBox="1"/>
+          <p:nvPr/>
+        </p:nvSpPr>
+        <p:spPr>
+          <a:xfrm>
+            <a:off x="452880" y="3869000"/>
+            <a:ext cx="5521596" cy="250000"/>
+          </a:xfrm>
+          <a:prstGeom prst="rect">
+            <a:avLst/>
+          </a:prstGeom>
+          <a:noFill/>
+        </p:spPr>
+        <p:txBody>
+          <a:bodyPr wrap="square" anchor="ctr">
+            <a:spAutoFit/>
+          </a:bodyPr>
+          <a:lstStyle/>
+          <a:p>
+            <a:pPr algn="l"/>
+            <a:r>
+              <a:rPr sz="2000" b="0">
+                <a:solidFill>
+                  <a:srgbClr val="FFFFFF"/>
+                </a:solidFill>
+                <a:latin typeface="Calibri"/>
+              </a:rPr>
+              <a:t>📅</a:t>
+            </a:r>
+          </a:p>
+        </p:txBody>
+      </p:sp>
+      <p:sp>
+        <p:nvSpPr>
+          <p:cNvPr id="66" name="TextBox 65"/>
+          <p:cNvSpPr txBox="1"/>
+          <p:nvPr/>
+        </p:nvSpPr>
+        <p:spPr>
+          <a:xfrm>
+            <a:off x="592880" y="3859000"/>
+            <a:ext cx="5381596" cy="280000"/>
+          </a:xfrm>
+          <a:prstGeom prst="rect">
+            <a:avLst/>
+          </a:prstGeom>
+          <a:noFill/>
+        </p:spPr>
+        <p:txBody>
+          <a:bodyPr wrap="square" anchor="ctr">
+            <a:spAutoFit/>
+          </a:bodyPr>
+          <a:lstStyle/>
+          <a:p>
+            <a:pPr algn="l"/>
+            <a:r>
+              <a:rPr sz="1400" b="1">
+                <a:solidFill>
+                  <a:srgbClr val="FFFFFF"/>
+                </a:solidFill>
+                <a:latin typeface="Calibri"/>
+              </a:rPr>
+              <a:t>12-Week Learning Roadmap</a:t>
+            </a:r>
+          </a:p>
+        </p:txBody>
+      </p:sp>
+      <p:sp>
+        <p:nvSpPr>
+          <p:cNvPr id="67" name="Rectangle 66"/>
+          <p:cNvSpPr/>
+          <p:nvPr/>
+        </p:nvSpPr>
+        <p:spPr>
+          <a:xfrm>
+            <a:off x="347880" y="4119000"/>
+            <a:ext cx="30000" cy="2549000"/>
+          </a:xfrm>
+          <a:prstGeom prst="rect">
+            <a:avLst/>
+          </a:prstGeom>
+          <a:solidFill>
+            <a:srgbClr val="1A6B6B"/>
+          </a:solidFill>
+          <a:ln>
+            <a:noFill/>
+          </a:ln>
+        </p:spPr>
+        <p:style>
+          <a:lnRef idx="1">
+            <a:schemeClr val="accent1"/>
+          </a:lnRef>
+          <a:fillRef idx="3">
+            <a:schemeClr val="accent1"/>
+          </a:fillRef>
+          <a:effectRef idx="2">
+            <a:schemeClr val="accent1"/>
+          </a:effectRef>
+          <a:fontRef idx="minor">
+            <a:schemeClr val="lt1"/>
+          </a:fontRef>
+        </p:style>
+        <p:txBody>
+          <a:bodyPr rtlCol="0" anchor="ctr"/>
+          <a:lstStyle/>
+          <a:p>
+            <a:pPr algn="ctr"/>
+          </a:p>
+        </p:txBody>
+      </p:sp>
+      <p:sp>
+        <p:nvSpPr>
+          <p:cNvPr id="68" name="Oval 67"/>
+          <p:cNvSpPr/>
+          <p:nvPr/>
+        </p:nvSpPr>
+        <p:spPr>
+          <a:xfrm>
+            <a:off x="232880" y="4313875"/>
+            <a:ext cx="260000" cy="260000"/>
+          </a:xfrm>
+          <a:prstGeom prst="ellipse">
+            <a:avLst/>
+          </a:prstGeom>
+          <a:solidFill>
+            <a:srgbClr val="F4A261"/>
+          </a:solidFill>
+          <a:ln>
+            <a:noFill/>
+          </a:ln>
+        </p:spPr>
+        <p:style>
+          <a:lnRef idx="1">
+            <a:schemeClr val="accent1"/>
+          </a:lnRef>
+          <a:fillRef idx="3">
+            <a:schemeClr val="accent1"/>
+          </a:fillRef>
+          <a:effectRef idx="2">
+            <a:schemeClr val="accent1"/>
+          </a:effectRef>
+          <a:fontRef idx="minor">
+            <a:schemeClr val="lt1"/>
+          </a:fontRef>
+        </p:style>
+        <p:txBody>
+          <a:bodyPr rtlCol="0" anchor="ctr"/>
+          <a:lstStyle/>
+          <a:p>
+            <a:pPr algn="ctr"/>
+          </a:p>
+        </p:txBody>
+      </p:sp>
+      <p:sp>
+        <p:nvSpPr>
+          <p:cNvPr id="69" name="TextBox 68"/>
+          <p:cNvSpPr txBox="1"/>
+          <p:nvPr/>
+        </p:nvSpPr>
+        <p:spPr>
+          <a:xfrm>
+            <a:off x="262880" y="4293875"/>
+            <a:ext cx="230000" cy="140000"/>
+          </a:xfrm>
+          <a:prstGeom prst="rect">
+            <a:avLst/>
+          </a:prstGeom>
+          <a:noFill/>
+        </p:spPr>
+        <p:txBody>
+          <a:bodyPr wrap="square" anchor="ctr">
+            <a:spAutoFit/>
+          </a:bodyPr>
+          <a:lstStyle/>
+          <a:p>
+            <a:pPr algn="ctr"/>
+            <a:r>
+              <a:rPr sz="750" b="1">
+                <a:solidFill>
+                  <a:srgbClr val="F4A261"/>
+                </a:solidFill>
+                <a:latin typeface="Calibri"/>
+              </a:rPr>
+              <a:t>Weeks 1–3</a:t>
+            </a:r>
+          </a:p>
+        </p:txBody>
+      </p:sp>
+      <p:sp>
+        <p:nvSpPr>
+          <p:cNvPr id="70" name="TextBox 69"/>
+          <p:cNvSpPr txBox="1"/>
+          <p:nvPr/>
+        </p:nvSpPr>
+        <p:spPr>
+          <a:xfrm>
+            <a:off x="532880" y="4353875"/>
+            <a:ext cx="5431596" cy="200000"/>
+          </a:xfrm>
+          <a:prstGeom prst="rect">
+            <a:avLst/>
+          </a:prstGeom>
+          <a:noFill/>
+        </p:spPr>
+        <p:txBody>
+          <a:bodyPr wrap="square" anchor="ctr">
+            <a:spAutoFit/>
+          </a:bodyPr>
+          <a:lstStyle/>
+          <a:p>
+            <a:pPr algn="l"/>
+            <a:r>
+              <a:rPr sz="1200" b="1">
+                <a:solidFill>
+                  <a:srgbClr val="F4A261"/>
+                </a:solidFill>
+                <a:latin typeface="Calibri"/>
+              </a:rPr>
+              <a:t>Foundations</a:t>
+            </a:r>
+          </a:p>
+        </p:txBody>
+      </p:sp>
+      <p:sp>
+        <p:nvSpPr>
+          <p:cNvPr id="71" name="TextBox 70"/>
+          <p:cNvSpPr txBox="1"/>
+          <p:nvPr/>
+        </p:nvSpPr>
+        <p:spPr>
+          <a:xfrm>
+            <a:off x="532880" y="4523875"/>
+            <a:ext cx="5431596" cy="180000"/>
+          </a:xfrm>
+          <a:prstGeom prst="rect">
+            <a:avLst/>
+          </a:prstGeom>
+          <a:noFill/>
+        </p:spPr>
+        <p:txBody>
+          <a:bodyPr wrap="square" anchor="t">
+            <a:spAutoFit/>
+          </a:bodyPr>
+          <a:lstStyle/>
+          <a:p>
+            <a:pPr algn="l"/>
+            <a:r>
+              <a:rPr sz="850" b="0">
+                <a:solidFill>
+                  <a:srgbClr val="CCEEEE"/>
+                </a:solidFill>
+                <a:latin typeface="Calibri"/>
+              </a:rPr>
+              <a:t>Python  •  Raspberry Pi  •  Sensors  •  MQTT</a:t>
+            </a:r>
+          </a:p>
+        </p:txBody>
+      </p:sp>
+      <p:sp>
+        <p:nvSpPr>
+          <p:cNvPr id="72" name="Oval 71"/>
+          <p:cNvSpPr/>
+          <p:nvPr/>
+        </p:nvSpPr>
+        <p:spPr>
+          <a:xfrm>
+            <a:off x="232880" y="4963625"/>
+            <a:ext cx="260000" cy="260000"/>
+          </a:xfrm>
+          <a:prstGeom prst="ellipse">
+            <a:avLst/>
+          </a:prstGeom>
+          <a:solidFill>
+            <a:srgbClr val="2EC4B6"/>
+          </a:solidFill>
+          <a:ln>
+            <a:noFill/>
+          </a:ln>
+        </p:spPr>
+        <p:style>
+          <a:lnRef idx="1">
+            <a:schemeClr val="accent1"/>
+          </a:lnRef>
+          <a:fillRef idx="3">
+            <a:schemeClr val="accent1"/>
+          </a:fillRef>
+          <a:effectRef idx="2">
+            <a:schemeClr val="accent1"/>
+          </a:effectRef>
+          <a:fontRef idx="minor">
+            <a:schemeClr val="lt1"/>
+          </a:fontRef>
+        </p:style>
+        <p:txBody>
+          <a:bodyPr rtlCol="0" anchor="ctr"/>
+          <a:lstStyle/>
+          <a:p>
+            <a:pPr algn="ctr"/>
+          </a:p>
+        </p:txBody>
+      </p:sp>
+      <p:sp>
+        <p:nvSpPr>
+          <p:cNvPr id="73" name="TextBox 72"/>
+          <p:cNvSpPr txBox="1"/>
+          <p:nvPr/>
+        </p:nvSpPr>
+        <p:spPr>
+          <a:xfrm>
+            <a:off x="262880" y="4943625"/>
+            <a:ext cx="230000" cy="140000"/>
+          </a:xfrm>
+          <a:prstGeom prst="rect">
+            <a:avLst/>
+          </a:prstGeom>
+          <a:noFill/>
+        </p:spPr>
+        <p:txBody>
+          <a:bodyPr wrap="square" anchor="ctr">
+            <a:spAutoFit/>
+          </a:bodyPr>
+          <a:lstStyle/>
+          <a:p>
+            <a:pPr algn="ctr"/>
+            <a:r>
+              <a:rPr sz="750" b="1">
+                <a:solidFill>
+                  <a:srgbClr val="2EC4B6"/>
+                </a:solidFill>
+                <a:latin typeface="Calibri"/>
+              </a:rPr>
+              <a:t>Weeks 4–6</a:t>
+            </a:r>
+          </a:p>
+        </p:txBody>
+      </p:sp>
+      <p:sp>
+        <p:nvSpPr>
+          <p:cNvPr id="74" name="TextBox 73"/>
+          <p:cNvSpPr txBox="1"/>
+          <p:nvPr/>
+        </p:nvSpPr>
+        <p:spPr>
+          <a:xfrm>
+            <a:off x="532880" y="5003625"/>
+            <a:ext cx="5431596" cy="200000"/>
+          </a:xfrm>
+          <a:prstGeom prst="rect">
+            <a:avLst/>
+          </a:prstGeom>
+          <a:noFill/>
+        </p:spPr>
+        <p:txBody>
+          <a:bodyPr wrap="square" anchor="ctr">
+            <a:spAutoFit/>
+          </a:bodyPr>
+          <a:lstStyle/>
+          <a:p>
+            <a:pPr algn="l"/>
+            <a:r>
+              <a:rPr sz="1200" b="1">
+                <a:solidFill>
+                  <a:srgbClr val="2EC4B6"/>
+                </a:solidFill>
+                <a:latin typeface="Calibri"/>
+              </a:rPr>
+              <a:t>IoT Devices</a:t>
+            </a:r>
+          </a:p>
+        </p:txBody>
+      </p:sp>
+      <p:sp>
+        <p:nvSpPr>
+          <p:cNvPr id="75" name="TextBox 74"/>
+          <p:cNvSpPr txBox="1"/>
+          <p:nvPr/>
+        </p:nvSpPr>
+        <p:spPr>
+          <a:xfrm>
+            <a:off x="532880" y="5173625"/>
+            <a:ext cx="5431596" cy="180000"/>
+          </a:xfrm>
+          <a:prstGeom prst="rect">
+            <a:avLst/>
+          </a:prstGeom>
+          <a:noFill/>
+        </p:spPr>
+        <p:txBody>
+          <a:bodyPr wrap="square" anchor="t">
+            <a:spAutoFit/>
+          </a:bodyPr>
+          <a:lstStyle/>
+          <a:p>
+            <a:pPr algn="l"/>
+            <a:r>
+              <a:rPr sz="850" b="0">
+                <a:solidFill>
+                  <a:srgbClr val="CCEEEE"/>
+                </a:solidFill>
+                <a:latin typeface="Calibri"/>
+              </a:rPr>
+              <a:t>ZigBee  •  Smart Bulbs  •  APIs  •  Grafana</a:t>
+            </a:r>
+          </a:p>
+        </p:txBody>
+      </p:sp>
+      <p:sp>
+        <p:nvSpPr>
+          <p:cNvPr id="76" name="Oval 75"/>
+          <p:cNvSpPr/>
+          <p:nvPr/>
+        </p:nvSpPr>
+        <p:spPr>
+          <a:xfrm>
+            <a:off x="232880" y="5613375"/>
+            <a:ext cx="260000" cy="260000"/>
+          </a:xfrm>
+          <a:prstGeom prst="ellipse">
+            <a:avLst/>
+          </a:prstGeom>
+          <a:solidFill>
+            <a:srgbClr val="48CAE4"/>
+          </a:solidFill>
+          <a:ln>
+            <a:noFill/>
+          </a:ln>
+        </p:spPr>
+        <p:style>
+          <a:lnRef idx="1">
+            <a:schemeClr val="accent1"/>
+          </a:lnRef>
+          <a:fillRef idx="3">
+            <a:schemeClr val="accent1"/>
+          </a:fillRef>
+          <a:effectRef idx="2">
+            <a:schemeClr val="accent1"/>
+          </a:effectRef>
+          <a:fontRef idx="minor">
+            <a:schemeClr val="lt1"/>
+          </a:fontRef>
+        </p:style>
+        <p:txBody>
+          <a:bodyPr rtlCol="0" anchor="ctr"/>
+          <a:lstStyle/>
+          <a:p>
+            <a:pPr algn="ctr"/>
+          </a:p>
+        </p:txBody>
+      </p:sp>
+      <p:sp>
+        <p:nvSpPr>
+          <p:cNvPr id="77" name="TextBox 76"/>
+          <p:cNvSpPr txBox="1"/>
+          <p:nvPr/>
+        </p:nvSpPr>
+        <p:spPr>
+          <a:xfrm>
+            <a:off x="262880" y="5593375"/>
+            <a:ext cx="230000" cy="140000"/>
+          </a:xfrm>
+          <a:prstGeom prst="rect">
+            <a:avLst/>
+          </a:prstGeom>
+          <a:noFill/>
+        </p:spPr>
+        <p:txBody>
+          <a:bodyPr wrap="square" anchor="ctr">
+            <a:spAutoFit/>
+          </a:bodyPr>
+          <a:lstStyle/>
+          <a:p>
+            <a:pPr algn="ctr"/>
+            <a:r>
+              <a:rPr sz="750" b="1">
+                <a:solidFill>
+                  <a:srgbClr val="48CAE4"/>
+                </a:solidFill>
+                <a:latin typeface="Calibri"/>
+              </a:rPr>
+              <a:t>Weeks 7–9</a:t>
+            </a:r>
+          </a:p>
+        </p:txBody>
+      </p:sp>
+      <p:sp>
+        <p:nvSpPr>
+          <p:cNvPr id="78" name="TextBox 77"/>
+          <p:cNvSpPr txBox="1"/>
+          <p:nvPr/>
+        </p:nvSpPr>
+        <p:spPr>
+          <a:xfrm>
+            <a:off x="532880" y="5653375"/>
+            <a:ext cx="5431596" cy="200000"/>
+          </a:xfrm>
+          <a:prstGeom prst="rect">
+            <a:avLst/>
+          </a:prstGeom>
+          <a:noFill/>
+        </p:spPr>
+        <p:txBody>
+          <a:bodyPr wrap="square" anchor="ctr">
+            <a:spAutoFit/>
+          </a:bodyPr>
+          <a:lstStyle/>
+          <a:p>
+            <a:pPr algn="l"/>
+            <a:r>
+              <a:rPr sz="1200" b="1">
+                <a:solidFill>
+                  <a:srgbClr val="48CAE4"/>
+                </a:solidFill>
+                <a:latin typeface="Calibri"/>
+              </a:rPr>
+              <a:t>System Build</a:t>
+            </a:r>
+          </a:p>
+        </p:txBody>
+      </p:sp>
+      <p:sp>
+        <p:nvSpPr>
+          <p:cNvPr id="79" name="TextBox 78"/>
+          <p:cNvSpPr txBox="1"/>
+          <p:nvPr/>
+        </p:nvSpPr>
+        <p:spPr>
+          <a:xfrm>
+            <a:off x="532880" y="5823375"/>
+            <a:ext cx="5431596" cy="180000"/>
+          </a:xfrm>
+          <a:prstGeom prst="rect">
+            <a:avLst/>
+          </a:prstGeom>
+          <a:noFill/>
+        </p:spPr>
+        <p:txBody>
+          <a:bodyPr wrap="square" anchor="t">
+            <a:spAutoFit/>
+          </a:bodyPr>
+          <a:lstStyle/>
+          <a:p>
+            <a:pPr algn="l"/>
+            <a:r>
+              <a:rPr sz="850" b="0">
+                <a:solidFill>
+                  <a:srgbClr val="CCEEEE"/>
+                </a:solidFill>
+                <a:latin typeface="Calibri"/>
+              </a:rPr>
+              <a:t>Device Registry  •  Scheduler  •  MQTT Brain</a:t>
+            </a:r>
+          </a:p>
+        </p:txBody>
+      </p:sp>
+      <p:sp>
+        <p:nvSpPr>
+          <p:cNvPr id="80" name="Oval 79"/>
+          <p:cNvSpPr/>
+          <p:nvPr/>
+        </p:nvSpPr>
+        <p:spPr>
+          <a:xfrm>
+            <a:off x="232880" y="6263125"/>
+            <a:ext cx="260000" cy="260000"/>
+          </a:xfrm>
+          <a:prstGeom prst="ellipse">
+            <a:avLst/>
+          </a:prstGeom>
+          <a:solidFill>
+            <a:srgbClr val="84B59F"/>
+          </a:solidFill>
+          <a:ln>
+            <a:noFill/>
+          </a:ln>
+        </p:spPr>
+        <p:style>
+          <a:lnRef idx="1">
+            <a:schemeClr val="accent1"/>
+          </a:lnRef>
+          <a:fillRef idx="3">
+            <a:schemeClr val="accent1"/>
+          </a:fillRef>
+          <a:effectRef idx="2">
+            <a:schemeClr val="accent1"/>
+          </a:effectRef>
+          <a:fontRef idx="minor">
+            <a:schemeClr val="lt1"/>
+          </a:fontRef>
+        </p:style>
+        <p:txBody>
+          <a:bodyPr rtlCol="0" anchor="ctr"/>
+          <a:lstStyle/>
+          <a:p>
+            <a:pPr algn="ctr"/>
+          </a:p>
+        </p:txBody>
+      </p:sp>
+      <p:sp>
+        <p:nvSpPr>
+          <p:cNvPr id="81" name="TextBox 80"/>
+          <p:cNvSpPr txBox="1"/>
+          <p:nvPr/>
+        </p:nvSpPr>
+        <p:spPr>
+          <a:xfrm>
+            <a:off x="262880" y="6243125"/>
+            <a:ext cx="230000" cy="140000"/>
+          </a:xfrm>
+          <a:prstGeom prst="rect">
+            <a:avLst/>
+          </a:prstGeom>
+          <a:noFill/>
+        </p:spPr>
+        <p:txBody>
+          <a:bodyPr wrap="square" anchor="ctr">
+            <a:spAutoFit/>
+          </a:bodyPr>
+          <a:lstStyle/>
+          <a:p>
+            <a:pPr algn="ctr"/>
+            <a:r>
+              <a:rPr sz="750" b="1">
+                <a:solidFill>
+                  <a:srgbClr val="84B59F"/>
+                </a:solidFill>
+                <a:latin typeface="Calibri"/>
+              </a:rPr>
+              <a:t>Weeks 10–12</a:t>
+            </a:r>
+          </a:p>
+        </p:txBody>
+      </p:sp>
+      <p:sp>
+        <p:nvSpPr>
+          <p:cNvPr id="82" name="TextBox 81"/>
+          <p:cNvSpPr txBox="1"/>
+          <p:nvPr/>
+        </p:nvSpPr>
+        <p:spPr>
+          <a:xfrm>
+            <a:off x="532880" y="6303125"/>
+            <a:ext cx="5431596" cy="200000"/>
+          </a:xfrm>
+          <a:prstGeom prst="rect">
+            <a:avLst/>
+          </a:prstGeom>
+          <a:noFill/>
+        </p:spPr>
+        <p:txBody>
+          <a:bodyPr wrap="square" anchor="ctr">
+            <a:spAutoFit/>
+          </a:bodyPr>
+          <a:lstStyle/>
+          <a:p>
+            <a:pPr algn="l"/>
+            <a:r>
+              <a:rPr sz="1200" b="1">
+                <a:solidFill>
+                  <a:srgbClr val="84B59F"/>
+                </a:solidFill>
+                <a:latin typeface="Calibri"/>
+              </a:rPr>
+              <a:t>Contribute</a:t>
+            </a:r>
+          </a:p>
+        </p:txBody>
+      </p:sp>
+      <p:sp>
+        <p:nvSpPr>
+          <p:cNvPr id="83" name="TextBox 82"/>
+          <p:cNvSpPr txBox="1"/>
+          <p:nvPr/>
+        </p:nvSpPr>
+        <p:spPr>
+          <a:xfrm>
+            <a:off x="532880" y="6473125"/>
+            <a:ext cx="5431596" cy="180000"/>
+          </a:xfrm>
+          <a:prstGeom prst="rect">
+            <a:avLst/>
+          </a:prstGeom>
+          <a:noFill/>
+        </p:spPr>
+        <p:txBody>
+          <a:bodyPr wrap="square" anchor="t">
+            <a:spAutoFit/>
+          </a:bodyPr>
+          <a:lstStyle/>
+          <a:p>
+            <a:pPr algn="l"/>
+            <a:r>
+              <a:rPr sz="850" b="0">
+                <a:solidFill>
+                  <a:srgbClr val="CCEEEE"/>
+                </a:solidFill>
+                <a:latin typeface="Calibri"/>
+              </a:rPr>
+              <a:t>Experiments  •  GitHub PR  •  Research Report</a:t>
+            </a:r>
+          </a:p>
+        </p:txBody>
+      </p:sp>
+      <p:sp>
+        <p:nvSpPr>
+          <p:cNvPr id="84" name="Rectangle 83"/>
+          <p:cNvSpPr/>
+          <p:nvPr/>
+        </p:nvSpPr>
+        <p:spPr>
+          <a:xfrm>
+            <a:off x="6144476" y="3749000"/>
+            <a:ext cx="5861596" cy="2979000"/>
+          </a:xfrm>
+          <a:prstGeom prst="roundRect">
+            <a:avLst>
+              <a:gd name="adj" fmla="val 20000"/>
+            </a:avLst>
+          </a:prstGeom>
+          <a:solidFill>
+            <a:srgbClr val="0A4A4A"/>
+          </a:solidFill>
+          <a:ln w="9144">
+            <a:solidFill>
+              <a:srgbClr val="1A6B6B"/>
+            </a:solidFill>
+          </a:ln>
+        </p:spPr>
+        <p:style>
+          <a:lnRef idx="1">
+            <a:schemeClr val="accent1"/>
+          </a:lnRef>
+          <a:fillRef idx="3">
+            <a:schemeClr val="accent1"/>
+          </a:fillRef>
+          <a:effectRef idx="2">
+            <a:schemeClr val="accent1"/>
+          </a:effectRef>
+          <a:fontRef idx="minor">
+            <a:schemeClr val="lt1"/>
+          </a:fontRef>
+        </p:style>
+        <p:txBody>
+          <a:bodyPr rtlCol="0" anchor="ctr"/>
+          <a:lstStyle/>
+          <a:p>
+            <a:pPr algn="ctr"/>
+          </a:p>
+        </p:txBody>
+      </p:sp>
+      <p:sp>
+        <p:nvSpPr>
+          <p:cNvPr id="85" name="Rectangle 84"/>
+          <p:cNvSpPr/>
+          <p:nvPr/>
+        </p:nvSpPr>
+        <p:spPr>
+          <a:xfrm>
+            <a:off x="6204476" y="3809000"/>
+            <a:ext cx="50000" cy="280000"/>
+          </a:xfrm>
+          <a:prstGeom prst="rect">
+            <a:avLst/>
+          </a:prstGeom>
+          <a:solidFill>
+            <a:srgbClr val="84B59F"/>
+          </a:solidFill>
+          <a:ln>
+            <a:noFill/>
+          </a:ln>
+        </p:spPr>
+        <p:style>
+          <a:lnRef idx="1">
+            <a:schemeClr val="accent1"/>
+          </a:lnRef>
+          <a:fillRef idx="3">
+            <a:schemeClr val="accent1"/>
+          </a:fillRef>
+          <a:effectRef idx="2">
+            <a:schemeClr val="accent1"/>
+          </a:effectRef>
+          <a:fontRef idx="minor">
+            <a:schemeClr val="lt1"/>
+          </a:fontRef>
+        </p:style>
+        <p:txBody>
+          <a:bodyPr rtlCol="0" anchor="ctr"/>
+          <a:lstStyle/>
+          <a:p>
+            <a:pPr algn="ctr"/>
+          </a:p>
+        </p:txBody>
+      </p:sp>
+      <p:sp>
+        <p:nvSpPr>
+          <p:cNvPr id="86" name="Oval 85"/>
+          <p:cNvSpPr/>
+          <p:nvPr/>
+        </p:nvSpPr>
+        <p:spPr>
+          <a:xfrm>
+            <a:off x="6204476" y="3809000"/>
+            <a:ext cx="280000" cy="280000"/>
+          </a:xfrm>
+          <a:prstGeom prst="ellipse">
+            <a:avLst/>
+          </a:prstGeom>
+          <a:solidFill>
+            <a:srgbClr val="84B59F"/>
+          </a:solidFill>
+          <a:ln>
+            <a:noFill/>
+          </a:ln>
+        </p:spPr>
+        <p:style>
+          <a:lnRef idx="1">
+            <a:schemeClr val="accent1"/>
+          </a:lnRef>
+          <a:fillRef idx="3">
+            <a:schemeClr val="accent1"/>
+          </a:fillRef>
+          <a:effectRef idx="2">
+            <a:schemeClr val="accent1"/>
+          </a:effectRef>
+          <a:fontRef idx="minor">
+            <a:schemeClr val="lt1"/>
+          </a:fontRef>
+        </p:style>
+        <p:txBody>
+          <a:bodyPr rtlCol="0" anchor="ctr"/>
+          <a:lstStyle/>
+          <a:p>
+            <a:pPr algn="ctr"/>
+          </a:p>
+        </p:txBody>
+      </p:sp>
+      <p:sp>
+        <p:nvSpPr>
+          <p:cNvPr id="87" name="TextBox 86"/>
+          <p:cNvSpPr txBox="1"/>
+          <p:nvPr/>
+        </p:nvSpPr>
+        <p:spPr>
+          <a:xfrm>
+            <a:off x="6414476" y="3869000"/>
+            <a:ext cx="5521596" cy="250000"/>
+          </a:xfrm>
+          <a:prstGeom prst="rect">
+            <a:avLst/>
+          </a:prstGeom>
+          <a:noFill/>
+        </p:spPr>
+        <p:txBody>
+          <a:bodyPr wrap="square" anchor="ctr">
+            <a:spAutoFit/>
+          </a:bodyPr>
+          <a:lstStyle/>
+          <a:p>
+            <a:pPr algn="l"/>
+            <a:r>
+              <a:rPr sz="2000" b="0">
+                <a:solidFill>
+                  <a:srgbClr val="FFFFFF"/>
+                </a:solidFill>
+                <a:latin typeface="Calibri"/>
+              </a:rPr>
+              <a:t>🔬</a:t>
+            </a:r>
+          </a:p>
+        </p:txBody>
+      </p:sp>
+      <p:sp>
+        <p:nvSpPr>
+          <p:cNvPr id="88" name="TextBox 87"/>
+          <p:cNvSpPr txBox="1"/>
+          <p:nvPr/>
+        </p:nvSpPr>
+        <p:spPr>
+          <a:xfrm>
+            <a:off x="6554476" y="3859000"/>
+            <a:ext cx="5381596" cy="280000"/>
+          </a:xfrm>
+          <a:prstGeom prst="rect">
+            <a:avLst/>
+          </a:prstGeom>
+          <a:noFill/>
+        </p:spPr>
+        <p:txBody>
+          <a:bodyPr wrap="square" anchor="ctr">
+            <a:spAutoFit/>
+          </a:bodyPr>
+          <a:lstStyle/>
+          <a:p>
+            <a:pPr algn="l"/>
+            <a:r>
+              <a:rPr sz="1400" b="1">
+                <a:solidFill>
+                  <a:srgbClr val="FFFFFF"/>
+                </a:solidFill>
+                <a:latin typeface="Calibri"/>
+              </a:rPr>
+              <a:t>5 Research Experiments</a:t>
+            </a:r>
+          </a:p>
+        </p:txBody>
+      </p:sp>
+      <p:sp>
+        <p:nvSpPr>
+          <p:cNvPr id="89" name="Rectangle 88"/>
+          <p:cNvSpPr/>
+          <p:nvPr/>
+        </p:nvSpPr>
+        <p:spPr>
+          <a:xfrm>
+            <a:off x="6224476" y="4299900"/>
+            <a:ext cx="160000" cy="160000"/>
+          </a:xfrm>
+          <a:prstGeom prst="roundRect">
+            <a:avLst>
+              <a:gd name="adj" fmla="val 50000"/>
+            </a:avLst>
+          </a:prstGeom>
+          <a:solidFill>
+            <a:srgbClr val="F4A261"/>
+          </a:solidFill>
+          <a:ln>
+            <a:noFill/>
+          </a:ln>
+        </p:spPr>
+        <p:style>
+          <a:lnRef idx="1">
+            <a:schemeClr val="accent1"/>
+          </a:lnRef>
+          <a:fillRef idx="3">
+            <a:schemeClr val="accent1"/>
+          </a:fillRef>
+          <a:effectRef idx="2">
+            <a:schemeClr val="accent1"/>
+          </a:effectRef>
+          <a:fontRef idx="minor">
+            <a:schemeClr val="lt1"/>
+          </a:fontRef>
+        </p:style>
+        <p:txBody>
+          <a:bodyPr rtlCol="0" anchor="ctr"/>
+          <a:lstStyle/>
+          <a:p>
+            <a:pPr algn="ctr"/>
+          </a:p>
+        </p:txBody>
+      </p:sp>
+      <p:sp>
+        <p:nvSpPr>
+          <p:cNvPr id="90" name="TextBox 89"/>
+          <p:cNvSpPr txBox="1"/>
+          <p:nvPr/>
+        </p:nvSpPr>
+        <p:spPr>
+          <a:xfrm>
+            <a:off x="6224476" y="4299900"/>
+            <a:ext cx="160000" cy="160000"/>
+          </a:xfrm>
+          <a:prstGeom prst="rect">
+            <a:avLst/>
+          </a:prstGeom>
+          <a:noFill/>
+        </p:spPr>
+        <p:txBody>
+          <a:bodyPr wrap="square" anchor="ctr">
+            <a:spAutoFit/>
+          </a:bodyPr>
+          <a:lstStyle/>
+          <a:p>
+            <a:pPr algn="ctr"/>
+            <a:r>
+              <a:rPr sz="900" b="1">
+                <a:solidFill>
+                  <a:srgbClr val="FFFFFF"/>
+                </a:solidFill>
+                <a:latin typeface="Calibri"/>
+              </a:rPr>
+              <a:t>01</a:t>
+            </a:r>
+          </a:p>
+        </p:txBody>
+      </p:sp>
+      <p:sp>
+        <p:nvSpPr>
+          <p:cNvPr id="91" name="TextBox 90"/>
+          <p:cNvSpPr txBox="1"/>
+          <p:nvPr/>
+        </p:nvSpPr>
+        <p:spPr>
+          <a:xfrm>
+            <a:off x="6424476" y="4139000"/>
+            <a:ext cx="5491596" cy="260900"/>
+          </a:xfrm>
+          <a:prstGeom prst="rect">
+            <a:avLst/>
+          </a:prstGeom>
+          <a:noFill/>
+        </p:spPr>
+        <p:txBody>
+          <a:bodyPr wrap="square" anchor="ctr">
+            <a:spAutoFit/>
+          </a:bodyPr>
+          <a:lstStyle/>
+          <a:p>
+            <a:pPr algn="l"/>
+            <a:r>
+              <a:rPr sz="1100" b="1">
+                <a:solidFill>
+                  <a:srgbClr val="FFFFFF"/>
+                </a:solidFill>
+                <a:latin typeface="Calibri"/>
+              </a:rPr>
+              <a:t>Weather Signal Light</a:t>
+            </a:r>
+          </a:p>
+        </p:txBody>
+      </p:sp>
+      <p:sp>
+        <p:nvSpPr>
+          <p:cNvPr id="92" name="TextBox 91"/>
+          <p:cNvSpPr txBox="1"/>
+          <p:nvPr/>
+        </p:nvSpPr>
+        <p:spPr>
+          <a:xfrm>
+            <a:off x="6424476" y="4379900"/>
+            <a:ext cx="5491596" cy="240900"/>
+          </a:xfrm>
+          <a:prstGeom prst="rect">
+            <a:avLst/>
+          </a:prstGeom>
+          <a:noFill/>
+        </p:spPr>
+        <p:txBody>
+          <a:bodyPr wrap="square" anchor="t">
+            <a:spAutoFit/>
+          </a:bodyPr>
+          <a:lstStyle/>
+          <a:p>
+            <a:pPr algn="l"/>
+            <a:r>
+              <a:rPr sz="850" b="0">
+                <a:solidFill>
+                  <a:srgbClr val="CCEEEE"/>
+                </a:solidFill>
+                <a:latin typeface="Calibri"/>
+              </a:rPr>
+              <a:t>Run 7 days  •  Log forecast vs actual accuracy</a:t>
+            </a:r>
+          </a:p>
+        </p:txBody>
+      </p:sp>
+      <p:sp>
+        <p:nvSpPr>
+          <p:cNvPr id="93" name="Rectangle 92"/>
+          <p:cNvSpPr/>
+          <p:nvPr/>
+        </p:nvSpPr>
+        <p:spPr>
+          <a:xfrm>
+            <a:off x="6224476" y="4615800"/>
+            <a:ext cx="5701596" cy="18000"/>
+          </a:xfrm>
+          <a:prstGeom prst="rect">
+            <a:avLst/>
+          </a:prstGeom>
+          <a:solidFill>
+            <a:srgbClr val="1A6B6B"/>
+          </a:solidFill>
+          <a:ln>
+            <a:noFill/>
+          </a:ln>
+        </p:spPr>
+        <p:style>
+          <a:lnRef idx="1">
+            <a:schemeClr val="accent1"/>
+          </a:lnRef>
+          <a:fillRef idx="3">
+            <a:schemeClr val="accent1"/>
+          </a:fillRef>
+          <a:effectRef idx="2">
+            <a:schemeClr val="accent1"/>
+          </a:effectRef>
+          <a:fontRef idx="minor">
+            <a:schemeClr val="lt1"/>
+          </a:fontRef>
+        </p:style>
+        <p:txBody>
+          <a:bodyPr rtlCol="0" anchor="ctr"/>
+          <a:lstStyle/>
+          <a:p>
+            <a:pPr algn="ctr"/>
+          </a:p>
+        </p:txBody>
+      </p:sp>
+      <p:sp>
+        <p:nvSpPr>
+          <p:cNvPr id="94" name="Rectangle 93"/>
+          <p:cNvSpPr/>
+          <p:nvPr/>
+        </p:nvSpPr>
+        <p:spPr>
+          <a:xfrm>
+            <a:off x="6224476" y="4821700"/>
+            <a:ext cx="160000" cy="160000"/>
+          </a:xfrm>
+          <a:prstGeom prst="roundRect">
+            <a:avLst>
+              <a:gd name="adj" fmla="val 50000"/>
+            </a:avLst>
+          </a:prstGeom>
+          <a:solidFill>
+            <a:srgbClr val="2EC4B6"/>
+          </a:solidFill>
+          <a:ln>
+            <a:noFill/>
+          </a:ln>
+        </p:spPr>
+        <p:style>
+          <a:lnRef idx="1">
+            <a:schemeClr val="accent1"/>
+          </a:lnRef>
+          <a:fillRef idx="3">
+            <a:schemeClr val="accent1"/>
+          </a:fillRef>
+          <a:effectRef idx="2">
+            <a:schemeClr val="accent1"/>
+          </a:effectRef>
+          <a:fontRef idx="minor">
+            <a:schemeClr val="lt1"/>
+          </a:fontRef>
+        </p:style>
+        <p:txBody>
+          <a:bodyPr rtlCol="0" anchor="ctr"/>
+          <a:lstStyle/>
+          <a:p>
+            <a:pPr algn="ctr"/>
+          </a:p>
+        </p:txBody>
+      </p:sp>
+      <p:sp>
+        <p:nvSpPr>
+          <p:cNvPr id="95" name="TextBox 94"/>
+          <p:cNvSpPr txBox="1"/>
+          <p:nvPr/>
+        </p:nvSpPr>
+        <p:spPr>
+          <a:xfrm>
+            <a:off x="6224476" y="4821700"/>
+            <a:ext cx="160000" cy="160000"/>
+          </a:xfrm>
+          <a:prstGeom prst="rect">
+            <a:avLst/>
+          </a:prstGeom>
+          <a:noFill/>
+        </p:spPr>
+        <p:txBody>
+          <a:bodyPr wrap="square" anchor="ctr">
+            <a:spAutoFit/>
+          </a:bodyPr>
+          <a:lstStyle/>
+          <a:p>
+            <a:pPr algn="ctr"/>
+            <a:r>
+              <a:rPr sz="900" b="1">
+                <a:solidFill>
+                  <a:srgbClr val="FFFFFF"/>
+                </a:solidFill>
+                <a:latin typeface="Calibri"/>
+              </a:rPr>
+              <a:t>02</a:t>
+            </a:r>
+          </a:p>
+        </p:txBody>
+      </p:sp>
+      <p:sp>
+        <p:nvSpPr>
+          <p:cNvPr id="96" name="TextBox 95"/>
+          <p:cNvSpPr txBox="1"/>
+          <p:nvPr/>
+        </p:nvSpPr>
+        <p:spPr>
+          <a:xfrm>
+            <a:off x="6424476" y="4660800"/>
+            <a:ext cx="5491596" cy="260900"/>
+          </a:xfrm>
+          <a:prstGeom prst="rect">
+            <a:avLst/>
+          </a:prstGeom>
+          <a:noFill/>
+        </p:spPr>
+        <p:txBody>
+          <a:bodyPr wrap="square" anchor="ctr">
+            <a:spAutoFit/>
+          </a:bodyPr>
+          <a:lstStyle/>
+          <a:p>
+            <a:pPr algn="l"/>
+            <a:r>
+              <a:rPr sz="1100" b="1">
+                <a:solidFill>
+                  <a:srgbClr val="FFFFFF"/>
+                </a:solidFill>
+                <a:latin typeface="Calibri"/>
+              </a:rPr>
+              <a:t>Simultaneous Load Logger</a:t>
+            </a:r>
+          </a:p>
+        </p:txBody>
+      </p:sp>
+      <p:sp>
+        <p:nvSpPr>
+          <p:cNvPr id="97" name="TextBox 96"/>
+          <p:cNvSpPr txBox="1"/>
+          <p:nvPr/>
+        </p:nvSpPr>
+        <p:spPr>
+          <a:xfrm>
+            <a:off x="6424476" y="4901700"/>
+            <a:ext cx="5491596" cy="240900"/>
+          </a:xfrm>
+          <a:prstGeom prst="rect">
+            <a:avLst/>
+          </a:prstGeom>
+          <a:noFill/>
+        </p:spPr>
+        <p:txBody>
+          <a:bodyPr wrap="square" anchor="t">
+            <a:spAutoFit/>
+          </a:bodyPr>
+          <a:lstStyle/>
+          <a:p>
+            <a:pPr algn="l"/>
+            <a:r>
+              <a:rPr sz="850" b="0">
+                <a:solidFill>
+                  <a:srgbClr val="CCEEEE"/>
+                </a:solidFill>
+                <a:latin typeface="Calibri"/>
+              </a:rPr>
+              <a:t>Measure peak demand: simultaneous vs staggered</a:t>
+            </a:r>
+          </a:p>
+        </p:txBody>
+      </p:sp>
+      <p:sp>
+        <p:nvSpPr>
+          <p:cNvPr id="98" name="Rectangle 97"/>
+          <p:cNvSpPr/>
+          <p:nvPr/>
+        </p:nvSpPr>
+        <p:spPr>
+          <a:xfrm>
+            <a:off x="6224476" y="5137600"/>
+            <a:ext cx="5701596" cy="18000"/>
+          </a:xfrm>
+          <a:prstGeom prst="rect">
+            <a:avLst/>
+          </a:prstGeom>
+          <a:solidFill>
+            <a:srgbClr val="1A6B6B"/>
+          </a:solidFill>
+          <a:ln>
+            <a:noFill/>
+          </a:ln>
+        </p:spPr>
+        <p:style>
+          <a:lnRef idx="1">
+            <a:schemeClr val="accent1"/>
+          </a:lnRef>
+          <a:fillRef idx="3">
+            <a:schemeClr val="accent1"/>
+          </a:fillRef>
+          <a:effectRef idx="2">
+            <a:schemeClr val="accent1"/>
+          </a:effectRef>
+          <a:fontRef idx="minor">
+            <a:schemeClr val="lt1"/>
+          </a:fontRef>
+        </p:style>
+        <p:txBody>
+          <a:bodyPr rtlCol="0" anchor="ctr"/>
+          <a:lstStyle/>
+          <a:p>
+            <a:pPr algn="ctr"/>
+          </a:p>
+        </p:txBody>
+      </p:sp>
+      <p:sp>
+        <p:nvSpPr>
+          <p:cNvPr id="99" name="Rectangle 98"/>
+          <p:cNvSpPr/>
+          <p:nvPr/>
+        </p:nvSpPr>
+        <p:spPr>
+          <a:xfrm>
+            <a:off x="6224476" y="5343500"/>
+            <a:ext cx="160000" cy="160000"/>
+          </a:xfrm>
+          <a:prstGeom prst="roundRect">
+            <a:avLst>
+              <a:gd name="adj" fmla="val 50000"/>
+            </a:avLst>
+          </a:prstGeom>
+          <a:solidFill>
+            <a:srgbClr val="48CAE4"/>
+          </a:solidFill>
+          <a:ln>
+            <a:noFill/>
+          </a:ln>
+        </p:spPr>
+        <p:style>
+          <a:lnRef idx="1">
+            <a:schemeClr val="accent1"/>
+          </a:lnRef>
+          <a:fillRef idx="3">
+            <a:schemeClr val="accent1"/>
+          </a:fillRef>
+          <a:effectRef idx="2">
+            <a:schemeClr val="accent1"/>
+          </a:effectRef>
+          <a:fontRef idx="minor">
+            <a:schemeClr val="lt1"/>
+          </a:fontRef>
+        </p:style>
+        <p:txBody>
+          <a:bodyPr rtlCol="0" anchor="ctr"/>
+          <a:lstStyle/>
+          <a:p>
+            <a:pPr algn="ctr"/>
+          </a:p>
+        </p:txBody>
+      </p:sp>
+      <p:sp>
+        <p:nvSpPr>
+          <p:cNvPr id="100" name="TextBox 99"/>
+          <p:cNvSpPr txBox="1"/>
+          <p:nvPr/>
+        </p:nvSpPr>
+        <p:spPr>
+          <a:xfrm>
+            <a:off x="6224476" y="5343500"/>
+            <a:ext cx="160000" cy="160000"/>
+          </a:xfrm>
+          <a:prstGeom prst="rect">
+            <a:avLst/>
+          </a:prstGeom>
+          <a:noFill/>
+        </p:spPr>
+        <p:txBody>
+          <a:bodyPr wrap="square" anchor="ctr">
+            <a:spAutoFit/>
+          </a:bodyPr>
+          <a:lstStyle/>
+          <a:p>
+            <a:pPr algn="ctr"/>
+            <a:r>
+              <a:rPr sz="900" b="1">
+                <a:solidFill>
+                  <a:srgbClr val="FFFFFF"/>
+                </a:solidFill>
+                <a:latin typeface="Calibri"/>
+              </a:rPr>
+              <a:t>03</a:t>
+            </a:r>
+          </a:p>
+        </p:txBody>
+      </p:sp>
+      <p:sp>
+        <p:nvSpPr>
+          <p:cNvPr id="101" name="TextBox 100"/>
+          <p:cNvSpPr txBox="1"/>
+          <p:nvPr/>
+        </p:nvSpPr>
+        <p:spPr>
+          <a:xfrm>
+            <a:off x="6424476" y="5182600"/>
+            <a:ext cx="5491596" cy="260900"/>
+          </a:xfrm>
+          <a:prstGeom prst="rect">
+            <a:avLst/>
+          </a:prstGeom>
+          <a:noFill/>
+        </p:spPr>
+        <p:txBody>
+          <a:bodyPr wrap="square" anchor="ctr">
+            <a:spAutoFit/>
+          </a:bodyPr>
+          <a:lstStyle/>
+          <a:p>
+            <a:pPr algn="l"/>
+            <a:r>
+              <a:rPr sz="1100" b="1">
+                <a:solidFill>
+                  <a:srgbClr val="FFFFFF"/>
+                </a:solidFill>
+                <a:latin typeface="Calibri"/>
+              </a:rPr>
+              <a:t>Multi-Sensor MQTT Network</a:t>
+            </a:r>
+          </a:p>
+        </p:txBody>
+      </p:sp>
+      <p:sp>
+        <p:nvSpPr>
+          <p:cNvPr id="102" name="TextBox 101"/>
+          <p:cNvSpPr txBox="1"/>
+          <p:nvPr/>
+        </p:nvSpPr>
+        <p:spPr>
+          <a:xfrm>
+            <a:off x="6424476" y="5423500"/>
+            <a:ext cx="5491596" cy="240900"/>
+          </a:xfrm>
+          <a:prstGeom prst="rect">
+            <a:avLst/>
+          </a:prstGeom>
+          <a:noFill/>
+        </p:spPr>
+        <p:txBody>
+          <a:bodyPr wrap="square" anchor="t">
+            <a:spAutoFit/>
+          </a:bodyPr>
+          <a:lstStyle/>
+          <a:p>
+            <a:pPr algn="l"/>
+            <a:r>
+              <a:rPr sz="850" b="0">
+                <a:solidFill>
+                  <a:srgbClr val="CCEEEE"/>
+                </a:solidFill>
+                <a:latin typeface="Calibri"/>
+              </a:rPr>
+              <a:t>2-node network  •  Latency under 500 ms target</a:t>
+            </a:r>
+          </a:p>
+        </p:txBody>
+      </p:sp>
+      <p:sp>
+        <p:nvSpPr>
+          <p:cNvPr id="103" name="Rectangle 102"/>
+          <p:cNvSpPr/>
+          <p:nvPr/>
+        </p:nvSpPr>
+        <p:spPr>
+          <a:xfrm>
+            <a:off x="6224476" y="5659400"/>
+            <a:ext cx="5701596" cy="18000"/>
+          </a:xfrm>
+          <a:prstGeom prst="rect">
+            <a:avLst/>
+          </a:prstGeom>
+          <a:solidFill>
+            <a:srgbClr val="1A6B6B"/>
+          </a:solidFill>
+          <a:ln>
+            <a:noFill/>
+          </a:ln>
+        </p:spPr>
+        <p:style>
+          <a:lnRef idx="1">
+            <a:schemeClr val="accent1"/>
+          </a:lnRef>
+          <a:fillRef idx="3">
+            <a:schemeClr val="accent1"/>
+          </a:fillRef>
+          <a:effectRef idx="2">
+            <a:schemeClr val="accent1"/>
+          </a:effectRef>
+          <a:fontRef idx="minor">
+            <a:schemeClr val="lt1"/>
+          </a:fontRef>
+        </p:style>
+        <p:txBody>
+          <a:bodyPr rtlCol="0" anchor="ctr"/>
+          <a:lstStyle/>
+          <a:p>
+            <a:pPr algn="ctr"/>
+          </a:p>
+        </p:txBody>
+      </p:sp>
+      <p:sp>
+        <p:nvSpPr>
+          <p:cNvPr id="104" name="Rectangle 103"/>
+          <p:cNvSpPr/>
+          <p:nvPr/>
+        </p:nvSpPr>
+        <p:spPr>
+          <a:xfrm>
+            <a:off x="6224476" y="5865300"/>
+            <a:ext cx="160000" cy="160000"/>
+          </a:xfrm>
+          <a:prstGeom prst="roundRect">
+            <a:avLst>
+              <a:gd name="adj" fmla="val 50000"/>
+            </a:avLst>
+          </a:prstGeom>
+          <a:solidFill>
+            <a:srgbClr val="84B59F"/>
+          </a:solidFill>
+          <a:ln>
+            <a:noFill/>
+          </a:ln>
+        </p:spPr>
+        <p:style>
+          <a:lnRef idx="1">
+            <a:schemeClr val="accent1"/>
+          </a:lnRef>
+          <a:fillRef idx="3">
+            <a:schemeClr val="accent1"/>
+          </a:fillRef>
+          <a:effectRef idx="2">
+            <a:schemeClr val="accent1"/>
+          </a:effectRef>
+          <a:fontRef idx="minor">
+            <a:schemeClr val="lt1"/>
+          </a:fontRef>
+        </p:style>
+        <p:txBody>
+          <a:bodyPr rtlCol="0" anchor="ctr"/>
+          <a:lstStyle/>
+          <a:p>
+            <a:pPr algn="ctr"/>
+          </a:p>
+        </p:txBody>
+      </p:sp>
+      <p:sp>
+        <p:nvSpPr>
+          <p:cNvPr id="105" name="TextBox 104"/>
+          <p:cNvSpPr txBox="1"/>
+          <p:nvPr/>
+        </p:nvSpPr>
+        <p:spPr>
+          <a:xfrm>
+            <a:off x="6224476" y="5865300"/>
+            <a:ext cx="160000" cy="160000"/>
+          </a:xfrm>
+          <a:prstGeom prst="rect">
+            <a:avLst/>
+          </a:prstGeom>
+          <a:noFill/>
+        </p:spPr>
+        <p:txBody>
+          <a:bodyPr wrap="square" anchor="ctr">
+            <a:spAutoFit/>
+          </a:bodyPr>
+          <a:lstStyle/>
+          <a:p>
+            <a:pPr algn="ctr"/>
+            <a:r>
+              <a:rPr sz="900" b="1">
+                <a:solidFill>
+                  <a:srgbClr val="FFFFFF"/>
+                </a:solidFill>
+                <a:latin typeface="Calibri"/>
+              </a:rPr>
+              <a:t>04</a:t>
+            </a:r>
+          </a:p>
+        </p:txBody>
+      </p:sp>
+      <p:sp>
+        <p:nvSpPr>
+          <p:cNvPr id="106" name="TextBox 105"/>
+          <p:cNvSpPr txBox="1"/>
+          <p:nvPr/>
+        </p:nvSpPr>
+        <p:spPr>
+          <a:xfrm>
+            <a:off x="6424476" y="5704400"/>
+            <a:ext cx="5491596" cy="260900"/>
+          </a:xfrm>
+          <a:prstGeom prst="rect">
+            <a:avLst/>
+          </a:prstGeom>
+          <a:noFill/>
+        </p:spPr>
+        <p:txBody>
+          <a:bodyPr wrap="square" anchor="ctr">
+            <a:spAutoFit/>
+          </a:bodyPr>
+          <a:lstStyle/>
+          <a:p>
+            <a:pPr algn="l"/>
+            <a:r>
+              <a:rPr sz="1100" b="1">
+                <a:solidFill>
+                  <a:srgbClr val="FFFFFF"/>
+                </a:solidFill>
+                <a:latin typeface="Calibri"/>
+              </a:rPr>
+              <a:t>Off-Peak Scheduler Validation</a:t>
+            </a:r>
+          </a:p>
+        </p:txBody>
+      </p:sp>
+      <p:sp>
+        <p:nvSpPr>
+          <p:cNvPr id="107" name="TextBox 106"/>
+          <p:cNvSpPr txBox="1"/>
+          <p:nvPr/>
+        </p:nvSpPr>
+        <p:spPr>
+          <a:xfrm>
+            <a:off x="6424476" y="5945300"/>
+            <a:ext cx="5491596" cy="240900"/>
+          </a:xfrm>
+          <a:prstGeom prst="rect">
+            <a:avLst/>
+          </a:prstGeom>
+          <a:noFill/>
+        </p:spPr>
+        <p:txBody>
+          <a:bodyPr wrap="square" anchor="t">
+            <a:spAutoFit/>
+          </a:bodyPr>
+          <a:lstStyle/>
+          <a:p>
+            <a:pPr algn="l"/>
+            <a:r>
+              <a:rPr sz="850" b="0">
+                <a:solidFill>
+                  <a:srgbClr val="CCEEEE"/>
+                </a:solidFill>
+                <a:latin typeface="Calibri"/>
+              </a:rPr>
+              <a:t>Calculate real £ savings vs naive scheduling</a:t>
+            </a:r>
+          </a:p>
+        </p:txBody>
+      </p:sp>
+      <p:sp>
+        <p:nvSpPr>
+          <p:cNvPr id="108" name="Rectangle 107"/>
+          <p:cNvSpPr/>
+          <p:nvPr/>
+        </p:nvSpPr>
+        <p:spPr>
+          <a:xfrm>
+            <a:off x="6224476" y="6181200"/>
+            <a:ext cx="5701596" cy="18000"/>
+          </a:xfrm>
+          <a:prstGeom prst="rect">
+            <a:avLst/>
+          </a:prstGeom>
+          <a:solidFill>
+            <a:srgbClr val="1A6B6B"/>
+          </a:solidFill>
+          <a:ln>
+            <a:noFill/>
+          </a:ln>
+        </p:spPr>
+        <p:style>
+          <a:lnRef idx="1">
+            <a:schemeClr val="accent1"/>
+          </a:lnRef>
+          <a:fillRef idx="3">
+            <a:schemeClr val="accent1"/>
+          </a:fillRef>
+          <a:effectRef idx="2">
+            <a:schemeClr val="accent1"/>
+          </a:effectRef>
+          <a:fontRef idx="minor">
+            <a:schemeClr val="lt1"/>
+          </a:fontRef>
+        </p:style>
+        <p:txBody>
+          <a:bodyPr rtlCol="0" anchor="ctr"/>
+          <a:lstStyle/>
+          <a:p>
+            <a:pPr algn="ctr"/>
+          </a:p>
+        </p:txBody>
+      </p:sp>
+      <p:sp>
+        <p:nvSpPr>
+          <p:cNvPr id="109" name="Rectangle 108"/>
+          <p:cNvSpPr/>
+          <p:nvPr/>
+        </p:nvSpPr>
+        <p:spPr>
+          <a:xfrm>
+            <a:off x="6224476" y="6387100"/>
+            <a:ext cx="160000" cy="160000"/>
+          </a:xfrm>
+          <a:prstGeom prst="roundRect">
+            <a:avLst>
+              <a:gd name="adj" fmla="val 50000"/>
+            </a:avLst>
+          </a:prstGeom>
+          <a:solidFill>
+            <a:srgbClr val="84B59F"/>
+          </a:solidFill>
+          <a:ln>
+            <a:noFill/>
+          </a:ln>
+        </p:spPr>
+        <p:style>
+          <a:lnRef idx="1">
+            <a:schemeClr val="accent1"/>
+          </a:lnRef>
+          <a:fillRef idx="3">
+            <a:schemeClr val="accent1"/>
+          </a:fillRef>
+          <a:effectRef idx="2">
+            <a:schemeClr val="accent1"/>
+          </a:effectRef>
+          <a:fontRef idx="minor">
+            <a:schemeClr val="lt1"/>
+          </a:fontRef>
+        </p:style>
+        <p:txBody>
+          <a:bodyPr rtlCol="0" anchor="ctr"/>
+          <a:lstStyle/>
+          <a:p>
+            <a:pPr algn="ctr"/>
+          </a:p>
+        </p:txBody>
+      </p:sp>
+      <p:sp>
+        <p:nvSpPr>
+          <p:cNvPr id="110" name="TextBox 109"/>
+          <p:cNvSpPr txBox="1"/>
+          <p:nvPr/>
+        </p:nvSpPr>
+        <p:spPr>
+          <a:xfrm>
+            <a:off x="6224476" y="6387100"/>
+            <a:ext cx="160000" cy="160000"/>
+          </a:xfrm>
+          <a:prstGeom prst="rect">
+            <a:avLst/>
+          </a:prstGeom>
+          <a:noFill/>
+        </p:spPr>
+        <p:txBody>
+          <a:bodyPr wrap="square" anchor="ctr">
+            <a:spAutoFit/>
+          </a:bodyPr>
+          <a:lstStyle/>
+          <a:p>
+            <a:pPr algn="ctr"/>
+            <a:r>
+              <a:rPr sz="900" b="1">
+                <a:solidFill>
+                  <a:srgbClr val="FFFFFF"/>
+                </a:solidFill>
+                <a:latin typeface="Calibri"/>
+              </a:rPr>
+              <a:t>05</a:t>
+            </a:r>
+          </a:p>
+        </p:txBody>
+      </p:sp>
+      <p:sp>
+        <p:nvSpPr>
+          <p:cNvPr id="111" name="TextBox 110"/>
+          <p:cNvSpPr txBox="1"/>
+          <p:nvPr/>
+        </p:nvSpPr>
+        <p:spPr>
+          <a:xfrm>
+            <a:off x="6424476" y="6226200"/>
+            <a:ext cx="5491596" cy="260900"/>
+          </a:xfrm>
+          <a:prstGeom prst="rect">
+            <a:avLst/>
+          </a:prstGeom>
+          <a:noFill/>
+        </p:spPr>
+        <p:txBody>
+          <a:bodyPr wrap="square" anchor="ctr">
+            <a:spAutoFit/>
+          </a:bodyPr>
+          <a:lstStyle/>
+          <a:p>
+            <a:pPr algn="l"/>
+            <a:r>
+              <a:rPr sz="1100" b="1">
+                <a:solidFill>
+                  <a:srgbClr val="FFFFFF"/>
+                </a:solidFill>
+                <a:latin typeface="Calibri"/>
+              </a:rPr>
+              <a:t>Full IoT-GPT Mini Demo</a:t>
+            </a:r>
+          </a:p>
+        </p:txBody>
+      </p:sp>
+      <p:sp>
+        <p:nvSpPr>
+          <p:cNvPr id="112" name="TextBox 111"/>
+          <p:cNvSpPr txBox="1"/>
+          <p:nvPr/>
+        </p:nvSpPr>
+        <p:spPr>
+          <a:xfrm>
+            <a:off x="6424476" y="6467100"/>
+            <a:ext cx="5491596" cy="240900"/>
+          </a:xfrm>
+          <a:prstGeom prst="rect">
+            <a:avLst/>
+          </a:prstGeom>
+          <a:noFill/>
+        </p:spPr>
+        <p:txBody>
+          <a:bodyPr wrap="square" anchor="t">
+            <a:spAutoFit/>
+          </a:bodyPr>
+          <a:lstStyle/>
+          <a:p>
+            <a:pPr algn="l"/>
+            <a:r>
+              <a:rPr sz="850" b="0">
+                <a:solidFill>
+                  <a:srgbClr val="CCEEEE"/>
+                </a:solidFill>
+                <a:latin typeface="Calibri"/>
+              </a:rPr>
+              <a:t>24 h autonomous operation  •  Decision log review</a:t>
             </a:r>
           </a:p>
         </p:txBody>

</xml_diff>